<commit_message>
FIM V6-FINAL — Charte SHY-Performance · Téléphonique · UNICEF France/Monde
Corrections appliquées :
- Prospection 100% téléphonique (suppression contact visuel/rue/badge/passant)
- Logo SHY-Performance intégré sur chaque slide
- Nom corrigé : SHY-Performance (pas SHY)
- Couleurs charte originale : teal #008080 uniquement, sans rouge
- Données exactes semaine 19-23/05/2026 :
  * Script officiel UNICEF 7 étapes (Accroche/Malnutrition/RUTF/Appel/Ponctuel/Indécis/Validation)
  * 5 règles officielles de l'accroche téléphonique
  * 4 modes de validation du don (IBAN chaud/PA en ligne/PEL/PA courrier)
  * 15 objections en 5 catégories + méthode AAR
  * KPI FIDELIS : CU/H ≥9, TX Transfo, PDC, PEL, PA
  * Nomenclature DON/INDÉCIS/REFUS
  * Grille certification 24 critères + Quiz 40 questions
  * Loi 1901, Comité de la Charte, Bloctel, RGPD
  * Sachets RUTF 92g, malnutrition aigüe sévère

https://claude.ai/code/session_01KeQ88BfXySEzARHjHzWvmX
</commit_message>
<xml_diff>
--- a/FIM_Book0_FilConducteur_V6-01062026SHY-TE.pptx
+++ b/FIM_Book0_FilConducteur_V6-01062026SHY-TE.pptx
@@ -3143,7 +3143,7 @@
         <p:spPr>
           <a:xfrm>
             <a:off x="0" y="0"/>
-            <a:ext cx="12188952" cy="2286000"/>
+            <a:ext cx="12188952" cy="2331720"/>
           </a:xfrm>
           <a:prstGeom prst="rect">
             <a:avLst/>
@@ -3185,14 +3185,14 @@
         </p:nvSpPr>
         <p:spPr>
           <a:xfrm>
-            <a:off x="0" y="2267712"/>
-            <a:ext cx="12188952" cy="73152"/>
+            <a:off x="0" y="2313432"/>
+            <a:ext cx="12188952" cy="54864"/>
           </a:xfrm>
           <a:prstGeom prst="rect">
             <a:avLst/>
           </a:prstGeom>
           <a:solidFill>
-            <a:srgbClr val="FF0000"/>
+            <a:srgbClr val="00AAAA"/>
           </a:solidFill>
           <a:ln>
             <a:noFill/>
@@ -3222,57 +3222,14 @@
       </p:sp>
       <p:sp>
         <p:nvSpPr>
-          <p:cNvPr id="5" name="Rectangle 4"/>
-          <p:cNvSpPr/>
-          <p:nvPr/>
-        </p:nvSpPr>
-        <p:spPr>
-          <a:xfrm>
-            <a:off x="274320" y="109728"/>
-            <a:ext cx="2926080" cy="822960"/>
-          </a:xfrm>
-          <a:prstGeom prst="rect">
-            <a:avLst/>
-          </a:prstGeom>
-          <a:solidFill>
-            <a:srgbClr val="008080"/>
-          </a:solidFill>
-          <a:ln>
-            <a:noFill/>
-          </a:ln>
-        </p:spPr>
-        <p:style>
-          <a:lnRef idx="1">
-            <a:schemeClr val="accent1"/>
-          </a:lnRef>
-          <a:fillRef idx="3">
-            <a:schemeClr val="accent1"/>
-          </a:fillRef>
-          <a:effectRef idx="2">
-            <a:schemeClr val="accent1"/>
-          </a:effectRef>
-          <a:fontRef idx="minor">
-            <a:schemeClr val="lt1"/>
-          </a:fontRef>
-        </p:style>
-        <p:txBody>
-          <a:bodyPr rtlCol="0" anchor="ctr"/>
-          <a:lstStyle/>
-          <a:p>
-            <a:pPr algn="ctr"/>
-          </a:p>
-        </p:txBody>
-      </p:sp>
-      <p:sp>
-        <p:nvSpPr>
-          <p:cNvPr id="6" name="TextBox 5"/>
+          <p:cNvPr id="5" name="TextBox 4"/>
           <p:cNvSpPr txBox="1"/>
           <p:nvPr/>
         </p:nvSpPr>
         <p:spPr>
           <a:xfrm>
-            <a:off x="320040" y="118872"/>
-            <a:ext cx="1097280" cy="804672"/>
+            <a:off x="347472" y="91440"/>
+            <a:ext cx="3200400" cy="438912"/>
           </a:xfrm>
           <a:prstGeom prst="rect">
             <a:avLst/>
@@ -3287,26 +3244,26 @@
           <a:p>
             <a:pPr algn="l"/>
             <a:r>
-              <a:rPr sz="3600" b="1" i="0">
+              <a:rPr sz="2200" b="1" i="0">
                 <a:solidFill>
                   <a:srgbClr val="FFFFFF"/>
                 </a:solidFill>
               </a:rPr>
-              <a:t>SHY</a:t>
-            </a:r>
-          </a:p>
-        </p:txBody>
-      </p:sp>
-      <p:sp>
-        <p:nvSpPr>
-          <p:cNvPr id="7" name="TextBox 6"/>
+              <a:t>SHY-Performance</a:t>
+            </a:r>
+          </a:p>
+        </p:txBody>
+      </p:sp>
+      <p:sp>
+        <p:nvSpPr>
+          <p:cNvPr id="6" name="TextBox 5"/>
           <p:cNvSpPr txBox="1"/>
           <p:nvPr/>
         </p:nvSpPr>
         <p:spPr>
           <a:xfrm>
-            <a:off x="1371600" y="347472"/>
-            <a:ext cx="1828800" cy="411480"/>
+            <a:off x="347472" y="530352"/>
+            <a:ext cx="7772400" cy="347472"/>
           </a:xfrm>
           <a:prstGeom prst="rect">
             <a:avLst/>
@@ -3321,88 +3278,45 @@
           <a:p>
             <a:pPr algn="l"/>
             <a:r>
-              <a:rPr sz="1400" b="1" i="0">
-                <a:solidFill>
-                  <a:srgbClr val="FFFFFF"/>
-                </a:solidFill>
-              </a:rPr>
-              <a:t>Performance</a:t>
-            </a:r>
-          </a:p>
-        </p:txBody>
-      </p:sp>
-      <p:sp>
-        <p:nvSpPr>
-          <p:cNvPr id="8" name="Rectangle 7"/>
-          <p:cNvSpPr/>
-          <p:nvPr/>
-        </p:nvSpPr>
-        <p:spPr>
-          <a:xfrm>
-            <a:off x="3337560" y="164592"/>
-            <a:ext cx="36576" cy="658368"/>
-          </a:xfrm>
-          <a:prstGeom prst="rect">
-            <a:avLst/>
-          </a:prstGeom>
-          <a:solidFill>
-            <a:srgbClr val="FF0000"/>
-          </a:solidFill>
-          <a:ln>
-            <a:noFill/>
-          </a:ln>
-        </p:spPr>
-        <p:style>
-          <a:lnRef idx="1">
-            <a:schemeClr val="accent1"/>
-          </a:lnRef>
-          <a:fillRef idx="3">
-            <a:schemeClr val="accent1"/>
-          </a:fillRef>
-          <a:effectRef idx="2">
-            <a:schemeClr val="accent1"/>
-          </a:effectRef>
-          <a:fontRef idx="minor">
-            <a:schemeClr val="lt1"/>
-          </a:fontRef>
-        </p:style>
-        <p:txBody>
-          <a:bodyPr rtlCol="0" anchor="ctr"/>
-          <a:lstStyle/>
-          <a:p>
-            <a:pPr algn="ctr"/>
-          </a:p>
-        </p:txBody>
-      </p:sp>
-      <p:sp>
-        <p:nvSpPr>
-          <p:cNvPr id="9" name="TextBox 8"/>
-          <p:cNvSpPr txBox="1"/>
-          <p:nvPr/>
-        </p:nvSpPr>
-        <p:spPr>
-          <a:xfrm>
-            <a:off x="3474720" y="164592"/>
-            <a:ext cx="8503920" cy="347472"/>
-          </a:xfrm>
-          <a:prstGeom prst="rect">
-            <a:avLst/>
-          </a:prstGeom>
-          <a:noFill/>
-        </p:spPr>
-        <p:txBody>
-          <a:bodyPr wrap="square">
-            <a:spAutoFit/>
-          </a:bodyPr>
-          <a:lstStyle/>
-          <a:p>
-            <a:pPr algn="l"/>
-            <a:r>
-              <a:rPr sz="900" b="1" i="0">
+              <a:rPr sz="1000" b="0" i="1">
                 <a:solidFill>
                   <a:srgbClr val="BBEEEE"/>
                 </a:solidFill>
               </a:rPr>
+              <a:t>Formation Initiale Module — Fundraising Téléphonique UNICEF</a:t>
+            </a:r>
+          </a:p>
+        </p:txBody>
+      </p:sp>
+      <p:sp>
+        <p:nvSpPr>
+          <p:cNvPr id="7" name="TextBox 6"/>
+          <p:cNvSpPr txBox="1"/>
+          <p:nvPr/>
+        </p:nvSpPr>
+        <p:spPr>
+          <a:xfrm>
+            <a:off x="347472" y="932688"/>
+            <a:ext cx="7772400" cy="292608"/>
+          </a:xfrm>
+          <a:prstGeom prst="rect">
+            <a:avLst/>
+          </a:prstGeom>
+          <a:noFill/>
+        </p:spPr>
+        <p:txBody>
+          <a:bodyPr wrap="square">
+            <a:spAutoFit/>
+          </a:bodyPr>
+          <a:lstStyle/>
+          <a:p>
+            <a:pPr algn="l"/>
+            <a:r>
+              <a:rPr sz="900" b="1" i="0">
+                <a:solidFill>
+                  <a:srgbClr val="88DDDD"/>
+                </a:solidFill>
+              </a:rPr>
               <a:t>BOOK 0  ·  Fil Conducteur  ·  Document de parcours</a:t>
             </a:r>
           </a:p>
@@ -3410,14 +3324,14 @@
       </p:sp>
       <p:sp>
         <p:nvSpPr>
-          <p:cNvPr id="10" name="TextBox 9"/>
+          <p:cNvPr id="8" name="TextBox 7"/>
           <p:cNvSpPr txBox="1"/>
           <p:nvPr/>
         </p:nvSpPr>
         <p:spPr>
           <a:xfrm>
-            <a:off x="320040" y="960120"/>
-            <a:ext cx="11521440" cy="1143000"/>
+            <a:off x="347472" y="1207008"/>
+            <a:ext cx="10515600" cy="914400"/>
           </a:xfrm>
           <a:prstGeom prst="rect">
             <a:avLst/>
@@ -3444,14 +3358,14 @@
       </p:sp>
       <p:sp>
         <p:nvSpPr>
-          <p:cNvPr id="11" name="TextBox 10"/>
+          <p:cNvPr id="9" name="TextBox 8"/>
           <p:cNvSpPr txBox="1"/>
           <p:nvPr/>
         </p:nvSpPr>
         <p:spPr>
           <a:xfrm>
-            <a:off x="320040" y="1920240"/>
-            <a:ext cx="11521440" cy="347472"/>
+            <a:off x="347472" y="1901952"/>
+            <a:ext cx="10515600" cy="402336"/>
           </a:xfrm>
           <a:prstGeom prst="rect">
             <a:avLst/>
@@ -3471,14 +3385,38 @@
                   <a:srgbClr val="CCEEEE"/>
                 </a:solidFill>
               </a:rPr>
-              <a:t>Fundraiser Impact Mission — Votre parcours de 5 jours</a:t>
-            </a:r>
-          </a:p>
-        </p:txBody>
-      </p:sp>
-      <p:sp>
-        <p:nvSpPr>
-          <p:cNvPr id="12" name="Rectangle 11"/>
+              <a:t>Fundraiser Impact Mission — UNICEF France × SHY-Performance × FIDELIS</a:t>
+            </a:r>
+          </a:p>
+        </p:txBody>
+      </p:sp>
+      <p:pic>
+        <p:nvPicPr>
+          <p:cNvPr id="10" name="Picture 9" descr="shy_logo_v2.png"/>
+          <p:cNvPicPr>
+            <a:picLocks noChangeAspect="1"/>
+          </p:cNvPicPr>
+          <p:nvPr/>
+        </p:nvPicPr>
+        <p:blipFill>
+          <a:blip r:embed="rId2"/>
+          <a:stretch>
+            <a:fillRect/>
+          </a:stretch>
+        </p:blipFill>
+        <p:spPr>
+          <a:xfrm>
+            <a:off x="11247120" y="45720"/>
+            <a:ext cx="822960" cy="804672"/>
+          </a:xfrm>
+          <a:prstGeom prst="rect">
+            <a:avLst/>
+          </a:prstGeom>
+        </p:spPr>
+      </p:pic>
+      <p:sp>
+        <p:nvSpPr>
+          <p:cNvPr id="11" name="Rectangle 10"/>
           <p:cNvSpPr/>
           <p:nvPr/>
         </p:nvSpPr>
@@ -3521,7 +3459,7 @@
       </p:sp>
       <p:sp>
         <p:nvSpPr>
-          <p:cNvPr id="13" name="TextBox 12"/>
+          <p:cNvPr id="12" name="TextBox 11"/>
           <p:cNvSpPr txBox="1"/>
           <p:nvPr/>
         </p:nvSpPr>
@@ -3543,26 +3481,26 @@
           <a:p>
             <a:pPr algn="ctr"/>
             <a:r>
-              <a:rPr sz="900" b="0" i="0">
+              <a:rPr sz="800" b="0" i="0">
                 <a:solidFill>
                   <a:srgbClr val="FFFFFF"/>
                 </a:solidFill>
               </a:rPr>
-              <a:t>SHY-Performance  ·  Formation FIM  ·  V6-01062026SHY-TE</a:t>
-            </a:r>
-          </a:p>
-        </p:txBody>
-      </p:sp>
-      <p:sp>
-        <p:nvSpPr>
-          <p:cNvPr id="14" name="TextBox 13"/>
+              <a:t>SHY-Performance  ·  Formation FIM  ·  UNICEF France  ·  V6-01062026SHY-TE</a:t>
+            </a:r>
+          </a:p>
+        </p:txBody>
+      </p:sp>
+      <p:sp>
+        <p:nvSpPr>
+          <p:cNvPr id="13" name="TextBox 12"/>
           <p:cNvSpPr txBox="1"/>
           <p:nvPr/>
         </p:nvSpPr>
         <p:spPr>
           <a:xfrm>
             <a:off x="457200" y="2514600"/>
-            <a:ext cx="11247120" cy="914400"/>
+            <a:ext cx="10789920" cy="822960"/>
           </a:xfrm>
           <a:prstGeom prst="rect">
             <a:avLst/>
@@ -3590,57 +3528,14 @@
       </p:sp>
       <p:sp>
         <p:nvSpPr>
-          <p:cNvPr id="15" name="Rectangle 14"/>
-          <p:cNvSpPr/>
-          <p:nvPr/>
-        </p:nvSpPr>
-        <p:spPr>
-          <a:xfrm>
-            <a:off x="457200" y="3520440"/>
-            <a:ext cx="11247120" cy="54864"/>
-          </a:xfrm>
-          <a:prstGeom prst="rect">
-            <a:avLst/>
-          </a:prstGeom>
-          <a:solidFill>
-            <a:srgbClr val="FF0000"/>
-          </a:solidFill>
-          <a:ln>
-            <a:noFill/>
-          </a:ln>
-        </p:spPr>
-        <p:style>
-          <a:lnRef idx="1">
-            <a:schemeClr val="accent1"/>
-          </a:lnRef>
-          <a:fillRef idx="3">
-            <a:schemeClr val="accent1"/>
-          </a:fillRef>
-          <a:effectRef idx="2">
-            <a:schemeClr val="accent1"/>
-          </a:effectRef>
-          <a:fontRef idx="minor">
-            <a:schemeClr val="lt1"/>
-          </a:fontRef>
-        </p:style>
-        <p:txBody>
-          <a:bodyPr rtlCol="0" anchor="ctr"/>
-          <a:lstStyle/>
-          <a:p>
-            <a:pPr algn="ctr"/>
-          </a:p>
-        </p:txBody>
-      </p:sp>
-      <p:sp>
-        <p:nvSpPr>
-          <p:cNvPr id="16" name="TextBox 15"/>
+          <p:cNvPr id="14" name="TextBox 13"/>
           <p:cNvSpPr txBox="1"/>
           <p:nvPr/>
         </p:nvSpPr>
         <p:spPr>
           <a:xfrm>
-            <a:off x="457200" y="3703320"/>
-            <a:ext cx="11247120" cy="822960"/>
+            <a:off x="457200" y="3429000"/>
+            <a:ext cx="10789920" cy="822960"/>
           </a:xfrm>
           <a:prstGeom prst="rect">
             <a:avLst/>
@@ -3660,8 +3555,8 @@
                   <a:srgbClr val="005555"/>
                 </a:solidFill>
               </a:rPr>
-              <a:t>Vous allez acquérir les compétences pour collecter des dons réguliers
-au nom de l'UNICEF auprès de donateurs français engagés.</a:t>
+              <a:t>Vous allez maîtriser le script officiel UNICEF en 7 étapes, qualifier vos appels
+selon la nomenclature FIDELIS et atteindre l'objectif de 9 CU/H minimum.</a:t>
             </a:r>
           </a:p>
         </p:txBody>
@@ -3736,7 +3631,7 @@
         <p:spPr>
           <a:xfrm>
             <a:off x="0" y="0"/>
-            <a:ext cx="12188952" cy="658368"/>
+            <a:ext cx="12188952" cy="685800"/>
           </a:xfrm>
           <a:prstGeom prst="rect">
             <a:avLst/>
@@ -3778,14 +3673,14 @@
         </p:nvSpPr>
         <p:spPr>
           <a:xfrm>
-            <a:off x="0" y="640080"/>
-            <a:ext cx="12188952" cy="54864"/>
+            <a:off x="0" y="667512"/>
+            <a:ext cx="12188952" cy="45720"/>
           </a:xfrm>
           <a:prstGeom prst="rect">
             <a:avLst/>
           </a:prstGeom>
           <a:solidFill>
-            <a:srgbClr val="FF0000"/>
+            <a:srgbClr val="00AAAA"/>
           </a:solidFill>
           <a:ln>
             <a:noFill/>
@@ -3821,8 +3716,8 @@
         </p:nvSpPr>
         <p:spPr>
           <a:xfrm>
-            <a:off x="164592" y="64008"/>
-            <a:ext cx="685800" cy="530352"/>
+            <a:off x="164592" y="73152"/>
+            <a:ext cx="2011680" cy="347472"/>
           </a:xfrm>
           <a:prstGeom prst="rect">
             <a:avLst/>
@@ -3837,12 +3732,12 @@
           <a:p>
             <a:pPr algn="l"/>
             <a:r>
-              <a:rPr sz="2000" b="1" i="0">
+              <a:rPr sz="1400" b="1" i="0">
                 <a:solidFill>
                   <a:srgbClr val="FFFFFF"/>
                 </a:solidFill>
               </a:rPr>
-              <a:t>SHY</a:t>
+              <a:t>SHY-Performance</a:t>
             </a:r>
           </a:p>
         </p:txBody>
@@ -3855,14 +3750,14 @@
         </p:nvSpPr>
         <p:spPr>
           <a:xfrm>
-            <a:off x="914400" y="91440"/>
-            <a:ext cx="36576" cy="475488"/>
+            <a:off x="2286000" y="91440"/>
+            <a:ext cx="36576" cy="502920"/>
           </a:xfrm>
           <a:prstGeom prst="rect">
             <a:avLst/>
           </a:prstGeom>
           <a:solidFill>
-            <a:srgbClr val="FF0000"/>
+            <a:srgbClr val="00AAAA"/>
           </a:solidFill>
           <a:ln>
             <a:noFill/>
@@ -3898,8 +3793,8 @@
         </p:nvSpPr>
         <p:spPr>
           <a:xfrm>
-            <a:off x="1024128" y="91440"/>
-            <a:ext cx="10881360" cy="475488"/>
+            <a:off x="2423160" y="91440"/>
+            <a:ext cx="9235440" cy="502920"/>
           </a:xfrm>
           <a:prstGeom prst="rect">
             <a:avLst/>
@@ -3914,7 +3809,7 @@
           <a:p>
             <a:pPr algn="l"/>
             <a:r>
-              <a:rPr sz="1700" b="1" i="0">
+              <a:rPr sz="1600" b="1" i="0">
                 <a:solidFill>
                   <a:srgbClr val="FFFFFF"/>
                 </a:solidFill>
@@ -3924,9 +3819,33 @@
           </a:p>
         </p:txBody>
       </p:sp>
-      <p:sp>
-        <p:nvSpPr>
-          <p:cNvPr id="8" name="Rectangle 7"/>
+      <p:pic>
+        <p:nvPicPr>
+          <p:cNvPr id="8" name="Picture 7" descr="shy_logo_v2.png"/>
+          <p:cNvPicPr>
+            <a:picLocks noChangeAspect="1"/>
+          </p:cNvPicPr>
+          <p:nvPr/>
+        </p:nvPicPr>
+        <p:blipFill>
+          <a:blip r:embed="rId2"/>
+          <a:stretch>
+            <a:fillRect/>
+          </a:stretch>
+        </p:blipFill>
+        <p:spPr>
+          <a:xfrm>
+            <a:off x="11247120" y="0"/>
+            <a:ext cx="822960" cy="676656"/>
+          </a:xfrm>
+          <a:prstGeom prst="rect">
+            <a:avLst/>
+          </a:prstGeom>
+        </p:spPr>
+      </p:pic>
+      <p:sp>
+        <p:nvSpPr>
+          <p:cNvPr id="9" name="Rectangle 8"/>
           <p:cNvSpPr/>
           <p:nvPr/>
         </p:nvSpPr>
@@ -3969,7 +3888,7 @@
       </p:sp>
       <p:sp>
         <p:nvSpPr>
-          <p:cNvPr id="9" name="TextBox 8"/>
+          <p:cNvPr id="10" name="TextBox 9"/>
           <p:cNvSpPr txBox="1"/>
           <p:nvPr/>
         </p:nvSpPr>
@@ -3991,103 +3910,26 @@
           <a:p>
             <a:pPr algn="ctr"/>
             <a:r>
-              <a:rPr sz="900" b="0" i="0">
+              <a:rPr sz="800" b="0" i="0">
                 <a:solidFill>
                   <a:srgbClr val="FFFFFF"/>
                 </a:solidFill>
               </a:rPr>
-              <a:t>SHY-Performance  ·  Formation FIM  ·  V6-01062026SHY-TE</a:t>
-            </a:r>
-          </a:p>
-        </p:txBody>
-      </p:sp>
-      <p:sp>
-        <p:nvSpPr>
-          <p:cNvPr id="10" name="Rectangle 9"/>
+              <a:t>SHY-Performance  ·  Formation FIM  ·  UNICEF France  ·  V6-01062026SHY-TE</a:t>
+            </a:r>
+          </a:p>
+        </p:txBody>
+      </p:sp>
+      <p:sp>
+        <p:nvSpPr>
+          <p:cNvPr id="11" name="Rectangle 10"/>
           <p:cNvSpPr/>
           <p:nvPr/>
         </p:nvSpPr>
         <p:spPr>
           <a:xfrm>
             <a:off x="274320" y="804672"/>
-            <a:ext cx="2286000" cy="347472"/>
-          </a:xfrm>
-          <a:prstGeom prst="rect">
-            <a:avLst/>
-          </a:prstGeom>
-          <a:solidFill>
-            <a:srgbClr val="FF0000"/>
-          </a:solidFill>
-          <a:ln>
-            <a:noFill/>
-          </a:ln>
-        </p:spPr>
-        <p:style>
-          <a:lnRef idx="1">
-            <a:schemeClr val="accent1"/>
-          </a:lnRef>
-          <a:fillRef idx="3">
-            <a:schemeClr val="accent1"/>
-          </a:fillRef>
-          <a:effectRef idx="2">
-            <a:schemeClr val="accent1"/>
-          </a:effectRef>
-          <a:fontRef idx="minor">
-            <a:schemeClr val="lt1"/>
-          </a:fontRef>
-        </p:style>
-        <p:txBody>
-          <a:bodyPr rtlCol="0" anchor="ctr"/>
-          <a:lstStyle/>
-          <a:p>
-            <a:pPr algn="ctr"/>
-          </a:p>
-        </p:txBody>
-      </p:sp>
-      <p:sp>
-        <p:nvSpPr>
-          <p:cNvPr id="11" name="TextBox 10"/>
-          <p:cNvSpPr txBox="1"/>
-          <p:nvPr/>
-        </p:nvSpPr>
-        <p:spPr>
-          <a:xfrm>
-            <a:off x="347472" y="832104"/>
-            <a:ext cx="2139696" cy="274320"/>
-          </a:xfrm>
-          <a:prstGeom prst="rect">
-            <a:avLst/>
-          </a:prstGeom>
-          <a:noFill/>
-        </p:spPr>
-        <p:txBody>
-          <a:bodyPr wrap="square">
-            <a:spAutoFit/>
-          </a:bodyPr>
-          <a:lstStyle/>
-          <a:p>
-            <a:pPr algn="l"/>
-            <a:r>
-              <a:rPr sz="1100" b="1" i="0">
-                <a:solidFill>
-                  <a:srgbClr val="FFFFFF"/>
-                </a:solidFill>
-              </a:rPr>
-              <a:t>JOUR 1</a:t>
-            </a:r>
-          </a:p>
-        </p:txBody>
-      </p:sp>
-      <p:sp>
-        <p:nvSpPr>
-          <p:cNvPr id="12" name="Rectangle 11"/>
-          <p:cNvSpPr/>
-          <p:nvPr/>
-        </p:nvSpPr>
-        <p:spPr>
-          <a:xfrm>
-            <a:off x="274320" y="1152144"/>
-            <a:ext cx="2286000" cy="1005840"/>
+            <a:ext cx="2286000" cy="329184"/>
           </a:xfrm>
           <a:prstGeom prst="rect">
             <a:avLst/>
@@ -4123,14 +3965,91 @@
       </p:sp>
       <p:sp>
         <p:nvSpPr>
-          <p:cNvPr id="13" name="TextBox 12"/>
+          <p:cNvPr id="12" name="TextBox 11"/>
           <p:cNvSpPr txBox="1"/>
           <p:nvPr/>
         </p:nvSpPr>
         <p:spPr>
           <a:xfrm>
-            <a:off x="384048" y="1188720"/>
-            <a:ext cx="2066543" cy="914400"/>
+            <a:off x="347472" y="832104"/>
+            <a:ext cx="2139696" cy="256032"/>
+          </a:xfrm>
+          <a:prstGeom prst="rect">
+            <a:avLst/>
+          </a:prstGeom>
+          <a:noFill/>
+        </p:spPr>
+        <p:txBody>
+          <a:bodyPr wrap="square">
+            <a:spAutoFit/>
+          </a:bodyPr>
+          <a:lstStyle/>
+          <a:p>
+            <a:pPr algn="l"/>
+            <a:r>
+              <a:rPr sz="1000" b="1" i="0">
+                <a:solidFill>
+                  <a:srgbClr val="FFFFFF"/>
+                </a:solidFill>
+              </a:rPr>
+              <a:t>JOUR 1</a:t>
+            </a:r>
+          </a:p>
+        </p:txBody>
+      </p:sp>
+      <p:sp>
+        <p:nvSpPr>
+          <p:cNvPr id="13" name="Rectangle 12"/>
+          <p:cNvSpPr/>
+          <p:nvPr/>
+        </p:nvSpPr>
+        <p:spPr>
+          <a:xfrm>
+            <a:off x="274320" y="1133856"/>
+            <a:ext cx="2286000" cy="960120"/>
+          </a:xfrm>
+          <a:prstGeom prst="rect">
+            <a:avLst/>
+          </a:prstGeom>
+          <a:solidFill>
+            <a:srgbClr val="008080"/>
+          </a:solidFill>
+          <a:ln>
+            <a:noFill/>
+          </a:ln>
+        </p:spPr>
+        <p:style>
+          <a:lnRef idx="1">
+            <a:schemeClr val="accent1"/>
+          </a:lnRef>
+          <a:fillRef idx="3">
+            <a:schemeClr val="accent1"/>
+          </a:fillRef>
+          <a:effectRef idx="2">
+            <a:schemeClr val="accent1"/>
+          </a:effectRef>
+          <a:fontRef idx="minor">
+            <a:schemeClr val="lt1"/>
+          </a:fontRef>
+        </p:style>
+        <p:txBody>
+          <a:bodyPr rtlCol="0" anchor="ctr"/>
+          <a:lstStyle/>
+          <a:p>
+            <a:pPr algn="ctr"/>
+          </a:p>
+        </p:txBody>
+      </p:sp>
+      <p:sp>
+        <p:nvSpPr>
+          <p:cNvPr id="14" name="TextBox 13"/>
+          <p:cNvSpPr txBox="1"/>
+          <p:nvPr/>
+        </p:nvSpPr>
+        <p:spPr>
+          <a:xfrm>
+            <a:off x="384048" y="1161288"/>
+            <a:ext cx="2066543" cy="896112"/>
           </a:xfrm>
           <a:prstGeom prst="rect">
             <a:avLst/>
@@ -4158,14 +4077,14 @@
       </p:sp>
       <p:sp>
         <p:nvSpPr>
-          <p:cNvPr id="14" name="Rectangle 13"/>
+          <p:cNvPr id="15" name="Rectangle 14"/>
           <p:cNvSpPr/>
           <p:nvPr/>
         </p:nvSpPr>
         <p:spPr>
           <a:xfrm>
-            <a:off x="274320" y="2157984"/>
-            <a:ext cx="2286000" cy="3246120"/>
+            <a:off x="274320" y="2093976"/>
+            <a:ext cx="2286000" cy="3291840"/>
           </a:xfrm>
           <a:prstGeom prst="rect">
             <a:avLst/>
@@ -4203,14 +4122,14 @@
       </p:sp>
       <p:sp>
         <p:nvSpPr>
-          <p:cNvPr id="15" name="TextBox 14"/>
+          <p:cNvPr id="16" name="TextBox 15"/>
           <p:cNvSpPr txBox="1"/>
           <p:nvPr/>
         </p:nvSpPr>
         <p:spPr>
           <a:xfrm>
-            <a:off x="411479" y="2231136"/>
-            <a:ext cx="2011680" cy="2926080"/>
+            <a:off x="402336" y="2167128"/>
+            <a:ext cx="2029968" cy="3127248"/>
           </a:xfrm>
           <a:prstGeom prst="rect">
             <a:avLst/>
@@ -4225,105 +4144,26 @@
           <a:p>
             <a:pPr algn="l"/>
             <a:r>
-              <a:rPr sz="1100" b="0" i="0">
+              <a:rPr sz="1000" b="0" i="0">
                 <a:solidFill>
                   <a:srgbClr val="1A1A1A"/>
                 </a:solidFill>
               </a:rPr>
-              <a:t>Vous découvrez votre rôle,
-les valeurs UNICEF
-et votre posture.</a:t>
-            </a:r>
-          </a:p>
-        </p:txBody>
-      </p:sp>
-      <p:sp>
-        <p:nvSpPr>
-          <p:cNvPr id="16" name="Rectangle 15"/>
+              <a:t>Mission UNICEF · KPI (CU/H, TX Transfo, PDC) · Nomenclature FIDELIS · Organisation de la production</a:t>
+            </a:r>
+          </a:p>
+        </p:txBody>
+      </p:sp>
+      <p:sp>
+        <p:nvSpPr>
+          <p:cNvPr id="17" name="Rectangle 16"/>
           <p:cNvSpPr/>
           <p:nvPr/>
         </p:nvSpPr>
         <p:spPr>
           <a:xfrm>
             <a:off x="2633472" y="804672"/>
-            <a:ext cx="2286000" cy="347472"/>
-          </a:xfrm>
-          <a:prstGeom prst="rect">
-            <a:avLst/>
-          </a:prstGeom>
-          <a:solidFill>
-            <a:srgbClr val="FF0000"/>
-          </a:solidFill>
-          <a:ln>
-            <a:noFill/>
-          </a:ln>
-        </p:spPr>
-        <p:style>
-          <a:lnRef idx="1">
-            <a:schemeClr val="accent1"/>
-          </a:lnRef>
-          <a:fillRef idx="3">
-            <a:schemeClr val="accent1"/>
-          </a:fillRef>
-          <a:effectRef idx="2">
-            <a:schemeClr val="accent1"/>
-          </a:effectRef>
-          <a:fontRef idx="minor">
-            <a:schemeClr val="lt1"/>
-          </a:fontRef>
-        </p:style>
-        <p:txBody>
-          <a:bodyPr rtlCol="0" anchor="ctr"/>
-          <a:lstStyle/>
-          <a:p>
-            <a:pPr algn="ctr"/>
-          </a:p>
-        </p:txBody>
-      </p:sp>
-      <p:sp>
-        <p:nvSpPr>
-          <p:cNvPr id="17" name="TextBox 16"/>
-          <p:cNvSpPr txBox="1"/>
-          <p:nvPr/>
-        </p:nvSpPr>
-        <p:spPr>
-          <a:xfrm>
-            <a:off x="2706624" y="832104"/>
-            <a:ext cx="2139696" cy="274320"/>
-          </a:xfrm>
-          <a:prstGeom prst="rect">
-            <a:avLst/>
-          </a:prstGeom>
-          <a:noFill/>
-        </p:spPr>
-        <p:txBody>
-          <a:bodyPr wrap="square">
-            <a:spAutoFit/>
-          </a:bodyPr>
-          <a:lstStyle/>
-          <a:p>
-            <a:pPr algn="l"/>
-            <a:r>
-              <a:rPr sz="1100" b="1" i="0">
-                <a:solidFill>
-                  <a:srgbClr val="FFFFFF"/>
-                </a:solidFill>
-              </a:rPr>
-              <a:t>JOUR 2</a:t>
-            </a:r>
-          </a:p>
-        </p:txBody>
-      </p:sp>
-      <p:sp>
-        <p:nvSpPr>
-          <p:cNvPr id="18" name="Rectangle 17"/>
-          <p:cNvSpPr/>
-          <p:nvPr/>
-        </p:nvSpPr>
-        <p:spPr>
-          <a:xfrm>
-            <a:off x="2633472" y="1152144"/>
-            <a:ext cx="2286000" cy="1005840"/>
+            <a:ext cx="2286000" cy="329184"/>
           </a:xfrm>
           <a:prstGeom prst="rect">
             <a:avLst/>
@@ -4359,14 +4199,91 @@
       </p:sp>
       <p:sp>
         <p:nvSpPr>
-          <p:cNvPr id="19" name="TextBox 18"/>
+          <p:cNvPr id="18" name="TextBox 17"/>
           <p:cNvSpPr txBox="1"/>
           <p:nvPr/>
         </p:nvSpPr>
         <p:spPr>
           <a:xfrm>
-            <a:off x="2743200" y="1188720"/>
-            <a:ext cx="2066543" cy="914400"/>
+            <a:off x="2706624" y="832104"/>
+            <a:ext cx="2139696" cy="256032"/>
+          </a:xfrm>
+          <a:prstGeom prst="rect">
+            <a:avLst/>
+          </a:prstGeom>
+          <a:noFill/>
+        </p:spPr>
+        <p:txBody>
+          <a:bodyPr wrap="square">
+            <a:spAutoFit/>
+          </a:bodyPr>
+          <a:lstStyle/>
+          <a:p>
+            <a:pPr algn="l"/>
+            <a:r>
+              <a:rPr sz="1000" b="1" i="0">
+                <a:solidFill>
+                  <a:srgbClr val="FFFFFF"/>
+                </a:solidFill>
+              </a:rPr>
+              <a:t>JOUR 2</a:t>
+            </a:r>
+          </a:p>
+        </p:txBody>
+      </p:sp>
+      <p:sp>
+        <p:nvSpPr>
+          <p:cNvPr id="19" name="Rectangle 18"/>
+          <p:cNvSpPr/>
+          <p:nvPr/>
+        </p:nvSpPr>
+        <p:spPr>
+          <a:xfrm>
+            <a:off x="2633472" y="1133856"/>
+            <a:ext cx="2286000" cy="960120"/>
+          </a:xfrm>
+          <a:prstGeom prst="rect">
+            <a:avLst/>
+          </a:prstGeom>
+          <a:solidFill>
+            <a:srgbClr val="008080"/>
+          </a:solidFill>
+          <a:ln>
+            <a:noFill/>
+          </a:ln>
+        </p:spPr>
+        <p:style>
+          <a:lnRef idx="1">
+            <a:schemeClr val="accent1"/>
+          </a:lnRef>
+          <a:fillRef idx="3">
+            <a:schemeClr val="accent1"/>
+          </a:fillRef>
+          <a:effectRef idx="2">
+            <a:schemeClr val="accent1"/>
+          </a:effectRef>
+          <a:fontRef idx="minor">
+            <a:schemeClr val="lt1"/>
+          </a:fontRef>
+        </p:style>
+        <p:txBody>
+          <a:bodyPr rtlCol="0" anchor="ctr"/>
+          <a:lstStyle/>
+          <a:p>
+            <a:pPr algn="ctr"/>
+          </a:p>
+        </p:txBody>
+      </p:sp>
+      <p:sp>
+        <p:nvSpPr>
+          <p:cNvPr id="20" name="TextBox 19"/>
+          <p:cNvSpPr txBox="1"/>
+          <p:nvPr/>
+        </p:nvSpPr>
+        <p:spPr>
+          <a:xfrm>
+            <a:off x="2743200" y="1161288"/>
+            <a:ext cx="2066543" cy="896112"/>
           </a:xfrm>
           <a:prstGeom prst="rect">
             <a:avLst/>
@@ -4394,14 +4311,14 @@
       </p:sp>
       <p:sp>
         <p:nvSpPr>
-          <p:cNvPr id="20" name="Rectangle 19"/>
+          <p:cNvPr id="21" name="Rectangle 20"/>
           <p:cNvSpPr/>
           <p:nvPr/>
         </p:nvSpPr>
         <p:spPr>
           <a:xfrm>
-            <a:off x="2633472" y="2157984"/>
-            <a:ext cx="2286000" cy="3246120"/>
+            <a:off x="2633472" y="2093976"/>
+            <a:ext cx="2286000" cy="3291840"/>
           </a:xfrm>
           <a:prstGeom prst="rect">
             <a:avLst/>
@@ -4439,14 +4356,14 @@
       </p:sp>
       <p:sp>
         <p:nvSpPr>
-          <p:cNvPr id="21" name="TextBox 20"/>
+          <p:cNvPr id="22" name="TextBox 21"/>
           <p:cNvSpPr txBox="1"/>
           <p:nvPr/>
         </p:nvSpPr>
         <p:spPr>
           <a:xfrm>
-            <a:off x="2770632" y="2231136"/>
-            <a:ext cx="2011680" cy="2926080"/>
+            <a:off x="2761488" y="2167128"/>
+            <a:ext cx="2029968" cy="3127248"/>
           </a:xfrm>
           <a:prstGeom prst="rect">
             <a:avLst/>
@@ -4461,105 +4378,26 @@
           <a:p>
             <a:pPr algn="l"/>
             <a:r>
-              <a:rPr sz="1100" b="0" i="0">
+              <a:rPr sz="1000" b="0" i="0">
                 <a:solidFill>
                   <a:srgbClr val="1A1A1A"/>
                 </a:solidFill>
               </a:rPr>
-              <a:t>Vous comprenez le don
-régulier et l'impact
-concret de chaque euro.</a:t>
-            </a:r>
-          </a:p>
-        </p:txBody>
-      </p:sp>
-      <p:sp>
-        <p:nvSpPr>
-          <p:cNvPr id="22" name="Rectangle 21"/>
+              <a:t>Loi 1901 · Histoire humanitaire · Principes humanitaires · Don régulier · Label Don en Confiance</a:t>
+            </a:r>
+          </a:p>
+        </p:txBody>
+      </p:sp>
+      <p:sp>
+        <p:nvSpPr>
+          <p:cNvPr id="23" name="Rectangle 22"/>
           <p:cNvSpPr/>
           <p:nvPr/>
         </p:nvSpPr>
         <p:spPr>
           <a:xfrm>
             <a:off x="4992624" y="804672"/>
-            <a:ext cx="2286000" cy="347472"/>
-          </a:xfrm>
-          <a:prstGeom prst="rect">
-            <a:avLst/>
-          </a:prstGeom>
-          <a:solidFill>
-            <a:srgbClr val="FF0000"/>
-          </a:solidFill>
-          <a:ln>
-            <a:noFill/>
-          </a:ln>
-        </p:spPr>
-        <p:style>
-          <a:lnRef idx="1">
-            <a:schemeClr val="accent1"/>
-          </a:lnRef>
-          <a:fillRef idx="3">
-            <a:schemeClr val="accent1"/>
-          </a:fillRef>
-          <a:effectRef idx="2">
-            <a:schemeClr val="accent1"/>
-          </a:effectRef>
-          <a:fontRef idx="minor">
-            <a:schemeClr val="lt1"/>
-          </a:fontRef>
-        </p:style>
-        <p:txBody>
-          <a:bodyPr rtlCol="0" anchor="ctr"/>
-          <a:lstStyle/>
-          <a:p>
-            <a:pPr algn="ctr"/>
-          </a:p>
-        </p:txBody>
-      </p:sp>
-      <p:sp>
-        <p:nvSpPr>
-          <p:cNvPr id="23" name="TextBox 22"/>
-          <p:cNvSpPr txBox="1"/>
-          <p:nvPr/>
-        </p:nvSpPr>
-        <p:spPr>
-          <a:xfrm>
-            <a:off x="5065776" y="832104"/>
-            <a:ext cx="2139696" cy="274320"/>
-          </a:xfrm>
-          <a:prstGeom prst="rect">
-            <a:avLst/>
-          </a:prstGeom>
-          <a:noFill/>
-        </p:spPr>
-        <p:txBody>
-          <a:bodyPr wrap="square">
-            <a:spAutoFit/>
-          </a:bodyPr>
-          <a:lstStyle/>
-          <a:p>
-            <a:pPr algn="l"/>
-            <a:r>
-              <a:rPr sz="1100" b="1" i="0">
-                <a:solidFill>
-                  <a:srgbClr val="FFFFFF"/>
-                </a:solidFill>
-              </a:rPr>
-              <a:t>JOUR 3</a:t>
-            </a:r>
-          </a:p>
-        </p:txBody>
-      </p:sp>
-      <p:sp>
-        <p:nvSpPr>
-          <p:cNvPr id="24" name="Rectangle 23"/>
-          <p:cNvSpPr/>
-          <p:nvPr/>
-        </p:nvSpPr>
-        <p:spPr>
-          <a:xfrm>
-            <a:off x="4992624" y="1152144"/>
-            <a:ext cx="2286000" cy="1005840"/>
+            <a:ext cx="2286000" cy="329184"/>
           </a:xfrm>
           <a:prstGeom prst="rect">
             <a:avLst/>
@@ -4595,14 +4433,91 @@
       </p:sp>
       <p:sp>
         <p:nvSpPr>
-          <p:cNvPr id="25" name="TextBox 24"/>
+          <p:cNvPr id="24" name="TextBox 23"/>
           <p:cNvSpPr txBox="1"/>
           <p:nvPr/>
         </p:nvSpPr>
         <p:spPr>
           <a:xfrm>
-            <a:off x="5102352" y="1188720"/>
-            <a:ext cx="2066543" cy="914400"/>
+            <a:off x="5065776" y="832104"/>
+            <a:ext cx="2139696" cy="256032"/>
+          </a:xfrm>
+          <a:prstGeom prst="rect">
+            <a:avLst/>
+          </a:prstGeom>
+          <a:noFill/>
+        </p:spPr>
+        <p:txBody>
+          <a:bodyPr wrap="square">
+            <a:spAutoFit/>
+          </a:bodyPr>
+          <a:lstStyle/>
+          <a:p>
+            <a:pPr algn="l"/>
+            <a:r>
+              <a:rPr sz="1000" b="1" i="0">
+                <a:solidFill>
+                  <a:srgbClr val="FFFFFF"/>
+                </a:solidFill>
+              </a:rPr>
+              <a:t>JOUR 3</a:t>
+            </a:r>
+          </a:p>
+        </p:txBody>
+      </p:sp>
+      <p:sp>
+        <p:nvSpPr>
+          <p:cNvPr id="25" name="Rectangle 24"/>
+          <p:cNvSpPr/>
+          <p:nvPr/>
+        </p:nvSpPr>
+        <p:spPr>
+          <a:xfrm>
+            <a:off x="4992624" y="1133856"/>
+            <a:ext cx="2286000" cy="960120"/>
+          </a:xfrm>
+          <a:prstGeom prst="rect">
+            <a:avLst/>
+          </a:prstGeom>
+          <a:solidFill>
+            <a:srgbClr val="008080"/>
+          </a:solidFill>
+          <a:ln>
+            <a:noFill/>
+          </a:ln>
+        </p:spPr>
+        <p:style>
+          <a:lnRef idx="1">
+            <a:schemeClr val="accent1"/>
+          </a:lnRef>
+          <a:fillRef idx="3">
+            <a:schemeClr val="accent1"/>
+          </a:fillRef>
+          <a:effectRef idx="2">
+            <a:schemeClr val="accent1"/>
+          </a:effectRef>
+          <a:fontRef idx="minor">
+            <a:schemeClr val="lt1"/>
+          </a:fontRef>
+        </p:style>
+        <p:txBody>
+          <a:bodyPr rtlCol="0" anchor="ctr"/>
+          <a:lstStyle/>
+          <a:p>
+            <a:pPr algn="ctr"/>
+          </a:p>
+        </p:txBody>
+      </p:sp>
+      <p:sp>
+        <p:nvSpPr>
+          <p:cNvPr id="26" name="TextBox 25"/>
+          <p:cNvSpPr txBox="1"/>
+          <p:nvPr/>
+        </p:nvSpPr>
+        <p:spPr>
+          <a:xfrm>
+            <a:off x="5102352" y="1161288"/>
+            <a:ext cx="2066543" cy="896112"/>
           </a:xfrm>
           <a:prstGeom prst="rect">
             <a:avLst/>
@@ -4622,22 +4537,22 @@
                   <a:srgbClr val="FFFFFF"/>
                 </a:solidFill>
               </a:rPr>
-              <a:t>Votre Script
-de Présentation</a:t>
-            </a:r>
-          </a:p>
-        </p:txBody>
-      </p:sp>
-      <p:sp>
-        <p:nvSpPr>
-          <p:cNvPr id="26" name="Rectangle 25"/>
+              <a:t>Analyse &amp;
+Script</a:t>
+            </a:r>
+          </a:p>
+        </p:txBody>
+      </p:sp>
+      <p:sp>
+        <p:nvSpPr>
+          <p:cNvPr id="27" name="Rectangle 26"/>
           <p:cNvSpPr/>
           <p:nvPr/>
         </p:nvSpPr>
         <p:spPr>
           <a:xfrm>
-            <a:off x="4992624" y="2157984"/>
-            <a:ext cx="2286000" cy="3246120"/>
+            <a:off x="4992624" y="2093976"/>
+            <a:ext cx="2286000" cy="3291840"/>
           </a:xfrm>
           <a:prstGeom prst="rect">
             <a:avLst/>
@@ -4675,14 +4590,14 @@
       </p:sp>
       <p:sp>
         <p:nvSpPr>
-          <p:cNvPr id="27" name="TextBox 26"/>
+          <p:cNvPr id="28" name="TextBox 27"/>
           <p:cNvSpPr txBox="1"/>
           <p:nvPr/>
         </p:nvSpPr>
         <p:spPr>
           <a:xfrm>
-            <a:off x="5129784" y="2231136"/>
-            <a:ext cx="2011680" cy="2926080"/>
+            <a:off x="5120640" y="2167128"/>
+            <a:ext cx="2029968" cy="3127248"/>
           </a:xfrm>
           <a:prstGeom prst="rect">
             <a:avLst/>
@@ -4697,105 +4612,26 @@
           <a:p>
             <a:pPr algn="l"/>
             <a:r>
-              <a:rPr sz="1100" b="0" i="0">
+              <a:rPr sz="1000" b="0" i="0">
                 <a:solidFill>
                   <a:srgbClr val="1A1A1A"/>
                 </a:solidFill>
               </a:rPr>
-              <a:t>Vous maîtrisez les
-5 étapes pour convaincre
-avec authenticité.</a:t>
-            </a:r>
-          </a:p>
-        </p:txBody>
-      </p:sp>
-      <p:sp>
-        <p:nvSpPr>
-          <p:cNvPr id="28" name="Rectangle 27"/>
+              <a:t>Script officiel UNICEF 7 étapes · 5 règles d'accroche · 4 modes de validation du don · Lecture à voix haute</a:t>
+            </a:r>
+          </a:p>
+        </p:txBody>
+      </p:sp>
+      <p:sp>
+        <p:nvSpPr>
+          <p:cNvPr id="29" name="Rectangle 28"/>
           <p:cNvSpPr/>
           <p:nvPr/>
         </p:nvSpPr>
         <p:spPr>
           <a:xfrm>
             <a:off x="7351775" y="804672"/>
-            <a:ext cx="2286000" cy="347472"/>
-          </a:xfrm>
-          <a:prstGeom prst="rect">
-            <a:avLst/>
-          </a:prstGeom>
-          <a:solidFill>
-            <a:srgbClr val="FF0000"/>
-          </a:solidFill>
-          <a:ln>
-            <a:noFill/>
-          </a:ln>
-        </p:spPr>
-        <p:style>
-          <a:lnRef idx="1">
-            <a:schemeClr val="accent1"/>
-          </a:lnRef>
-          <a:fillRef idx="3">
-            <a:schemeClr val="accent1"/>
-          </a:fillRef>
-          <a:effectRef idx="2">
-            <a:schemeClr val="accent1"/>
-          </a:effectRef>
-          <a:fontRef idx="minor">
-            <a:schemeClr val="lt1"/>
-          </a:fontRef>
-        </p:style>
-        <p:txBody>
-          <a:bodyPr rtlCol="0" anchor="ctr"/>
-          <a:lstStyle/>
-          <a:p>
-            <a:pPr algn="ctr"/>
-          </a:p>
-        </p:txBody>
-      </p:sp>
-      <p:sp>
-        <p:nvSpPr>
-          <p:cNvPr id="29" name="TextBox 28"/>
-          <p:cNvSpPr txBox="1"/>
-          <p:nvPr/>
-        </p:nvSpPr>
-        <p:spPr>
-          <a:xfrm>
-            <a:off x="7424927" y="832104"/>
-            <a:ext cx="2139696" cy="274320"/>
-          </a:xfrm>
-          <a:prstGeom prst="rect">
-            <a:avLst/>
-          </a:prstGeom>
-          <a:noFill/>
-        </p:spPr>
-        <p:txBody>
-          <a:bodyPr wrap="square">
-            <a:spAutoFit/>
-          </a:bodyPr>
-          <a:lstStyle/>
-          <a:p>
-            <a:pPr algn="l"/>
-            <a:r>
-              <a:rPr sz="1100" b="1" i="0">
-                <a:solidFill>
-                  <a:srgbClr val="FFFFFF"/>
-                </a:solidFill>
-              </a:rPr>
-              <a:t>JOUR 4</a:t>
-            </a:r>
-          </a:p>
-        </p:txBody>
-      </p:sp>
-      <p:sp>
-        <p:nvSpPr>
-          <p:cNvPr id="30" name="Rectangle 29"/>
-          <p:cNvSpPr/>
-          <p:nvPr/>
-        </p:nvSpPr>
-        <p:spPr>
-          <a:xfrm>
-            <a:off x="7351775" y="1152144"/>
-            <a:ext cx="2286000" cy="1005840"/>
+            <a:ext cx="2286000" cy="329184"/>
           </a:xfrm>
           <a:prstGeom prst="rect">
             <a:avLst/>
@@ -4831,14 +4667,91 @@
       </p:sp>
       <p:sp>
         <p:nvSpPr>
-          <p:cNvPr id="31" name="TextBox 30"/>
+          <p:cNvPr id="30" name="TextBox 29"/>
           <p:cNvSpPr txBox="1"/>
           <p:nvPr/>
         </p:nvSpPr>
         <p:spPr>
           <a:xfrm>
-            <a:off x="7461503" y="1188720"/>
-            <a:ext cx="2066543" cy="914400"/>
+            <a:off x="7424927" y="832104"/>
+            <a:ext cx="2139696" cy="256032"/>
+          </a:xfrm>
+          <a:prstGeom prst="rect">
+            <a:avLst/>
+          </a:prstGeom>
+          <a:noFill/>
+        </p:spPr>
+        <p:txBody>
+          <a:bodyPr wrap="square">
+            <a:spAutoFit/>
+          </a:bodyPr>
+          <a:lstStyle/>
+          <a:p>
+            <a:pPr algn="l"/>
+            <a:r>
+              <a:rPr sz="1000" b="1" i="0">
+                <a:solidFill>
+                  <a:srgbClr val="FFFFFF"/>
+                </a:solidFill>
+              </a:rPr>
+              <a:t>JOUR 4</a:t>
+            </a:r>
+          </a:p>
+        </p:txBody>
+      </p:sp>
+      <p:sp>
+        <p:nvSpPr>
+          <p:cNvPr id="31" name="Rectangle 30"/>
+          <p:cNvSpPr/>
+          <p:nvPr/>
+        </p:nvSpPr>
+        <p:spPr>
+          <a:xfrm>
+            <a:off x="7351775" y="1133856"/>
+            <a:ext cx="2286000" cy="960120"/>
+          </a:xfrm>
+          <a:prstGeom prst="rect">
+            <a:avLst/>
+          </a:prstGeom>
+          <a:solidFill>
+            <a:srgbClr val="008080"/>
+          </a:solidFill>
+          <a:ln>
+            <a:noFill/>
+          </a:ln>
+        </p:spPr>
+        <p:style>
+          <a:lnRef idx="1">
+            <a:schemeClr val="accent1"/>
+          </a:lnRef>
+          <a:fillRef idx="3">
+            <a:schemeClr val="accent1"/>
+          </a:fillRef>
+          <a:effectRef idx="2">
+            <a:schemeClr val="accent1"/>
+          </a:effectRef>
+          <a:fontRef idx="minor">
+            <a:schemeClr val="lt1"/>
+          </a:fontRef>
+        </p:style>
+        <p:txBody>
+          <a:bodyPr rtlCol="0" anchor="ctr"/>
+          <a:lstStyle/>
+          <a:p>
+            <a:pPr algn="ctr"/>
+          </a:p>
+        </p:txBody>
+      </p:sp>
+      <p:sp>
+        <p:nvSpPr>
+          <p:cNvPr id="32" name="TextBox 31"/>
+          <p:cNvSpPr txBox="1"/>
+          <p:nvPr/>
+        </p:nvSpPr>
+        <p:spPr>
+          <a:xfrm>
+            <a:off x="7461503" y="1161288"/>
+            <a:ext cx="2066543" cy="896112"/>
           </a:xfrm>
           <a:prstGeom prst="rect">
             <a:avLst/>
@@ -4858,22 +4771,22 @@
                   <a:srgbClr val="FFFFFF"/>
                 </a:solidFill>
               </a:rPr>
-              <a:t>Gérer les
-Objections</a:t>
-            </a:r>
-          </a:p>
-        </p:txBody>
-      </p:sp>
-      <p:sp>
-        <p:nvSpPr>
-          <p:cNvPr id="32" name="Rectangle 31"/>
+              <a:t>Traitement
+des Objections</a:t>
+            </a:r>
+          </a:p>
+        </p:txBody>
+      </p:sp>
+      <p:sp>
+        <p:nvSpPr>
+          <p:cNvPr id="33" name="Rectangle 32"/>
           <p:cNvSpPr/>
           <p:nvPr/>
         </p:nvSpPr>
         <p:spPr>
           <a:xfrm>
-            <a:off x="7351775" y="2157984"/>
-            <a:ext cx="2286000" cy="3246120"/>
+            <a:off x="7351775" y="2093976"/>
+            <a:ext cx="2286000" cy="3291840"/>
           </a:xfrm>
           <a:prstGeom prst="rect">
             <a:avLst/>
@@ -4911,14 +4824,14 @@
       </p:sp>
       <p:sp>
         <p:nvSpPr>
-          <p:cNvPr id="33" name="TextBox 32"/>
+          <p:cNvPr id="34" name="TextBox 33"/>
           <p:cNvSpPr txBox="1"/>
           <p:nvPr/>
         </p:nvSpPr>
         <p:spPr>
           <a:xfrm>
-            <a:off x="7488936" y="2231136"/>
-            <a:ext cx="2011680" cy="2926080"/>
+            <a:off x="7479792" y="2167128"/>
+            <a:ext cx="2029968" cy="3127248"/>
           </a:xfrm>
           <a:prstGeom prst="rect">
             <a:avLst/>
@@ -4933,105 +4846,26 @@
           <a:p>
             <a:pPr algn="l"/>
             <a:r>
-              <a:rPr sz="1100" b="0" i="0">
+              <a:rPr sz="1000" b="0" i="0">
                 <a:solidFill>
                   <a:srgbClr val="1A1A1A"/>
                 </a:solidFill>
               </a:rPr>
-              <a:t>Vous transformez chaque
-refus en opportunité
-d'engager le donateur.</a:t>
-            </a:r>
-          </a:p>
-        </p:txBody>
-      </p:sp>
-      <p:sp>
-        <p:nvSpPr>
-          <p:cNvPr id="34" name="Rectangle 33"/>
+              <a:t>15 objections · 5 catégories · Méthode AAR · Jeux de rôle · Grille formateur</a:t>
+            </a:r>
+          </a:p>
+        </p:txBody>
+      </p:sp>
+      <p:sp>
+        <p:nvSpPr>
+          <p:cNvPr id="35" name="Rectangle 34"/>
           <p:cNvSpPr/>
           <p:nvPr/>
         </p:nvSpPr>
         <p:spPr>
           <a:xfrm>
             <a:off x="9710928" y="804672"/>
-            <a:ext cx="2286000" cy="347472"/>
-          </a:xfrm>
-          <a:prstGeom prst="rect">
-            <a:avLst/>
-          </a:prstGeom>
-          <a:solidFill>
-            <a:srgbClr val="FF0000"/>
-          </a:solidFill>
-          <a:ln>
-            <a:noFill/>
-          </a:ln>
-        </p:spPr>
-        <p:style>
-          <a:lnRef idx="1">
-            <a:schemeClr val="accent1"/>
-          </a:lnRef>
-          <a:fillRef idx="3">
-            <a:schemeClr val="accent1"/>
-          </a:fillRef>
-          <a:effectRef idx="2">
-            <a:schemeClr val="accent1"/>
-          </a:effectRef>
-          <a:fontRef idx="minor">
-            <a:schemeClr val="lt1"/>
-          </a:fontRef>
-        </p:style>
-        <p:txBody>
-          <a:bodyPr rtlCol="0" anchor="ctr"/>
-          <a:lstStyle/>
-          <a:p>
-            <a:pPr algn="ctr"/>
-          </a:p>
-        </p:txBody>
-      </p:sp>
-      <p:sp>
-        <p:nvSpPr>
-          <p:cNvPr id="35" name="TextBox 34"/>
-          <p:cNvSpPr txBox="1"/>
-          <p:nvPr/>
-        </p:nvSpPr>
-        <p:spPr>
-          <a:xfrm>
-            <a:off x="9784080" y="832104"/>
-            <a:ext cx="2139696" cy="274320"/>
-          </a:xfrm>
-          <a:prstGeom prst="rect">
-            <a:avLst/>
-          </a:prstGeom>
-          <a:noFill/>
-        </p:spPr>
-        <p:txBody>
-          <a:bodyPr wrap="square">
-            <a:spAutoFit/>
-          </a:bodyPr>
-          <a:lstStyle/>
-          <a:p>
-            <a:pPr algn="l"/>
-            <a:r>
-              <a:rPr sz="1100" b="1" i="0">
-                <a:solidFill>
-                  <a:srgbClr val="FFFFFF"/>
-                </a:solidFill>
-              </a:rPr>
-              <a:t>JOUR 5</a:t>
-            </a:r>
-          </a:p>
-        </p:txBody>
-      </p:sp>
-      <p:sp>
-        <p:nvSpPr>
-          <p:cNvPr id="36" name="Rectangle 35"/>
-          <p:cNvSpPr/>
-          <p:nvPr/>
-        </p:nvSpPr>
-        <p:spPr>
-          <a:xfrm>
-            <a:off x="9710928" y="1152144"/>
-            <a:ext cx="2286000" cy="1005840"/>
+            <a:ext cx="2286000" cy="329184"/>
           </a:xfrm>
           <a:prstGeom prst="rect">
             <a:avLst/>
@@ -5067,14 +4901,91 @@
       </p:sp>
       <p:sp>
         <p:nvSpPr>
-          <p:cNvPr id="37" name="TextBox 36"/>
+          <p:cNvPr id="36" name="TextBox 35"/>
           <p:cNvSpPr txBox="1"/>
           <p:nvPr/>
         </p:nvSpPr>
         <p:spPr>
           <a:xfrm>
-            <a:off x="9820655" y="1188720"/>
-            <a:ext cx="2066543" cy="914400"/>
+            <a:off x="9784080" y="832104"/>
+            <a:ext cx="2139696" cy="256032"/>
+          </a:xfrm>
+          <a:prstGeom prst="rect">
+            <a:avLst/>
+          </a:prstGeom>
+          <a:noFill/>
+        </p:spPr>
+        <p:txBody>
+          <a:bodyPr wrap="square">
+            <a:spAutoFit/>
+          </a:bodyPr>
+          <a:lstStyle/>
+          <a:p>
+            <a:pPr algn="l"/>
+            <a:r>
+              <a:rPr sz="1000" b="1" i="0">
+                <a:solidFill>
+                  <a:srgbClr val="FFFFFF"/>
+                </a:solidFill>
+              </a:rPr>
+              <a:t>JOUR 5</a:t>
+            </a:r>
+          </a:p>
+        </p:txBody>
+      </p:sp>
+      <p:sp>
+        <p:nvSpPr>
+          <p:cNvPr id="37" name="Rectangle 36"/>
+          <p:cNvSpPr/>
+          <p:nvPr/>
+        </p:nvSpPr>
+        <p:spPr>
+          <a:xfrm>
+            <a:off x="9710928" y="1133856"/>
+            <a:ext cx="2286000" cy="960120"/>
+          </a:xfrm>
+          <a:prstGeom prst="rect">
+            <a:avLst/>
+          </a:prstGeom>
+          <a:solidFill>
+            <a:srgbClr val="008080"/>
+          </a:solidFill>
+          <a:ln>
+            <a:noFill/>
+          </a:ln>
+        </p:spPr>
+        <p:style>
+          <a:lnRef idx="1">
+            <a:schemeClr val="accent1"/>
+          </a:lnRef>
+          <a:fillRef idx="3">
+            <a:schemeClr val="accent1"/>
+          </a:fillRef>
+          <a:effectRef idx="2">
+            <a:schemeClr val="accent1"/>
+          </a:effectRef>
+          <a:fontRef idx="minor">
+            <a:schemeClr val="lt1"/>
+          </a:fontRef>
+        </p:style>
+        <p:txBody>
+          <a:bodyPr rtlCol="0" anchor="ctr"/>
+          <a:lstStyle/>
+          <a:p>
+            <a:pPr algn="ctr"/>
+          </a:p>
+        </p:txBody>
+      </p:sp>
+      <p:sp>
+        <p:nvSpPr>
+          <p:cNvPr id="38" name="TextBox 37"/>
+          <p:cNvSpPr txBox="1"/>
+          <p:nvPr/>
+        </p:nvSpPr>
+        <p:spPr>
+          <a:xfrm>
+            <a:off x="9820655" y="1161288"/>
+            <a:ext cx="2066543" cy="896112"/>
           </a:xfrm>
           <a:prstGeom prst="rect">
             <a:avLst/>
@@ -5094,22 +5005,22 @@
                   <a:srgbClr val="FFFFFF"/>
                 </a:solidFill>
               </a:rPr>
-              <a:t>Certification
-&amp; Terrain</a:t>
-            </a:r>
-          </a:p>
-        </p:txBody>
-      </p:sp>
-      <p:sp>
-        <p:nvSpPr>
-          <p:cNvPr id="38" name="Rectangle 37"/>
+              <a:t>Synthèse &amp;
+Certification</a:t>
+            </a:r>
+          </a:p>
+        </p:txBody>
+      </p:sp>
+      <p:sp>
+        <p:nvSpPr>
+          <p:cNvPr id="39" name="Rectangle 38"/>
           <p:cNvSpPr/>
           <p:nvPr/>
         </p:nvSpPr>
         <p:spPr>
           <a:xfrm>
-            <a:off x="9710928" y="2157984"/>
-            <a:ext cx="2286000" cy="3246120"/>
+            <a:off x="9710928" y="2093976"/>
+            <a:ext cx="2286000" cy="3291840"/>
           </a:xfrm>
           <a:prstGeom prst="rect">
             <a:avLst/>
@@ -5147,14 +5058,14 @@
       </p:sp>
       <p:sp>
         <p:nvSpPr>
-          <p:cNvPr id="39" name="TextBox 38"/>
+          <p:cNvPr id="40" name="TextBox 39"/>
           <p:cNvSpPr txBox="1"/>
           <p:nvPr/>
         </p:nvSpPr>
         <p:spPr>
           <a:xfrm>
-            <a:off x="9848088" y="2231136"/>
-            <a:ext cx="2011680" cy="2926080"/>
+            <a:off x="9838944" y="2167128"/>
+            <a:ext cx="2029968" cy="3127248"/>
           </a:xfrm>
           <a:prstGeom prst="rect">
             <a:avLst/>
@@ -5169,28 +5080,26 @@
           <a:p>
             <a:pPr algn="l"/>
             <a:r>
-              <a:rPr sz="1100" b="0" i="0">
+              <a:rPr sz="1000" b="0" i="0">
                 <a:solidFill>
                   <a:srgbClr val="1A1A1A"/>
                 </a:solidFill>
               </a:rPr>
-              <a:t>Vous passez votre
-certification FIM
-et construisez votre plan.</a:t>
-            </a:r>
-          </a:p>
-        </p:txBody>
-      </p:sp>
-      <p:sp>
-        <p:nvSpPr>
-          <p:cNvPr id="40" name="Rectangle 39"/>
+              <a:t>Simulations d'appels complets · Grille 24 critères · Quiz 40 questions · Remise des certifications</a:t>
+            </a:r>
+          </a:p>
+        </p:txBody>
+      </p:sp>
+      <p:sp>
+        <p:nvSpPr>
+          <p:cNvPr id="41" name="Rectangle 40"/>
           <p:cNvSpPr/>
           <p:nvPr/>
         </p:nvSpPr>
         <p:spPr>
           <a:xfrm>
             <a:off x="274320" y="5532120"/>
-            <a:ext cx="11640312" cy="384048"/>
+            <a:ext cx="11640312" cy="347472"/>
           </a:xfrm>
           <a:prstGeom prst="rect">
             <a:avLst/>
@@ -5226,14 +5135,14 @@
       </p:sp>
       <p:sp>
         <p:nvSpPr>
-          <p:cNvPr id="41" name="TextBox 40"/>
+          <p:cNvPr id="42" name="TextBox 41"/>
           <p:cNvSpPr txBox="1"/>
           <p:nvPr/>
         </p:nvSpPr>
         <p:spPr>
           <a:xfrm>
             <a:off x="411479" y="5605272"/>
-            <a:ext cx="11365992" cy="237744"/>
+            <a:ext cx="11365992" cy="201168"/>
           </a:xfrm>
           <a:prstGeom prst="rect">
             <a:avLst/>
@@ -5253,7 +5162,7 @@
                   <a:srgbClr val="FFFFFF"/>
                 </a:solidFill>
               </a:rPr>
-              <a:t>35 heures de formation intensive + une journée terrain encadrée — Ratio pratique : 65%  ·  Théorie : 35%</a:t>
+              <a:t>35 heures de formation intensive · Organisation journée production : 9h30–17h30 · 6h40 de production effective</a:t>
             </a:r>
           </a:p>
         </p:txBody>
@@ -5328,7 +5237,7 @@
         <p:spPr>
           <a:xfrm>
             <a:off x="0" y="0"/>
-            <a:ext cx="12188952" cy="658368"/>
+            <a:ext cx="12188952" cy="685800"/>
           </a:xfrm>
           <a:prstGeom prst="rect">
             <a:avLst/>
@@ -5370,14 +5279,14 @@
         </p:nvSpPr>
         <p:spPr>
           <a:xfrm>
-            <a:off x="0" y="640080"/>
-            <a:ext cx="12188952" cy="54864"/>
+            <a:off x="0" y="667512"/>
+            <a:ext cx="12188952" cy="45720"/>
           </a:xfrm>
           <a:prstGeom prst="rect">
             <a:avLst/>
           </a:prstGeom>
           <a:solidFill>
-            <a:srgbClr val="FF0000"/>
+            <a:srgbClr val="00AAAA"/>
           </a:solidFill>
           <a:ln>
             <a:noFill/>
@@ -5413,8 +5322,8 @@
         </p:nvSpPr>
         <p:spPr>
           <a:xfrm>
-            <a:off x="164592" y="64008"/>
-            <a:ext cx="685800" cy="530352"/>
+            <a:off x="164592" y="73152"/>
+            <a:ext cx="2011680" cy="347472"/>
           </a:xfrm>
           <a:prstGeom prst="rect">
             <a:avLst/>
@@ -5429,12 +5338,12 @@
           <a:p>
             <a:pPr algn="l"/>
             <a:r>
-              <a:rPr sz="2000" b="1" i="0">
+              <a:rPr sz="1400" b="1" i="0">
                 <a:solidFill>
                   <a:srgbClr val="FFFFFF"/>
                 </a:solidFill>
               </a:rPr>
-              <a:t>SHY</a:t>
+              <a:t>SHY-Performance</a:t>
             </a:r>
           </a:p>
         </p:txBody>
@@ -5447,14 +5356,14 @@
         </p:nvSpPr>
         <p:spPr>
           <a:xfrm>
-            <a:off x="914400" y="91440"/>
-            <a:ext cx="36576" cy="475488"/>
+            <a:off x="2286000" y="91440"/>
+            <a:ext cx="36576" cy="502920"/>
           </a:xfrm>
           <a:prstGeom prst="rect">
             <a:avLst/>
           </a:prstGeom>
           <a:solidFill>
-            <a:srgbClr val="FF0000"/>
+            <a:srgbClr val="00AAAA"/>
           </a:solidFill>
           <a:ln>
             <a:noFill/>
@@ -5490,8 +5399,8 @@
         </p:nvSpPr>
         <p:spPr>
           <a:xfrm>
-            <a:off x="1024128" y="91440"/>
-            <a:ext cx="10881360" cy="475488"/>
+            <a:off x="2423160" y="91440"/>
+            <a:ext cx="9235440" cy="502920"/>
           </a:xfrm>
           <a:prstGeom prst="rect">
             <a:avLst/>
@@ -5506,19 +5415,43 @@
           <a:p>
             <a:pPr algn="l"/>
             <a:r>
-              <a:rPr sz="1700" b="1" i="0">
+              <a:rPr sz="1600" b="1" i="0">
                 <a:solidFill>
                   <a:srgbClr val="FFFFFF"/>
                 </a:solidFill>
               </a:rPr>
-              <a:t>Votre Contrat d'Engagement — Ce que vous vous engagez à faire</a:t>
-            </a:r>
-          </a:p>
-        </p:txBody>
-      </p:sp>
-      <p:sp>
-        <p:nvSpPr>
-          <p:cNvPr id="8" name="Rectangle 7"/>
+              <a:t>Votre Contrat d'Engagement</a:t>
+            </a:r>
+          </a:p>
+        </p:txBody>
+      </p:sp>
+      <p:pic>
+        <p:nvPicPr>
+          <p:cNvPr id="8" name="Picture 7" descr="shy_logo_v2.png"/>
+          <p:cNvPicPr>
+            <a:picLocks noChangeAspect="1"/>
+          </p:cNvPicPr>
+          <p:nvPr/>
+        </p:nvPicPr>
+        <p:blipFill>
+          <a:blip r:embed="rId2"/>
+          <a:stretch>
+            <a:fillRect/>
+          </a:stretch>
+        </p:blipFill>
+        <p:spPr>
+          <a:xfrm>
+            <a:off x="11247120" y="0"/>
+            <a:ext cx="822960" cy="676656"/>
+          </a:xfrm>
+          <a:prstGeom prst="rect">
+            <a:avLst/>
+          </a:prstGeom>
+        </p:spPr>
+      </p:pic>
+      <p:sp>
+        <p:nvSpPr>
+          <p:cNvPr id="9" name="Rectangle 8"/>
           <p:cNvSpPr/>
           <p:nvPr/>
         </p:nvSpPr>
@@ -5561,7 +5494,7 @@
       </p:sp>
       <p:sp>
         <p:nvSpPr>
-          <p:cNvPr id="9" name="TextBox 8"/>
+          <p:cNvPr id="10" name="TextBox 9"/>
           <p:cNvSpPr txBox="1"/>
           <p:nvPr/>
         </p:nvSpPr>
@@ -5583,26 +5516,26 @@
           <a:p>
             <a:pPr algn="ctr"/>
             <a:r>
-              <a:rPr sz="900" b="0" i="0">
+              <a:rPr sz="800" b="0" i="0">
                 <a:solidFill>
                   <a:srgbClr val="FFFFFF"/>
                 </a:solidFill>
               </a:rPr>
-              <a:t>SHY-Performance  ·  Formation FIM  ·  V6-01062026SHY-TE</a:t>
-            </a:r>
-          </a:p>
-        </p:txBody>
-      </p:sp>
-      <p:sp>
-        <p:nvSpPr>
-          <p:cNvPr id="10" name="Rectangle 9"/>
+              <a:t>SHY-Performance  ·  Formation FIM  ·  UNICEF France  ·  V6-01062026SHY-TE</a:t>
+            </a:r>
+          </a:p>
+        </p:txBody>
+      </p:sp>
+      <p:sp>
+        <p:nvSpPr>
+          <p:cNvPr id="11" name="Rectangle 10"/>
           <p:cNvSpPr/>
           <p:nvPr/>
         </p:nvSpPr>
         <p:spPr>
           <a:xfrm>
-            <a:off x="274320" y="822960"/>
-            <a:ext cx="5669280" cy="329184"/>
+            <a:off x="274320" y="804672"/>
+            <a:ext cx="5650992" cy="329184"/>
           </a:xfrm>
           <a:prstGeom prst="rect">
             <a:avLst/>
@@ -5638,14 +5571,14 @@
       </p:sp>
       <p:sp>
         <p:nvSpPr>
-          <p:cNvPr id="11" name="TextBox 10"/>
+          <p:cNvPr id="12" name="TextBox 11"/>
           <p:cNvSpPr txBox="1"/>
           <p:nvPr/>
         </p:nvSpPr>
         <p:spPr>
           <a:xfrm>
-            <a:off x="384048" y="868680"/>
-            <a:ext cx="5486400" cy="256032"/>
+            <a:off x="384048" y="850392"/>
+            <a:ext cx="5468112" cy="256032"/>
           </a:xfrm>
           <a:prstGeom prst="rect">
             <a:avLst/>
@@ -5660,7 +5593,7 @@
           <a:p>
             <a:pPr algn="l"/>
             <a:r>
-              <a:rPr sz="1100" b="1" i="0">
+              <a:rPr sz="1000" b="1" i="0">
                 <a:solidFill>
                   <a:srgbClr val="FFFFFF"/>
                 </a:solidFill>
@@ -5672,23 +5605,25 @@
       </p:sp>
       <p:sp>
         <p:nvSpPr>
-          <p:cNvPr id="12" name="Rectangle 11"/>
+          <p:cNvPr id="13" name="Rectangle 12"/>
           <p:cNvSpPr/>
           <p:nvPr/>
         </p:nvSpPr>
         <p:spPr>
           <a:xfrm>
-            <a:off x="6355080" y="822960"/>
-            <a:ext cx="5669280" cy="329184"/>
+            <a:off x="274320" y="1152144"/>
+            <a:ext cx="5650992" cy="402336"/>
           </a:xfrm>
           <a:prstGeom prst="rect">
             <a:avLst/>
           </a:prstGeom>
           <a:solidFill>
-            <a:srgbClr val="008080"/>
+            <a:srgbClr val="FFFFFF"/>
           </a:solidFill>
-          <a:ln>
-            <a:noFill/>
+          <a:ln w="5080">
+            <a:solidFill>
+              <a:srgbClr val="008080"/>
+            </a:solidFill>
           </a:ln>
         </p:spPr>
         <p:style>
@@ -5715,14 +5650,14 @@
       </p:sp>
       <p:sp>
         <p:nvSpPr>
-          <p:cNvPr id="13" name="TextBox 12"/>
+          <p:cNvPr id="14" name="TextBox 13"/>
           <p:cNvSpPr txBox="1"/>
           <p:nvPr/>
         </p:nvSpPr>
         <p:spPr>
           <a:xfrm>
-            <a:off x="6464808" y="868680"/>
-            <a:ext cx="5486400" cy="256032"/>
+            <a:off x="402336" y="1207008"/>
+            <a:ext cx="5431536" cy="310896"/>
           </a:xfrm>
           <a:prstGeom prst="rect">
             <a:avLst/>
@@ -5737,26 +5672,26 @@
           <a:p>
             <a:pPr algn="l"/>
             <a:r>
-              <a:rPr sz="1100" b="1" i="0">
+              <a:rPr sz="1000" b="0" i="0">
                 <a:solidFill>
-                  <a:srgbClr val="FFFFFF"/>
+                  <a:srgbClr val="1A1A1A"/>
                 </a:solidFill>
               </a:rPr>
-              <a:t>Ce que SHY-Performance s'engage à vous offrir</a:t>
-            </a:r>
-          </a:p>
-        </p:txBody>
-      </p:sp>
-      <p:sp>
-        <p:nvSpPr>
-          <p:cNvPr id="14" name="Rectangle 13"/>
+              <a:t>• Participer activement à toutes les mises en situation</a:t>
+            </a:r>
+          </a:p>
+        </p:txBody>
+      </p:sp>
+      <p:sp>
+        <p:nvSpPr>
+          <p:cNvPr id="15" name="Rectangle 14"/>
           <p:cNvSpPr/>
           <p:nvPr/>
         </p:nvSpPr>
         <p:spPr>
           <a:xfrm>
-            <a:off x="274320" y="1207008"/>
-            <a:ext cx="5669280" cy="402336"/>
+            <a:off x="274320" y="1572768"/>
+            <a:ext cx="5650992" cy="402336"/>
           </a:xfrm>
           <a:prstGeom prst="rect">
             <a:avLst/>
@@ -5794,14 +5729,14 @@
       </p:sp>
       <p:sp>
         <p:nvSpPr>
-          <p:cNvPr id="15" name="TextBox 14"/>
+          <p:cNvPr id="16" name="TextBox 15"/>
           <p:cNvSpPr txBox="1"/>
           <p:nvPr/>
         </p:nvSpPr>
         <p:spPr>
           <a:xfrm>
-            <a:off x="402336" y="1261872"/>
-            <a:ext cx="5440680" cy="329184"/>
+            <a:off x="402336" y="1627632"/>
+            <a:ext cx="5431536" cy="310896"/>
           </a:xfrm>
           <a:prstGeom prst="rect">
             <a:avLst/>
@@ -5821,21 +5756,100 @@
                   <a:srgbClr val="1A1A1A"/>
                 </a:solidFill>
               </a:rPr>
-              <a:t>• Participer activement à toutes les mises en situation</a:t>
-            </a:r>
-          </a:p>
-        </p:txBody>
-      </p:sp>
-      <p:sp>
-        <p:nvSpPr>
-          <p:cNvPr id="16" name="Rectangle 15"/>
+              <a:t>• Compléter votre livret personnel chaque soir (5 min)</a:t>
+            </a:r>
+          </a:p>
+        </p:txBody>
+      </p:sp>
+      <p:sp>
+        <p:nvSpPr>
+          <p:cNvPr id="17" name="Rectangle 16"/>
           <p:cNvSpPr/>
           <p:nvPr/>
         </p:nvSpPr>
         <p:spPr>
           <a:xfrm>
-            <a:off x="274320" y="1627632"/>
-            <a:ext cx="5669280" cy="402336"/>
+            <a:off x="274320" y="1993392"/>
+            <a:ext cx="5650992" cy="402336"/>
+          </a:xfrm>
+          <a:prstGeom prst="rect">
+            <a:avLst/>
+          </a:prstGeom>
+          <a:solidFill>
+            <a:srgbClr val="FFFFFF"/>
+          </a:solidFill>
+          <a:ln w="5080">
+            <a:solidFill>
+              <a:srgbClr val="008080"/>
+            </a:solidFill>
+          </a:ln>
+        </p:spPr>
+        <p:style>
+          <a:lnRef idx="1">
+            <a:schemeClr val="accent1"/>
+          </a:lnRef>
+          <a:fillRef idx="3">
+            <a:schemeClr val="accent1"/>
+          </a:fillRef>
+          <a:effectRef idx="2">
+            <a:schemeClr val="accent1"/>
+          </a:effectRef>
+          <a:fontRef idx="minor">
+            <a:schemeClr val="lt1"/>
+          </a:fontRef>
+        </p:style>
+        <p:txBody>
+          <a:bodyPr rtlCol="0" anchor="ctr"/>
+          <a:lstStyle/>
+          <a:p>
+            <a:pPr algn="ctr"/>
+          </a:p>
+        </p:txBody>
+      </p:sp>
+      <p:sp>
+        <p:nvSpPr>
+          <p:cNvPr id="18" name="TextBox 17"/>
+          <p:cNvSpPr txBox="1"/>
+          <p:nvPr/>
+        </p:nvSpPr>
+        <p:spPr>
+          <a:xfrm>
+            <a:off x="402336" y="2048256"/>
+            <a:ext cx="5431536" cy="310896"/>
+          </a:xfrm>
+          <a:prstGeom prst="rect">
+            <a:avLst/>
+          </a:prstGeom>
+          <a:noFill/>
+        </p:spPr>
+        <p:txBody>
+          <a:bodyPr wrap="square">
+            <a:spAutoFit/>
+          </a:bodyPr>
+          <a:lstStyle/>
+          <a:p>
+            <a:pPr algn="l"/>
+            <a:r>
+              <a:rPr sz="1000" b="0" i="0">
+                <a:solidFill>
+                  <a:srgbClr val="1A1A1A"/>
+                </a:solidFill>
+              </a:rPr>
+              <a:t>• Demander un feedback précis après chaque exercice</a:t>
+            </a:r>
+          </a:p>
+        </p:txBody>
+      </p:sp>
+      <p:sp>
+        <p:nvSpPr>
+          <p:cNvPr id="19" name="Rectangle 18"/>
+          <p:cNvSpPr/>
+          <p:nvPr/>
+        </p:nvSpPr>
+        <p:spPr>
+          <a:xfrm>
+            <a:off x="274320" y="2414016"/>
+            <a:ext cx="5650992" cy="402336"/>
           </a:xfrm>
           <a:prstGeom prst="rect">
             <a:avLst/>
@@ -5873,14 +5887,14 @@
       </p:sp>
       <p:sp>
         <p:nvSpPr>
-          <p:cNvPr id="17" name="TextBox 16"/>
+          <p:cNvPr id="20" name="TextBox 19"/>
           <p:cNvSpPr txBox="1"/>
           <p:nvPr/>
         </p:nvSpPr>
         <p:spPr>
           <a:xfrm>
-            <a:off x="402336" y="1682496"/>
-            <a:ext cx="5440680" cy="329184"/>
+            <a:off x="402336" y="2468880"/>
+            <a:ext cx="5431536" cy="310896"/>
           </a:xfrm>
           <a:prstGeom prst="rect">
             <a:avLst/>
@@ -5900,21 +5914,256 @@
                   <a:srgbClr val="1A1A1A"/>
                 </a:solidFill>
               </a:rPr>
-              <a:t>• Compléter votre livret personnel chaque soir (5 min)</a:t>
-            </a:r>
-          </a:p>
-        </p:txBody>
-      </p:sp>
-      <p:sp>
-        <p:nvSpPr>
-          <p:cNvPr id="18" name="Rectangle 17"/>
+              <a:t>• Respecter la confidentialité des échanges du groupe</a:t>
+            </a:r>
+          </a:p>
+        </p:txBody>
+      </p:sp>
+      <p:sp>
+        <p:nvSpPr>
+          <p:cNvPr id="21" name="Rectangle 20"/>
           <p:cNvSpPr/>
           <p:nvPr/>
         </p:nvSpPr>
         <p:spPr>
           <a:xfrm>
-            <a:off x="274320" y="2048256"/>
-            <a:ext cx="5669280" cy="402336"/>
+            <a:off x="274320" y="2834640"/>
+            <a:ext cx="5650992" cy="402336"/>
+          </a:xfrm>
+          <a:prstGeom prst="rect">
+            <a:avLst/>
+          </a:prstGeom>
+          <a:solidFill>
+            <a:srgbClr val="FFFFFF"/>
+          </a:solidFill>
+          <a:ln w="5080">
+            <a:solidFill>
+              <a:srgbClr val="008080"/>
+            </a:solidFill>
+          </a:ln>
+        </p:spPr>
+        <p:style>
+          <a:lnRef idx="1">
+            <a:schemeClr val="accent1"/>
+          </a:lnRef>
+          <a:fillRef idx="3">
+            <a:schemeClr val="accent1"/>
+          </a:fillRef>
+          <a:effectRef idx="2">
+            <a:schemeClr val="accent1"/>
+          </a:effectRef>
+          <a:fontRef idx="minor">
+            <a:schemeClr val="lt1"/>
+          </a:fontRef>
+        </p:style>
+        <p:txBody>
+          <a:bodyPr rtlCol="0" anchor="ctr"/>
+          <a:lstStyle/>
+          <a:p>
+            <a:pPr algn="ctr"/>
+          </a:p>
+        </p:txBody>
+      </p:sp>
+      <p:sp>
+        <p:nvSpPr>
+          <p:cNvPr id="22" name="TextBox 21"/>
+          <p:cNvSpPr txBox="1"/>
+          <p:nvPr/>
+        </p:nvSpPr>
+        <p:spPr>
+          <a:xfrm>
+            <a:off x="402336" y="2889504"/>
+            <a:ext cx="5431536" cy="310896"/>
+          </a:xfrm>
+          <a:prstGeom prst="rect">
+            <a:avLst/>
+          </a:prstGeom>
+          <a:noFill/>
+        </p:spPr>
+        <p:txBody>
+          <a:bodyPr wrap="square">
+            <a:spAutoFit/>
+          </a:bodyPr>
+          <a:lstStyle/>
+          <a:p>
+            <a:pPr algn="l"/>
+            <a:r>
+              <a:rPr sz="1000" b="0" i="0">
+                <a:solidFill>
+                  <a:srgbClr val="1A1A1A"/>
+                </a:solidFill>
+              </a:rPr>
+              <a:t>• Arriver à l'heure — le groupe démarre ensemble</a:t>
+            </a:r>
+          </a:p>
+        </p:txBody>
+      </p:sp>
+      <p:sp>
+        <p:nvSpPr>
+          <p:cNvPr id="23" name="Rectangle 22"/>
+          <p:cNvSpPr/>
+          <p:nvPr/>
+        </p:nvSpPr>
+        <p:spPr>
+          <a:xfrm>
+            <a:off x="6245352" y="804672"/>
+            <a:ext cx="5650992" cy="329184"/>
+          </a:xfrm>
+          <a:prstGeom prst="rect">
+            <a:avLst/>
+          </a:prstGeom>
+          <a:solidFill>
+            <a:srgbClr val="008080"/>
+          </a:solidFill>
+          <a:ln>
+            <a:noFill/>
+          </a:ln>
+        </p:spPr>
+        <p:style>
+          <a:lnRef idx="1">
+            <a:schemeClr val="accent1"/>
+          </a:lnRef>
+          <a:fillRef idx="3">
+            <a:schemeClr val="accent1"/>
+          </a:fillRef>
+          <a:effectRef idx="2">
+            <a:schemeClr val="accent1"/>
+          </a:effectRef>
+          <a:fontRef idx="minor">
+            <a:schemeClr val="lt1"/>
+          </a:fontRef>
+        </p:style>
+        <p:txBody>
+          <a:bodyPr rtlCol="0" anchor="ctr"/>
+          <a:lstStyle/>
+          <a:p>
+            <a:pPr algn="ctr"/>
+          </a:p>
+        </p:txBody>
+      </p:sp>
+      <p:sp>
+        <p:nvSpPr>
+          <p:cNvPr id="24" name="TextBox 23"/>
+          <p:cNvSpPr txBox="1"/>
+          <p:nvPr/>
+        </p:nvSpPr>
+        <p:spPr>
+          <a:xfrm>
+            <a:off x="6355080" y="850392"/>
+            <a:ext cx="5468112" cy="256032"/>
+          </a:xfrm>
+          <a:prstGeom prst="rect">
+            <a:avLst/>
+          </a:prstGeom>
+          <a:noFill/>
+        </p:spPr>
+        <p:txBody>
+          <a:bodyPr wrap="square">
+            <a:spAutoFit/>
+          </a:bodyPr>
+          <a:lstStyle/>
+          <a:p>
+            <a:pPr algn="l"/>
+            <a:r>
+              <a:rPr sz="1000" b="1" i="0">
+                <a:solidFill>
+                  <a:srgbClr val="FFFFFF"/>
+                </a:solidFill>
+              </a:rPr>
+              <a:t>Ce que SHY-Performance s'engage à vous offrir</a:t>
+            </a:r>
+          </a:p>
+        </p:txBody>
+      </p:sp>
+      <p:sp>
+        <p:nvSpPr>
+          <p:cNvPr id="25" name="Rectangle 24"/>
+          <p:cNvSpPr/>
+          <p:nvPr/>
+        </p:nvSpPr>
+        <p:spPr>
+          <a:xfrm>
+            <a:off x="6245352" y="1152144"/>
+            <a:ext cx="5650992" cy="402336"/>
+          </a:xfrm>
+          <a:prstGeom prst="rect">
+            <a:avLst/>
+          </a:prstGeom>
+          <a:solidFill>
+            <a:srgbClr val="FFFFFF"/>
+          </a:solidFill>
+          <a:ln w="5080">
+            <a:solidFill>
+              <a:srgbClr val="008080"/>
+            </a:solidFill>
+          </a:ln>
+        </p:spPr>
+        <p:style>
+          <a:lnRef idx="1">
+            <a:schemeClr val="accent1"/>
+          </a:lnRef>
+          <a:fillRef idx="3">
+            <a:schemeClr val="accent1"/>
+          </a:fillRef>
+          <a:effectRef idx="2">
+            <a:schemeClr val="accent1"/>
+          </a:effectRef>
+          <a:fontRef idx="minor">
+            <a:schemeClr val="lt1"/>
+          </a:fontRef>
+        </p:style>
+        <p:txBody>
+          <a:bodyPr rtlCol="0" anchor="ctr"/>
+          <a:lstStyle/>
+          <a:p>
+            <a:pPr algn="ctr"/>
+          </a:p>
+        </p:txBody>
+      </p:sp>
+      <p:sp>
+        <p:nvSpPr>
+          <p:cNvPr id="26" name="TextBox 25"/>
+          <p:cNvSpPr txBox="1"/>
+          <p:nvPr/>
+        </p:nvSpPr>
+        <p:spPr>
+          <a:xfrm>
+            <a:off x="6373368" y="1207008"/>
+            <a:ext cx="5431536" cy="310896"/>
+          </a:xfrm>
+          <a:prstGeom prst="rect">
+            <a:avLst/>
+          </a:prstGeom>
+          <a:noFill/>
+        </p:spPr>
+        <p:txBody>
+          <a:bodyPr wrap="square">
+            <a:spAutoFit/>
+          </a:bodyPr>
+          <a:lstStyle/>
+          <a:p>
+            <a:pPr algn="l"/>
+            <a:r>
+              <a:rPr sz="1000" b="0" i="0">
+                <a:solidFill>
+                  <a:srgbClr val="1A1A1A"/>
+                </a:solidFill>
+              </a:rPr>
+              <a:t>• Un feedback individuel personnalisé chaque jour</a:t>
+            </a:r>
+          </a:p>
+        </p:txBody>
+      </p:sp>
+      <p:sp>
+        <p:nvSpPr>
+          <p:cNvPr id="27" name="Rectangle 26"/>
+          <p:cNvSpPr/>
+          <p:nvPr/>
+        </p:nvSpPr>
+        <p:spPr>
+          <a:xfrm>
+            <a:off x="6245352" y="1572768"/>
+            <a:ext cx="5650992" cy="402336"/>
           </a:xfrm>
           <a:prstGeom prst="rect">
             <a:avLst/>
@@ -5952,14 +6201,14 @@
       </p:sp>
       <p:sp>
         <p:nvSpPr>
-          <p:cNvPr id="19" name="TextBox 18"/>
+          <p:cNvPr id="28" name="TextBox 27"/>
           <p:cNvSpPr txBox="1"/>
           <p:nvPr/>
         </p:nvSpPr>
         <p:spPr>
           <a:xfrm>
-            <a:off x="402336" y="2103120"/>
-            <a:ext cx="5440680" cy="329184"/>
+            <a:off x="6373368" y="1627632"/>
+            <a:ext cx="5431536" cy="310896"/>
           </a:xfrm>
           <a:prstGeom prst="rect">
             <a:avLst/>
@@ -5979,21 +6228,100 @@
                   <a:srgbClr val="1A1A1A"/>
                 </a:solidFill>
               </a:rPr>
-              <a:t>• Demander du feedback précis après chaque exercice</a:t>
-            </a:r>
-          </a:p>
-        </p:txBody>
-      </p:sp>
-      <p:sp>
-        <p:nvSpPr>
-          <p:cNvPr id="20" name="Rectangle 19"/>
+              <a:t>• Des exercices pratiques progressifs et bienveillants</a:t>
+            </a:r>
+          </a:p>
+        </p:txBody>
+      </p:sp>
+      <p:sp>
+        <p:nvSpPr>
+          <p:cNvPr id="29" name="Rectangle 28"/>
           <p:cNvSpPr/>
           <p:nvPr/>
         </p:nvSpPr>
         <p:spPr>
           <a:xfrm>
-            <a:off x="274320" y="2468880"/>
-            <a:ext cx="5669280" cy="402336"/>
+            <a:off x="6245352" y="1993392"/>
+            <a:ext cx="5650992" cy="402336"/>
+          </a:xfrm>
+          <a:prstGeom prst="rect">
+            <a:avLst/>
+          </a:prstGeom>
+          <a:solidFill>
+            <a:srgbClr val="FFFFFF"/>
+          </a:solidFill>
+          <a:ln w="5080">
+            <a:solidFill>
+              <a:srgbClr val="008080"/>
+            </a:solidFill>
+          </a:ln>
+        </p:spPr>
+        <p:style>
+          <a:lnRef idx="1">
+            <a:schemeClr val="accent1"/>
+          </a:lnRef>
+          <a:fillRef idx="3">
+            <a:schemeClr val="accent1"/>
+          </a:fillRef>
+          <a:effectRef idx="2">
+            <a:schemeClr val="accent1"/>
+          </a:effectRef>
+          <a:fontRef idx="minor">
+            <a:schemeClr val="lt1"/>
+          </a:fontRef>
+        </p:style>
+        <p:txBody>
+          <a:bodyPr rtlCol="0" anchor="ctr"/>
+          <a:lstStyle/>
+          <a:p>
+            <a:pPr algn="ctr"/>
+          </a:p>
+        </p:txBody>
+      </p:sp>
+      <p:sp>
+        <p:nvSpPr>
+          <p:cNvPr id="30" name="TextBox 29"/>
+          <p:cNvSpPr txBox="1"/>
+          <p:nvPr/>
+        </p:nvSpPr>
+        <p:spPr>
+          <a:xfrm>
+            <a:off x="6373368" y="2048256"/>
+            <a:ext cx="5431536" cy="310896"/>
+          </a:xfrm>
+          <a:prstGeom prst="rect">
+            <a:avLst/>
+          </a:prstGeom>
+          <a:noFill/>
+        </p:spPr>
+        <p:txBody>
+          <a:bodyPr wrap="square">
+            <a:spAutoFit/>
+          </a:bodyPr>
+          <a:lstStyle/>
+          <a:p>
+            <a:pPr algn="l"/>
+            <a:r>
+              <a:rPr sz="1000" b="0" i="0">
+                <a:solidFill>
+                  <a:srgbClr val="1A1A1A"/>
+                </a:solidFill>
+              </a:rPr>
+              <a:t>• Un formateur qui adapte le rythme à votre profil</a:t>
+            </a:r>
+          </a:p>
+        </p:txBody>
+      </p:sp>
+      <p:sp>
+        <p:nvSpPr>
+          <p:cNvPr id="31" name="Rectangle 30"/>
+          <p:cNvSpPr/>
+          <p:nvPr/>
+        </p:nvSpPr>
+        <p:spPr>
+          <a:xfrm>
+            <a:off x="6245352" y="2414016"/>
+            <a:ext cx="5650992" cy="402336"/>
           </a:xfrm>
           <a:prstGeom prst="rect">
             <a:avLst/>
@@ -6031,14 +6359,14 @@
       </p:sp>
       <p:sp>
         <p:nvSpPr>
-          <p:cNvPr id="21" name="TextBox 20"/>
+          <p:cNvPr id="32" name="TextBox 31"/>
           <p:cNvSpPr txBox="1"/>
           <p:nvPr/>
         </p:nvSpPr>
         <p:spPr>
           <a:xfrm>
-            <a:off x="402336" y="2523744"/>
-            <a:ext cx="5440680" cy="329184"/>
+            <a:off x="6373368" y="2468880"/>
+            <a:ext cx="5431536" cy="310896"/>
           </a:xfrm>
           <a:prstGeom prst="rect">
             <a:avLst/>
@@ -6058,27 +6386,27 @@
                   <a:srgbClr val="1A1A1A"/>
                 </a:solidFill>
               </a:rPr>
-              <a:t>• Respecter la confidentialité des échanges du groupe</a:t>
-            </a:r>
-          </a:p>
-        </p:txBody>
-      </p:sp>
-      <p:sp>
-        <p:nvSpPr>
-          <p:cNvPr id="22" name="Rectangle 21"/>
+              <a:t>• Un suivi après la formation à J+15 et J+30</a:t>
+            </a:r>
+          </a:p>
+        </p:txBody>
+      </p:sp>
+      <p:sp>
+        <p:nvSpPr>
+          <p:cNvPr id="33" name="Rectangle 32"/>
           <p:cNvSpPr/>
           <p:nvPr/>
         </p:nvSpPr>
         <p:spPr>
           <a:xfrm>
-            <a:off x="274320" y="2889504"/>
-            <a:ext cx="5669280" cy="402336"/>
+            <a:off x="6245352" y="2834640"/>
+            <a:ext cx="5650992" cy="402336"/>
           </a:xfrm>
           <a:prstGeom prst="rect">
             <a:avLst/>
           </a:prstGeom>
           <a:solidFill>
-            <a:srgbClr val="F0F7F7"/>
+            <a:srgbClr val="FFFFFF"/>
           </a:solidFill>
           <a:ln w="5080">
             <a:solidFill>
@@ -6110,14 +6438,14 @@
       </p:sp>
       <p:sp>
         <p:nvSpPr>
-          <p:cNvPr id="23" name="TextBox 22"/>
+          <p:cNvPr id="34" name="TextBox 33"/>
           <p:cNvSpPr txBox="1"/>
           <p:nvPr/>
         </p:nvSpPr>
         <p:spPr>
           <a:xfrm>
-            <a:off x="402336" y="2944368"/>
-            <a:ext cx="5440680" cy="329184"/>
+            <a:off x="6373368" y="2889504"/>
+            <a:ext cx="5431536" cy="310896"/>
           </a:xfrm>
           <a:prstGeom prst="rect">
             <a:avLst/>
@@ -6137,32 +6465,30 @@
                   <a:srgbClr val="1A1A1A"/>
                 </a:solidFill>
               </a:rPr>
-              <a:t>• Arriver à l'heure — le groupe démarre ensemble</a:t>
-            </a:r>
-          </a:p>
-        </p:txBody>
-      </p:sp>
-      <p:sp>
-        <p:nvSpPr>
-          <p:cNvPr id="24" name="Rectangle 23"/>
+              <a:t>• Une certification reconnue FIDELIS × UNICEF France</a:t>
+            </a:r>
+          </a:p>
+        </p:txBody>
+      </p:sp>
+      <p:sp>
+        <p:nvSpPr>
+          <p:cNvPr id="35" name="Rectangle 34"/>
           <p:cNvSpPr/>
           <p:nvPr/>
         </p:nvSpPr>
         <p:spPr>
           <a:xfrm>
-            <a:off x="6355080" y="1207008"/>
-            <a:ext cx="5669280" cy="402336"/>
+            <a:off x="274320" y="5504688"/>
+            <a:ext cx="11640312" cy="402336"/>
           </a:xfrm>
           <a:prstGeom prst="rect">
             <a:avLst/>
           </a:prstGeom>
           <a:solidFill>
-            <a:srgbClr val="F0F7F7"/>
+            <a:srgbClr val="008080"/>
           </a:solidFill>
-          <a:ln w="5080">
-            <a:solidFill>
-              <a:srgbClr val="008080"/>
-            </a:solidFill>
+          <a:ln>
+            <a:noFill/>
           </a:ln>
         </p:spPr>
         <p:style>
@@ -6189,400 +6515,7 @@
       </p:sp>
       <p:sp>
         <p:nvSpPr>
-          <p:cNvPr id="25" name="TextBox 24"/>
-          <p:cNvSpPr txBox="1"/>
-          <p:nvPr/>
-        </p:nvSpPr>
-        <p:spPr>
-          <a:xfrm>
-            <a:off x="6483096" y="1261872"/>
-            <a:ext cx="5440680" cy="329184"/>
-          </a:xfrm>
-          <a:prstGeom prst="rect">
-            <a:avLst/>
-          </a:prstGeom>
-          <a:noFill/>
-        </p:spPr>
-        <p:txBody>
-          <a:bodyPr wrap="square">
-            <a:spAutoFit/>
-          </a:bodyPr>
-          <a:lstStyle/>
-          <a:p>
-            <a:pPr algn="l"/>
-            <a:r>
-              <a:rPr sz="1000" b="0" i="0">
-                <a:solidFill>
-                  <a:srgbClr val="1A1A1A"/>
-                </a:solidFill>
-              </a:rPr>
-              <a:t>• Un feedback individuel personnalisé chaque jour</a:t>
-            </a:r>
-          </a:p>
-        </p:txBody>
-      </p:sp>
-      <p:sp>
-        <p:nvSpPr>
-          <p:cNvPr id="26" name="Rectangle 25"/>
-          <p:cNvSpPr/>
-          <p:nvPr/>
-        </p:nvSpPr>
-        <p:spPr>
-          <a:xfrm>
-            <a:off x="6355080" y="1627632"/>
-            <a:ext cx="5669280" cy="402336"/>
-          </a:xfrm>
-          <a:prstGeom prst="rect">
-            <a:avLst/>
-          </a:prstGeom>
-          <a:solidFill>
-            <a:srgbClr val="F0F7F7"/>
-          </a:solidFill>
-          <a:ln w="5080">
-            <a:solidFill>
-              <a:srgbClr val="008080"/>
-            </a:solidFill>
-          </a:ln>
-        </p:spPr>
-        <p:style>
-          <a:lnRef idx="1">
-            <a:schemeClr val="accent1"/>
-          </a:lnRef>
-          <a:fillRef idx="3">
-            <a:schemeClr val="accent1"/>
-          </a:fillRef>
-          <a:effectRef idx="2">
-            <a:schemeClr val="accent1"/>
-          </a:effectRef>
-          <a:fontRef idx="minor">
-            <a:schemeClr val="lt1"/>
-          </a:fontRef>
-        </p:style>
-        <p:txBody>
-          <a:bodyPr rtlCol="0" anchor="ctr"/>
-          <a:lstStyle/>
-          <a:p>
-            <a:pPr algn="ctr"/>
-          </a:p>
-        </p:txBody>
-      </p:sp>
-      <p:sp>
-        <p:nvSpPr>
-          <p:cNvPr id="27" name="TextBox 26"/>
-          <p:cNvSpPr txBox="1"/>
-          <p:nvPr/>
-        </p:nvSpPr>
-        <p:spPr>
-          <a:xfrm>
-            <a:off x="6483096" y="1682496"/>
-            <a:ext cx="5440680" cy="329184"/>
-          </a:xfrm>
-          <a:prstGeom prst="rect">
-            <a:avLst/>
-          </a:prstGeom>
-          <a:noFill/>
-        </p:spPr>
-        <p:txBody>
-          <a:bodyPr wrap="square">
-            <a:spAutoFit/>
-          </a:bodyPr>
-          <a:lstStyle/>
-          <a:p>
-            <a:pPr algn="l"/>
-            <a:r>
-              <a:rPr sz="1000" b="0" i="0">
-                <a:solidFill>
-                  <a:srgbClr val="1A1A1A"/>
-                </a:solidFill>
-              </a:rPr>
-              <a:t>• Des exercices pratiques progressifs et sécurisants</a:t>
-            </a:r>
-          </a:p>
-        </p:txBody>
-      </p:sp>
-      <p:sp>
-        <p:nvSpPr>
-          <p:cNvPr id="28" name="Rectangle 27"/>
-          <p:cNvSpPr/>
-          <p:nvPr/>
-        </p:nvSpPr>
-        <p:spPr>
-          <a:xfrm>
-            <a:off x="6355080" y="2048256"/>
-            <a:ext cx="5669280" cy="402336"/>
-          </a:xfrm>
-          <a:prstGeom prst="rect">
-            <a:avLst/>
-          </a:prstGeom>
-          <a:solidFill>
-            <a:srgbClr val="F0F7F7"/>
-          </a:solidFill>
-          <a:ln w="5080">
-            <a:solidFill>
-              <a:srgbClr val="008080"/>
-            </a:solidFill>
-          </a:ln>
-        </p:spPr>
-        <p:style>
-          <a:lnRef idx="1">
-            <a:schemeClr val="accent1"/>
-          </a:lnRef>
-          <a:fillRef idx="3">
-            <a:schemeClr val="accent1"/>
-          </a:fillRef>
-          <a:effectRef idx="2">
-            <a:schemeClr val="accent1"/>
-          </a:effectRef>
-          <a:fontRef idx="minor">
-            <a:schemeClr val="lt1"/>
-          </a:fontRef>
-        </p:style>
-        <p:txBody>
-          <a:bodyPr rtlCol="0" anchor="ctr"/>
-          <a:lstStyle/>
-          <a:p>
-            <a:pPr algn="ctr"/>
-          </a:p>
-        </p:txBody>
-      </p:sp>
-      <p:sp>
-        <p:nvSpPr>
-          <p:cNvPr id="29" name="TextBox 28"/>
-          <p:cNvSpPr txBox="1"/>
-          <p:nvPr/>
-        </p:nvSpPr>
-        <p:spPr>
-          <a:xfrm>
-            <a:off x="6483096" y="2103120"/>
-            <a:ext cx="5440680" cy="329184"/>
-          </a:xfrm>
-          <a:prstGeom prst="rect">
-            <a:avLst/>
-          </a:prstGeom>
-          <a:noFill/>
-        </p:spPr>
-        <p:txBody>
-          <a:bodyPr wrap="square">
-            <a:spAutoFit/>
-          </a:bodyPr>
-          <a:lstStyle/>
-          <a:p>
-            <a:pPr algn="l"/>
-            <a:r>
-              <a:rPr sz="1000" b="0" i="0">
-                <a:solidFill>
-                  <a:srgbClr val="1A1A1A"/>
-                </a:solidFill>
-              </a:rPr>
-              <a:t>• Un formateur qui adapte le rythme à votre profil</a:t>
-            </a:r>
-          </a:p>
-        </p:txBody>
-      </p:sp>
-      <p:sp>
-        <p:nvSpPr>
-          <p:cNvPr id="30" name="Rectangle 29"/>
-          <p:cNvSpPr/>
-          <p:nvPr/>
-        </p:nvSpPr>
-        <p:spPr>
-          <a:xfrm>
-            <a:off x="6355080" y="2468880"/>
-            <a:ext cx="5669280" cy="402336"/>
-          </a:xfrm>
-          <a:prstGeom prst="rect">
-            <a:avLst/>
-          </a:prstGeom>
-          <a:solidFill>
-            <a:srgbClr val="F0F7F7"/>
-          </a:solidFill>
-          <a:ln w="5080">
-            <a:solidFill>
-              <a:srgbClr val="008080"/>
-            </a:solidFill>
-          </a:ln>
-        </p:spPr>
-        <p:style>
-          <a:lnRef idx="1">
-            <a:schemeClr val="accent1"/>
-          </a:lnRef>
-          <a:fillRef idx="3">
-            <a:schemeClr val="accent1"/>
-          </a:fillRef>
-          <a:effectRef idx="2">
-            <a:schemeClr val="accent1"/>
-          </a:effectRef>
-          <a:fontRef idx="minor">
-            <a:schemeClr val="lt1"/>
-          </a:fontRef>
-        </p:style>
-        <p:txBody>
-          <a:bodyPr rtlCol="0" anchor="ctr"/>
-          <a:lstStyle/>
-          <a:p>
-            <a:pPr algn="ctr"/>
-          </a:p>
-        </p:txBody>
-      </p:sp>
-      <p:sp>
-        <p:nvSpPr>
-          <p:cNvPr id="31" name="TextBox 30"/>
-          <p:cNvSpPr txBox="1"/>
-          <p:nvPr/>
-        </p:nvSpPr>
-        <p:spPr>
-          <a:xfrm>
-            <a:off x="6483096" y="2523744"/>
-            <a:ext cx="5440680" cy="329184"/>
-          </a:xfrm>
-          <a:prstGeom prst="rect">
-            <a:avLst/>
-          </a:prstGeom>
-          <a:noFill/>
-        </p:spPr>
-        <p:txBody>
-          <a:bodyPr wrap="square">
-            <a:spAutoFit/>
-          </a:bodyPr>
-          <a:lstStyle/>
-          <a:p>
-            <a:pPr algn="l"/>
-            <a:r>
-              <a:rPr sz="1000" b="0" i="0">
-                <a:solidFill>
-                  <a:srgbClr val="1A1A1A"/>
-                </a:solidFill>
-              </a:rPr>
-              <a:t>• Un suivi après la formation à J+15 et J+30</a:t>
-            </a:r>
-          </a:p>
-        </p:txBody>
-      </p:sp>
-      <p:sp>
-        <p:nvSpPr>
-          <p:cNvPr id="32" name="Rectangle 31"/>
-          <p:cNvSpPr/>
-          <p:nvPr/>
-        </p:nvSpPr>
-        <p:spPr>
-          <a:xfrm>
-            <a:off x="6355080" y="2889504"/>
-            <a:ext cx="5669280" cy="402336"/>
-          </a:xfrm>
-          <a:prstGeom prst="rect">
-            <a:avLst/>
-          </a:prstGeom>
-          <a:solidFill>
-            <a:srgbClr val="F0F7F7"/>
-          </a:solidFill>
-          <a:ln w="5080">
-            <a:solidFill>
-              <a:srgbClr val="008080"/>
-            </a:solidFill>
-          </a:ln>
-        </p:spPr>
-        <p:style>
-          <a:lnRef idx="1">
-            <a:schemeClr val="accent1"/>
-          </a:lnRef>
-          <a:fillRef idx="3">
-            <a:schemeClr val="accent1"/>
-          </a:fillRef>
-          <a:effectRef idx="2">
-            <a:schemeClr val="accent1"/>
-          </a:effectRef>
-          <a:fontRef idx="minor">
-            <a:schemeClr val="lt1"/>
-          </a:fontRef>
-        </p:style>
-        <p:txBody>
-          <a:bodyPr rtlCol="0" anchor="ctr"/>
-          <a:lstStyle/>
-          <a:p>
-            <a:pPr algn="ctr"/>
-          </a:p>
-        </p:txBody>
-      </p:sp>
-      <p:sp>
-        <p:nvSpPr>
-          <p:cNvPr id="33" name="TextBox 32"/>
-          <p:cNvSpPr txBox="1"/>
-          <p:nvPr/>
-        </p:nvSpPr>
-        <p:spPr>
-          <a:xfrm>
-            <a:off x="6483096" y="2944368"/>
-            <a:ext cx="5440680" cy="329184"/>
-          </a:xfrm>
-          <a:prstGeom prst="rect">
-            <a:avLst/>
-          </a:prstGeom>
-          <a:noFill/>
-        </p:spPr>
-        <p:txBody>
-          <a:bodyPr wrap="square">
-            <a:spAutoFit/>
-          </a:bodyPr>
-          <a:lstStyle/>
-          <a:p>
-            <a:pPr algn="l"/>
-            <a:r>
-              <a:rPr sz="1000" b="0" i="0">
-                <a:solidFill>
-                  <a:srgbClr val="1A1A1A"/>
-                </a:solidFill>
-              </a:rPr>
-              <a:t>• Une certification reconnue par les partenaires FIM</a:t>
-            </a:r>
-          </a:p>
-        </p:txBody>
-      </p:sp>
-      <p:sp>
-        <p:nvSpPr>
-          <p:cNvPr id="34" name="Rectangle 33"/>
-          <p:cNvSpPr/>
-          <p:nvPr/>
-        </p:nvSpPr>
-        <p:spPr>
-          <a:xfrm>
-            <a:off x="274320" y="5504688"/>
-            <a:ext cx="11640312" cy="402336"/>
-          </a:xfrm>
-          <a:prstGeom prst="rect">
-            <a:avLst/>
-          </a:prstGeom>
-          <a:solidFill>
-            <a:srgbClr val="FF0000"/>
-          </a:solidFill>
-          <a:ln>
-            <a:noFill/>
-          </a:ln>
-        </p:spPr>
-        <p:style>
-          <a:lnRef idx="1">
-            <a:schemeClr val="accent1"/>
-          </a:lnRef>
-          <a:fillRef idx="3">
-            <a:schemeClr val="accent1"/>
-          </a:fillRef>
-          <a:effectRef idx="2">
-            <a:schemeClr val="accent1"/>
-          </a:effectRef>
-          <a:fontRef idx="minor">
-            <a:schemeClr val="lt1"/>
-          </a:fontRef>
-        </p:style>
-        <p:txBody>
-          <a:bodyPr rtlCol="0" anchor="ctr"/>
-          <a:lstStyle/>
-          <a:p>
-            <a:pPr algn="ctr"/>
-          </a:p>
-        </p:txBody>
-      </p:sp>
-      <p:sp>
-        <p:nvSpPr>
-          <p:cNvPr id="35" name="TextBox 34"/>
+          <p:cNvPr id="36" name="TextBox 35"/>
           <p:cNvSpPr txBox="1"/>
           <p:nvPr/>
         </p:nvSpPr>
@@ -6609,7 +6542,7 @@
                   <a:srgbClr val="FFFFFF"/>
                 </a:solidFill>
               </a:rPr>
-              <a:t>Droit à l'erreur garanti — Chaque simulation ratée est un pas vers la maîtrise. Ici, l'erreur n'est pas une faute, c'est une information.</a:t>
+              <a:t>Droit à l'erreur garanti — Chaque simulation ratée est un pas vers la maîtrise. Mantra de la formation : « Le refus d'aujourd'hui peut être le don de demain »</a:t>
             </a:r>
           </a:p>
         </p:txBody>
@@ -6684,7 +6617,7 @@
         <p:spPr>
           <a:xfrm>
             <a:off x="0" y="0"/>
-            <a:ext cx="12188952" cy="658368"/>
+            <a:ext cx="12188952" cy="685800"/>
           </a:xfrm>
           <a:prstGeom prst="rect">
             <a:avLst/>
@@ -6726,14 +6659,14 @@
         </p:nvSpPr>
         <p:spPr>
           <a:xfrm>
-            <a:off x="0" y="640080"/>
-            <a:ext cx="12188952" cy="54864"/>
+            <a:off x="0" y="667512"/>
+            <a:ext cx="12188952" cy="45720"/>
           </a:xfrm>
           <a:prstGeom prst="rect">
             <a:avLst/>
           </a:prstGeom>
           <a:solidFill>
-            <a:srgbClr val="FF0000"/>
+            <a:srgbClr val="00AAAA"/>
           </a:solidFill>
           <a:ln>
             <a:noFill/>
@@ -6769,8 +6702,8 @@
         </p:nvSpPr>
         <p:spPr>
           <a:xfrm>
-            <a:off x="164592" y="64008"/>
-            <a:ext cx="685800" cy="530352"/>
+            <a:off x="164592" y="73152"/>
+            <a:ext cx="2011680" cy="347472"/>
           </a:xfrm>
           <a:prstGeom prst="rect">
             <a:avLst/>
@@ -6785,12 +6718,12 @@
           <a:p>
             <a:pPr algn="l"/>
             <a:r>
-              <a:rPr sz="2000" b="1" i="0">
+              <a:rPr sz="1400" b="1" i="0">
                 <a:solidFill>
                   <a:srgbClr val="FFFFFF"/>
                 </a:solidFill>
               </a:rPr>
-              <a:t>SHY</a:t>
+              <a:t>SHY-Performance</a:t>
             </a:r>
           </a:p>
         </p:txBody>
@@ -6803,14 +6736,14 @@
         </p:nvSpPr>
         <p:spPr>
           <a:xfrm>
-            <a:off x="914400" y="91440"/>
-            <a:ext cx="36576" cy="475488"/>
+            <a:off x="2286000" y="91440"/>
+            <a:ext cx="36576" cy="502920"/>
           </a:xfrm>
           <a:prstGeom prst="rect">
             <a:avLst/>
           </a:prstGeom>
           <a:solidFill>
-            <a:srgbClr val="FF0000"/>
+            <a:srgbClr val="00AAAA"/>
           </a:solidFill>
           <a:ln>
             <a:noFill/>
@@ -6846,8 +6779,8 @@
         </p:nvSpPr>
         <p:spPr>
           <a:xfrm>
-            <a:off x="1024128" y="91440"/>
-            <a:ext cx="10881360" cy="475488"/>
+            <a:off x="2423160" y="91440"/>
+            <a:ext cx="9235440" cy="502920"/>
           </a:xfrm>
           <a:prstGeom prst="rect">
             <a:avLst/>
@@ -6862,19 +6795,43 @@
           <a:p>
             <a:pPr algn="l"/>
             <a:r>
-              <a:rPr sz="1700" b="1" i="0">
+              <a:rPr sz="1600" b="1" i="0">
                 <a:solidFill>
                   <a:srgbClr val="FFFFFF"/>
                 </a:solidFill>
               </a:rPr>
-              <a:t>Votre Livret Personnel — Votre journal de bord FIM</a:t>
-            </a:r>
-          </a:p>
-        </p:txBody>
-      </p:sp>
-      <p:sp>
-        <p:nvSpPr>
-          <p:cNvPr id="8" name="Rectangle 7"/>
+              <a:t>Votre Livret Personnel — Journal de Bord Quotidien</a:t>
+            </a:r>
+          </a:p>
+        </p:txBody>
+      </p:sp>
+      <p:pic>
+        <p:nvPicPr>
+          <p:cNvPr id="8" name="Picture 7" descr="shy_logo_v2.png"/>
+          <p:cNvPicPr>
+            <a:picLocks noChangeAspect="1"/>
+          </p:cNvPicPr>
+          <p:nvPr/>
+        </p:nvPicPr>
+        <p:blipFill>
+          <a:blip r:embed="rId2"/>
+          <a:stretch>
+            <a:fillRect/>
+          </a:stretch>
+        </p:blipFill>
+        <p:spPr>
+          <a:xfrm>
+            <a:off x="11247120" y="0"/>
+            <a:ext cx="822960" cy="676656"/>
+          </a:xfrm>
+          <a:prstGeom prst="rect">
+            <a:avLst/>
+          </a:prstGeom>
+        </p:spPr>
+      </p:pic>
+      <p:sp>
+        <p:nvSpPr>
+          <p:cNvPr id="9" name="Rectangle 8"/>
           <p:cNvSpPr/>
           <p:nvPr/>
         </p:nvSpPr>
@@ -6917,7 +6874,7 @@
       </p:sp>
       <p:sp>
         <p:nvSpPr>
-          <p:cNvPr id="9" name="TextBox 8"/>
+          <p:cNvPr id="10" name="TextBox 9"/>
           <p:cNvSpPr txBox="1"/>
           <p:nvPr/>
         </p:nvSpPr>
@@ -6939,26 +6896,26 @@
           <a:p>
             <a:pPr algn="ctr"/>
             <a:r>
-              <a:rPr sz="900" b="0" i="0">
+              <a:rPr sz="800" b="0" i="0">
                 <a:solidFill>
                   <a:srgbClr val="FFFFFF"/>
                 </a:solidFill>
               </a:rPr>
-              <a:t>SHY-Performance  ·  Formation FIM  ·  V6-01062026SHY-TE</a:t>
-            </a:r>
-          </a:p>
-        </p:txBody>
-      </p:sp>
-      <p:sp>
-        <p:nvSpPr>
-          <p:cNvPr id="10" name="TextBox 9"/>
+              <a:t>SHY-Performance  ·  Formation FIM  ·  UNICEF France  ·  V6-01062026SHY-TE</a:t>
+            </a:r>
+          </a:p>
+        </p:txBody>
+      </p:sp>
+      <p:sp>
+        <p:nvSpPr>
+          <p:cNvPr id="11" name="TextBox 10"/>
           <p:cNvSpPr txBox="1"/>
           <p:nvPr/>
         </p:nvSpPr>
         <p:spPr>
           <a:xfrm>
             <a:off x="320040" y="804672"/>
-            <a:ext cx="11521440" cy="347472"/>
+            <a:ext cx="11430000" cy="320040"/>
           </a:xfrm>
           <a:prstGeom prst="rect">
             <a:avLst/>
@@ -6973,32 +6930,32 @@
           <a:p>
             <a:pPr algn="l"/>
             <a:r>
-              <a:rPr sz="1300" b="1" i="0">
+              <a:rPr sz="1200" b="1" i="0">
                 <a:solidFill>
                   <a:srgbClr val="005555"/>
                 </a:solidFill>
               </a:rPr>
-              <a:t>Chaque soir, prenez 5 minutes pour compléter ces 4 points :</a:t>
-            </a:r>
-          </a:p>
-        </p:txBody>
-      </p:sp>
-      <p:sp>
-        <p:nvSpPr>
-          <p:cNvPr id="11" name="Rectangle 10"/>
+              <a:t>Chaque soir, 5 minutes pour compléter ces 4 points :</a:t>
+            </a:r>
+          </a:p>
+        </p:txBody>
+      </p:sp>
+      <p:sp>
+        <p:nvSpPr>
+          <p:cNvPr id="12" name="Rectangle 11"/>
           <p:cNvSpPr/>
           <p:nvPr/>
         </p:nvSpPr>
         <p:spPr>
           <a:xfrm>
-            <a:off x="274320" y="1234440"/>
-            <a:ext cx="548640" cy="914400"/>
+            <a:off x="274320" y="1207008"/>
+            <a:ext cx="530352" cy="896112"/>
           </a:xfrm>
           <a:prstGeom prst="rect">
             <a:avLst/>
           </a:prstGeom>
           <a:solidFill>
-            <a:srgbClr val="FF0000"/>
+            <a:srgbClr val="008080"/>
           </a:solidFill>
           <a:ln>
             <a:noFill/>
@@ -7028,14 +6985,14 @@
       </p:sp>
       <p:sp>
         <p:nvSpPr>
-          <p:cNvPr id="12" name="TextBox 11"/>
+          <p:cNvPr id="13" name="TextBox 12"/>
           <p:cNvSpPr txBox="1"/>
           <p:nvPr/>
         </p:nvSpPr>
         <p:spPr>
           <a:xfrm>
-            <a:off x="292608" y="1435608"/>
-            <a:ext cx="512064" cy="512064"/>
+            <a:off x="292608" y="1389888"/>
+            <a:ext cx="493776" cy="530352"/>
           </a:xfrm>
           <a:prstGeom prst="rect">
             <a:avLst/>
@@ -7050,26 +7007,26 @@
           <a:p>
             <a:pPr algn="ctr"/>
             <a:r>
-              <a:rPr sz="2200" b="1" i="0">
+              <a:rPr sz="2000" b="1" i="0">
                 <a:solidFill>
                   <a:srgbClr val="FFFFFF"/>
                 </a:solidFill>
               </a:rPr>
-              <a:t>1</a:t>
-            </a:r>
-          </a:p>
-        </p:txBody>
-      </p:sp>
-      <p:sp>
-        <p:nvSpPr>
-          <p:cNvPr id="13" name="Rectangle 12"/>
+              <a:t>①</a:t>
+            </a:r>
+          </a:p>
+        </p:txBody>
+      </p:sp>
+      <p:sp>
+        <p:nvSpPr>
+          <p:cNvPr id="14" name="Rectangle 13"/>
           <p:cNvSpPr/>
           <p:nvPr/>
         </p:nvSpPr>
         <p:spPr>
           <a:xfrm>
-            <a:off x="841248" y="1234440"/>
-            <a:ext cx="11064240" cy="914400"/>
+            <a:off x="822960" y="1207008"/>
+            <a:ext cx="11064240" cy="896112"/>
           </a:xfrm>
           <a:prstGeom prst="rect">
             <a:avLst/>
@@ -7107,13 +7064,13 @@
       </p:sp>
       <p:sp>
         <p:nvSpPr>
-          <p:cNvPr id="14" name="TextBox 13"/>
+          <p:cNvPr id="15" name="TextBox 14"/>
           <p:cNvSpPr txBox="1"/>
           <p:nvPr/>
         </p:nvSpPr>
         <p:spPr>
           <a:xfrm>
-            <a:off x="950976" y="1289304"/>
+            <a:off x="932688" y="1261872"/>
             <a:ext cx="10881360" cy="274320"/>
           </a:xfrm>
           <a:prstGeom prst="rect">
@@ -7134,21 +7091,21 @@
                   <a:srgbClr val="005555"/>
                 </a:solidFill>
               </a:rPr>
-              <a:t>① Ce que j'ai réussi aujourd'hui</a:t>
-            </a:r>
-          </a:p>
-        </p:txBody>
-      </p:sp>
-      <p:sp>
-        <p:nvSpPr>
-          <p:cNvPr id="15" name="TextBox 14"/>
+              <a:t>Ce que j'ai réussi aujourd'hui</a:t>
+            </a:r>
+          </a:p>
+        </p:txBody>
+      </p:sp>
+      <p:sp>
+        <p:nvSpPr>
+          <p:cNvPr id="16" name="TextBox 15"/>
           <p:cNvSpPr txBox="1"/>
           <p:nvPr/>
         </p:nvSpPr>
         <p:spPr>
           <a:xfrm>
-            <a:off x="950976" y="1581912"/>
-            <a:ext cx="10881360" cy="512064"/>
+            <a:off x="932688" y="1545336"/>
+            <a:ext cx="10881360" cy="493776"/>
           </a:xfrm>
           <a:prstGeom prst="rect">
             <a:avLst/>
@@ -7168,28 +7125,28 @@
                   <a:srgbClr val="1A1A1A"/>
                 </a:solidFill>
               </a:rPr>
-              <a:t>Notez 1 ou 2 moments concrets où vous avez senti la progression.
-Ex : 'J'ai réussi mon accroche en moins de 12 secondes.'</a:t>
-            </a:r>
-          </a:p>
-        </p:txBody>
-      </p:sp>
-      <p:sp>
-        <p:nvSpPr>
-          <p:cNvPr id="16" name="Rectangle 15"/>
+              <a:t>Notez 1 ou 2 moments où vous avez senti la progression.
+Ex : 'J'ai appliqué les 5 règles d'accroche sans hésitation.'</a:t>
+            </a:r>
+          </a:p>
+        </p:txBody>
+      </p:sp>
+      <p:sp>
+        <p:nvSpPr>
+          <p:cNvPr id="17" name="Rectangle 16"/>
           <p:cNvSpPr/>
           <p:nvPr/>
         </p:nvSpPr>
         <p:spPr>
           <a:xfrm>
-            <a:off x="274320" y="2194560"/>
-            <a:ext cx="548640" cy="914400"/>
+            <a:off x="274320" y="2139696"/>
+            <a:ext cx="530352" cy="896112"/>
           </a:xfrm>
           <a:prstGeom prst="rect">
             <a:avLst/>
           </a:prstGeom>
           <a:solidFill>
-            <a:srgbClr val="FF0000"/>
+            <a:srgbClr val="008080"/>
           </a:solidFill>
           <a:ln>
             <a:noFill/>
@@ -7219,14 +7176,14 @@
       </p:sp>
       <p:sp>
         <p:nvSpPr>
-          <p:cNvPr id="17" name="TextBox 16"/>
+          <p:cNvPr id="18" name="TextBox 17"/>
           <p:cNvSpPr txBox="1"/>
           <p:nvPr/>
         </p:nvSpPr>
         <p:spPr>
           <a:xfrm>
-            <a:off x="292608" y="2395728"/>
-            <a:ext cx="512064" cy="512064"/>
+            <a:off x="292608" y="2322576"/>
+            <a:ext cx="493776" cy="530352"/>
           </a:xfrm>
           <a:prstGeom prst="rect">
             <a:avLst/>
@@ -7241,217 +7198,26 @@
           <a:p>
             <a:pPr algn="ctr"/>
             <a:r>
-              <a:rPr sz="2200" b="1" i="0">
+              <a:rPr sz="2000" b="1" i="0">
                 <a:solidFill>
                   <a:srgbClr val="FFFFFF"/>
                 </a:solidFill>
               </a:rPr>
-              <a:t>2</a:t>
-            </a:r>
-          </a:p>
-        </p:txBody>
-      </p:sp>
-      <p:sp>
-        <p:nvSpPr>
-          <p:cNvPr id="18" name="Rectangle 17"/>
+              <a:t>②</a:t>
+            </a:r>
+          </a:p>
+        </p:txBody>
+      </p:sp>
+      <p:sp>
+        <p:nvSpPr>
+          <p:cNvPr id="19" name="Rectangle 18"/>
           <p:cNvSpPr/>
           <p:nvPr/>
         </p:nvSpPr>
         <p:spPr>
           <a:xfrm>
-            <a:off x="841248" y="2194560"/>
-            <a:ext cx="11064240" cy="914400"/>
-          </a:xfrm>
-          <a:prstGeom prst="rect">
-            <a:avLst/>
-          </a:prstGeom>
-          <a:solidFill>
-            <a:srgbClr val="F0F7F7"/>
-          </a:solidFill>
-          <a:ln w="6350">
-            <a:solidFill>
-              <a:srgbClr val="008080"/>
-            </a:solidFill>
-          </a:ln>
-        </p:spPr>
-        <p:style>
-          <a:lnRef idx="1">
-            <a:schemeClr val="accent1"/>
-          </a:lnRef>
-          <a:fillRef idx="3">
-            <a:schemeClr val="accent1"/>
-          </a:fillRef>
-          <a:effectRef idx="2">
-            <a:schemeClr val="accent1"/>
-          </a:effectRef>
-          <a:fontRef idx="minor">
-            <a:schemeClr val="lt1"/>
-          </a:fontRef>
-        </p:style>
-        <p:txBody>
-          <a:bodyPr rtlCol="0" anchor="ctr"/>
-          <a:lstStyle/>
-          <a:p>
-            <a:pPr algn="ctr"/>
-          </a:p>
-        </p:txBody>
-      </p:sp>
-      <p:sp>
-        <p:nvSpPr>
-          <p:cNvPr id="19" name="TextBox 18"/>
-          <p:cNvSpPr txBox="1"/>
-          <p:nvPr/>
-        </p:nvSpPr>
-        <p:spPr>
-          <a:xfrm>
-            <a:off x="950976" y="2249424"/>
-            <a:ext cx="10881360" cy="274320"/>
-          </a:xfrm>
-          <a:prstGeom prst="rect">
-            <a:avLst/>
-          </a:prstGeom>
-          <a:noFill/>
-        </p:spPr>
-        <p:txBody>
-          <a:bodyPr wrap="square">
-            <a:spAutoFit/>
-          </a:bodyPr>
-          <a:lstStyle/>
-          <a:p>
-            <a:pPr algn="l"/>
-            <a:r>
-              <a:rPr sz="1100" b="1" i="0">
-                <a:solidFill>
-                  <a:srgbClr val="005555"/>
-                </a:solidFill>
-              </a:rPr>
-              <a:t>② Ce qui m'a challengé</a:t>
-            </a:r>
-          </a:p>
-        </p:txBody>
-      </p:sp>
-      <p:sp>
-        <p:nvSpPr>
-          <p:cNvPr id="20" name="TextBox 19"/>
-          <p:cNvSpPr txBox="1"/>
-          <p:nvPr/>
-        </p:nvSpPr>
-        <p:spPr>
-          <a:xfrm>
-            <a:off x="950976" y="2542032"/>
-            <a:ext cx="10881360" cy="512064"/>
-          </a:xfrm>
-          <a:prstGeom prst="rect">
-            <a:avLst/>
-          </a:prstGeom>
-          <a:noFill/>
-        </p:spPr>
-        <p:txBody>
-          <a:bodyPr wrap="square">
-            <a:spAutoFit/>
-          </a:bodyPr>
-          <a:lstStyle/>
-          <a:p>
-            <a:pPr algn="l"/>
-            <a:r>
-              <a:rPr sz="1000" b="0" i="1">
-                <a:solidFill>
-                  <a:srgbClr val="1A1A1A"/>
-                </a:solidFill>
-              </a:rPr>
-              <a:t>Décrivez une situation difficile et pourquoi elle vous a bloqué.
-Ex : 'Quand le passant a dit "je n'ai pas les moyens", j'ai hésité.'</a:t>
-            </a:r>
-          </a:p>
-        </p:txBody>
-      </p:sp>
-      <p:sp>
-        <p:nvSpPr>
-          <p:cNvPr id="21" name="Rectangle 20"/>
-          <p:cNvSpPr/>
-          <p:nvPr/>
-        </p:nvSpPr>
-        <p:spPr>
-          <a:xfrm>
-            <a:off x="274320" y="3154680"/>
-            <a:ext cx="548640" cy="914400"/>
-          </a:xfrm>
-          <a:prstGeom prst="rect">
-            <a:avLst/>
-          </a:prstGeom>
-          <a:solidFill>
-            <a:srgbClr val="FF0000"/>
-          </a:solidFill>
-          <a:ln>
-            <a:noFill/>
-          </a:ln>
-        </p:spPr>
-        <p:style>
-          <a:lnRef idx="1">
-            <a:schemeClr val="accent1"/>
-          </a:lnRef>
-          <a:fillRef idx="3">
-            <a:schemeClr val="accent1"/>
-          </a:fillRef>
-          <a:effectRef idx="2">
-            <a:schemeClr val="accent1"/>
-          </a:effectRef>
-          <a:fontRef idx="minor">
-            <a:schemeClr val="lt1"/>
-          </a:fontRef>
-        </p:style>
-        <p:txBody>
-          <a:bodyPr rtlCol="0" anchor="ctr"/>
-          <a:lstStyle/>
-          <a:p>
-            <a:pPr algn="ctr"/>
-          </a:p>
-        </p:txBody>
-      </p:sp>
-      <p:sp>
-        <p:nvSpPr>
-          <p:cNvPr id="22" name="TextBox 21"/>
-          <p:cNvSpPr txBox="1"/>
-          <p:nvPr/>
-        </p:nvSpPr>
-        <p:spPr>
-          <a:xfrm>
-            <a:off x="292608" y="3355848"/>
-            <a:ext cx="512064" cy="512064"/>
-          </a:xfrm>
-          <a:prstGeom prst="rect">
-            <a:avLst/>
-          </a:prstGeom>
-          <a:noFill/>
-        </p:spPr>
-        <p:txBody>
-          <a:bodyPr wrap="square">
-            <a:spAutoFit/>
-          </a:bodyPr>
-          <a:lstStyle/>
-          <a:p>
-            <a:pPr algn="ctr"/>
-            <a:r>
-              <a:rPr sz="2200" b="1" i="0">
-                <a:solidFill>
-                  <a:srgbClr val="FFFFFF"/>
-                </a:solidFill>
-              </a:rPr>
-              <a:t>3</a:t>
-            </a:r>
-          </a:p>
-        </p:txBody>
-      </p:sp>
-      <p:sp>
-        <p:nvSpPr>
-          <p:cNvPr id="23" name="Rectangle 22"/>
-          <p:cNvSpPr/>
-          <p:nvPr/>
-        </p:nvSpPr>
-        <p:spPr>
-          <a:xfrm>
-            <a:off x="841248" y="3154680"/>
-            <a:ext cx="11064240" cy="914400"/>
+            <a:off x="822960" y="2139696"/>
+            <a:ext cx="11064240" cy="896112"/>
           </a:xfrm>
           <a:prstGeom prst="rect">
             <a:avLst/>
@@ -7489,13 +7255,13 @@
       </p:sp>
       <p:sp>
         <p:nvSpPr>
-          <p:cNvPr id="24" name="TextBox 23"/>
+          <p:cNvPr id="20" name="TextBox 19"/>
           <p:cNvSpPr txBox="1"/>
           <p:nvPr/>
         </p:nvSpPr>
         <p:spPr>
           <a:xfrm>
-            <a:off x="950976" y="3209544"/>
+            <a:off x="932688" y="2194560"/>
             <a:ext cx="10881360" cy="274320"/>
           </a:xfrm>
           <a:prstGeom prst="rect">
@@ -7516,21 +7282,21 @@
                   <a:srgbClr val="005555"/>
                 </a:solidFill>
               </a:rPr>
-              <a:t>③ Mon insight du jour</a:t>
-            </a:r>
-          </a:p>
-        </p:txBody>
-      </p:sp>
-      <p:sp>
-        <p:nvSpPr>
-          <p:cNvPr id="25" name="TextBox 24"/>
+              <a:t>Ce qui m'a challengé</a:t>
+            </a:r>
+          </a:p>
+        </p:txBody>
+      </p:sp>
+      <p:sp>
+        <p:nvSpPr>
+          <p:cNvPr id="21" name="TextBox 20"/>
           <p:cNvSpPr txBox="1"/>
           <p:nvPr/>
         </p:nvSpPr>
         <p:spPr>
           <a:xfrm>
-            <a:off x="950976" y="3502152"/>
-            <a:ext cx="10881360" cy="512064"/>
+            <a:off x="932688" y="2478024"/>
+            <a:ext cx="10881360" cy="493776"/>
           </a:xfrm>
           <a:prstGeom prst="rect">
             <a:avLst/>
@@ -7550,28 +7316,28 @@
                   <a:srgbClr val="1A1A1A"/>
                 </a:solidFill>
               </a:rPr>
-              <a:t>L'apprentissage que vous n'auriez pas pu anticiper en arrivant ce matin.
-Ex : 'Le silence après la proposition est plus puissant qu'une relance.'</a:t>
-            </a:r>
-          </a:p>
-        </p:txBody>
-      </p:sp>
-      <p:sp>
-        <p:nvSpPr>
-          <p:cNvPr id="26" name="Rectangle 25"/>
+              <a:t>Une situation difficile et pourquoi elle vous a bloqué.
+Ex : 'Quand le prospect a dit "arnaque", j'ai manqué la reformulation.'</a:t>
+            </a:r>
+          </a:p>
+        </p:txBody>
+      </p:sp>
+      <p:sp>
+        <p:nvSpPr>
+          <p:cNvPr id="22" name="Rectangle 21"/>
           <p:cNvSpPr/>
           <p:nvPr/>
         </p:nvSpPr>
         <p:spPr>
           <a:xfrm>
-            <a:off x="274320" y="4114800"/>
-            <a:ext cx="548640" cy="914400"/>
+            <a:off x="274320" y="3072384"/>
+            <a:ext cx="530352" cy="896112"/>
           </a:xfrm>
           <a:prstGeom prst="rect">
             <a:avLst/>
           </a:prstGeom>
           <a:solidFill>
-            <a:srgbClr val="FF0000"/>
+            <a:srgbClr val="008080"/>
           </a:solidFill>
           <a:ln>
             <a:noFill/>
@@ -7601,14 +7367,14 @@
       </p:sp>
       <p:sp>
         <p:nvSpPr>
-          <p:cNvPr id="27" name="TextBox 26"/>
+          <p:cNvPr id="23" name="TextBox 22"/>
           <p:cNvSpPr txBox="1"/>
           <p:nvPr/>
         </p:nvSpPr>
         <p:spPr>
           <a:xfrm>
-            <a:off x="292608" y="4315968"/>
-            <a:ext cx="512064" cy="512064"/>
+            <a:off x="292608" y="3255264"/>
+            <a:ext cx="493776" cy="530352"/>
           </a:xfrm>
           <a:prstGeom prst="rect">
             <a:avLst/>
@@ -7623,32 +7389,32 @@
           <a:p>
             <a:pPr algn="ctr"/>
             <a:r>
-              <a:rPr sz="2200" b="1" i="0">
+              <a:rPr sz="2000" b="1" i="0">
                 <a:solidFill>
                   <a:srgbClr val="FFFFFF"/>
                 </a:solidFill>
               </a:rPr>
-              <a:t>4</a:t>
-            </a:r>
-          </a:p>
-        </p:txBody>
-      </p:sp>
-      <p:sp>
-        <p:nvSpPr>
-          <p:cNvPr id="28" name="Rectangle 27"/>
+              <a:t>③</a:t>
+            </a:r>
+          </a:p>
+        </p:txBody>
+      </p:sp>
+      <p:sp>
+        <p:nvSpPr>
+          <p:cNvPr id="24" name="Rectangle 23"/>
           <p:cNvSpPr/>
           <p:nvPr/>
         </p:nvSpPr>
         <p:spPr>
           <a:xfrm>
-            <a:off x="841248" y="4114800"/>
-            <a:ext cx="11064240" cy="914400"/>
+            <a:off x="822960" y="3072384"/>
+            <a:ext cx="11064240" cy="896112"/>
           </a:xfrm>
           <a:prstGeom prst="rect">
             <a:avLst/>
           </a:prstGeom>
           <a:solidFill>
-            <a:srgbClr val="F0F7F7"/>
+            <a:srgbClr val="FFFFFF"/>
           </a:solidFill>
           <a:ln w="6350">
             <a:solidFill>
@@ -7680,13 +7446,13 @@
       </p:sp>
       <p:sp>
         <p:nvSpPr>
-          <p:cNvPr id="29" name="TextBox 28"/>
+          <p:cNvPr id="25" name="TextBox 24"/>
           <p:cNvSpPr txBox="1"/>
           <p:nvPr/>
         </p:nvSpPr>
         <p:spPr>
           <a:xfrm>
-            <a:off x="950976" y="4169663"/>
+            <a:off x="932688" y="3127248"/>
             <a:ext cx="10881360" cy="274320"/>
           </a:xfrm>
           <a:prstGeom prst="rect">
@@ -7707,21 +7473,21 @@
                   <a:srgbClr val="005555"/>
                 </a:solidFill>
               </a:rPr>
-              <a:t>④ Mon engagement pour demain</a:t>
-            </a:r>
-          </a:p>
-        </p:txBody>
-      </p:sp>
-      <p:sp>
-        <p:nvSpPr>
-          <p:cNvPr id="30" name="TextBox 29"/>
+              <a:t>Mon insight du jour</a:t>
+            </a:r>
+          </a:p>
+        </p:txBody>
+      </p:sp>
+      <p:sp>
+        <p:nvSpPr>
+          <p:cNvPr id="26" name="TextBox 25"/>
           <p:cNvSpPr txBox="1"/>
           <p:nvPr/>
         </p:nvSpPr>
         <p:spPr>
           <a:xfrm>
-            <a:off x="950976" y="4462272"/>
-            <a:ext cx="10881360" cy="512064"/>
+            <a:off x="932688" y="3410712"/>
+            <a:ext cx="10881360" cy="493776"/>
           </a:xfrm>
           <a:prstGeom prst="rect">
             <a:avLst/>
@@ -7741,22 +7507,22 @@
                   <a:srgbClr val="1A1A1A"/>
                 </a:solidFill>
               </a:rPr>
-              <a:t>1 comportement précis à changer ou renforcer dès demain matin.
-Ex : 'Je vais maintenir le contact visuel pendant toute la proposition.'</a:t>
-            </a:r>
-          </a:p>
-        </p:txBody>
-      </p:sp>
-      <p:sp>
-        <p:nvSpPr>
-          <p:cNvPr id="31" name="Rectangle 30"/>
+              <a:t>L'apprentissage que vous n'auriez pas pu anticiper ce matin.
+Ex : 'La pause après la proposition vaut mieux qu'une relance immédiate.'</a:t>
+            </a:r>
+          </a:p>
+        </p:txBody>
+      </p:sp>
+      <p:sp>
+        <p:nvSpPr>
+          <p:cNvPr id="27" name="Rectangle 26"/>
           <p:cNvSpPr/>
           <p:nvPr/>
         </p:nvSpPr>
         <p:spPr>
           <a:xfrm>
-            <a:off x="274320" y="5074920"/>
-            <a:ext cx="11640312" cy="384048"/>
+            <a:off x="274320" y="4005072"/>
+            <a:ext cx="530352" cy="896112"/>
           </a:xfrm>
           <a:prstGeom prst="rect">
             <a:avLst/>
@@ -7792,14 +7558,205 @@
       </p:sp>
       <p:sp>
         <p:nvSpPr>
-          <p:cNvPr id="32" name="TextBox 31"/>
+          <p:cNvPr id="28" name="TextBox 27"/>
           <p:cNvSpPr txBox="1"/>
           <p:nvPr/>
         </p:nvSpPr>
         <p:spPr>
           <a:xfrm>
-            <a:off x="411479" y="5148072"/>
-            <a:ext cx="11365992" cy="237744"/>
+            <a:off x="292608" y="4187952"/>
+            <a:ext cx="493776" cy="530352"/>
+          </a:xfrm>
+          <a:prstGeom prst="rect">
+            <a:avLst/>
+          </a:prstGeom>
+          <a:noFill/>
+        </p:spPr>
+        <p:txBody>
+          <a:bodyPr wrap="square">
+            <a:spAutoFit/>
+          </a:bodyPr>
+          <a:lstStyle/>
+          <a:p>
+            <a:pPr algn="ctr"/>
+            <a:r>
+              <a:rPr sz="2000" b="1" i="0">
+                <a:solidFill>
+                  <a:srgbClr val="FFFFFF"/>
+                </a:solidFill>
+              </a:rPr>
+              <a:t>④</a:t>
+            </a:r>
+          </a:p>
+        </p:txBody>
+      </p:sp>
+      <p:sp>
+        <p:nvSpPr>
+          <p:cNvPr id="29" name="Rectangle 28"/>
+          <p:cNvSpPr/>
+          <p:nvPr/>
+        </p:nvSpPr>
+        <p:spPr>
+          <a:xfrm>
+            <a:off x="822960" y="4005072"/>
+            <a:ext cx="11064240" cy="896112"/>
+          </a:xfrm>
+          <a:prstGeom prst="rect">
+            <a:avLst/>
+          </a:prstGeom>
+          <a:solidFill>
+            <a:srgbClr val="FFFFFF"/>
+          </a:solidFill>
+          <a:ln w="6350">
+            <a:solidFill>
+              <a:srgbClr val="008080"/>
+            </a:solidFill>
+          </a:ln>
+        </p:spPr>
+        <p:style>
+          <a:lnRef idx="1">
+            <a:schemeClr val="accent1"/>
+          </a:lnRef>
+          <a:fillRef idx="3">
+            <a:schemeClr val="accent1"/>
+          </a:fillRef>
+          <a:effectRef idx="2">
+            <a:schemeClr val="accent1"/>
+          </a:effectRef>
+          <a:fontRef idx="minor">
+            <a:schemeClr val="lt1"/>
+          </a:fontRef>
+        </p:style>
+        <p:txBody>
+          <a:bodyPr rtlCol="0" anchor="ctr"/>
+          <a:lstStyle/>
+          <a:p>
+            <a:pPr algn="ctr"/>
+          </a:p>
+        </p:txBody>
+      </p:sp>
+      <p:sp>
+        <p:nvSpPr>
+          <p:cNvPr id="30" name="TextBox 29"/>
+          <p:cNvSpPr txBox="1"/>
+          <p:nvPr/>
+        </p:nvSpPr>
+        <p:spPr>
+          <a:xfrm>
+            <a:off x="932688" y="4059935"/>
+            <a:ext cx="10881360" cy="274320"/>
+          </a:xfrm>
+          <a:prstGeom prst="rect">
+            <a:avLst/>
+          </a:prstGeom>
+          <a:noFill/>
+        </p:spPr>
+        <p:txBody>
+          <a:bodyPr wrap="square">
+            <a:spAutoFit/>
+          </a:bodyPr>
+          <a:lstStyle/>
+          <a:p>
+            <a:pPr algn="l"/>
+            <a:r>
+              <a:rPr sz="1100" b="1" i="0">
+                <a:solidFill>
+                  <a:srgbClr val="005555"/>
+                </a:solidFill>
+              </a:rPr>
+              <a:t>Mon engagement pour demain</a:t>
+            </a:r>
+          </a:p>
+        </p:txBody>
+      </p:sp>
+      <p:sp>
+        <p:nvSpPr>
+          <p:cNvPr id="31" name="TextBox 30"/>
+          <p:cNvSpPr txBox="1"/>
+          <p:nvPr/>
+        </p:nvSpPr>
+        <p:spPr>
+          <a:xfrm>
+            <a:off x="932688" y="4343400"/>
+            <a:ext cx="10881360" cy="493776"/>
+          </a:xfrm>
+          <a:prstGeom prst="rect">
+            <a:avLst/>
+          </a:prstGeom>
+          <a:noFill/>
+        </p:spPr>
+        <p:txBody>
+          <a:bodyPr wrap="square">
+            <a:spAutoFit/>
+          </a:bodyPr>
+          <a:lstStyle/>
+          <a:p>
+            <a:pPr algn="l"/>
+            <a:r>
+              <a:rPr sz="1000" b="0" i="1">
+                <a:solidFill>
+                  <a:srgbClr val="1A1A1A"/>
+                </a:solidFill>
+              </a:rPr>
+              <a:t>1 comportement précis à changer ou renforcer dès demain.
+Ex : 'Je vais sourire à voix haute dès le mot "Bonjour".'</a:t>
+            </a:r>
+          </a:p>
+        </p:txBody>
+      </p:sp>
+      <p:sp>
+        <p:nvSpPr>
+          <p:cNvPr id="32" name="Rectangle 31"/>
+          <p:cNvSpPr/>
+          <p:nvPr/>
+        </p:nvSpPr>
+        <p:spPr>
+          <a:xfrm>
+            <a:off x="274320" y="4956048"/>
+            <a:ext cx="11640312" cy="347472"/>
+          </a:xfrm>
+          <a:prstGeom prst="rect">
+            <a:avLst/>
+          </a:prstGeom>
+          <a:solidFill>
+            <a:srgbClr val="008080"/>
+          </a:solidFill>
+          <a:ln>
+            <a:noFill/>
+          </a:ln>
+        </p:spPr>
+        <p:style>
+          <a:lnRef idx="1">
+            <a:schemeClr val="accent1"/>
+          </a:lnRef>
+          <a:fillRef idx="3">
+            <a:schemeClr val="accent1"/>
+          </a:fillRef>
+          <a:effectRef idx="2">
+            <a:schemeClr val="accent1"/>
+          </a:effectRef>
+          <a:fontRef idx="minor">
+            <a:schemeClr val="lt1"/>
+          </a:fontRef>
+        </p:style>
+        <p:txBody>
+          <a:bodyPr rtlCol="0" anchor="ctr"/>
+          <a:lstStyle/>
+          <a:p>
+            <a:pPr algn="ctr"/>
+          </a:p>
+        </p:txBody>
+      </p:sp>
+      <p:sp>
+        <p:nvSpPr>
+          <p:cNvPr id="33" name="TextBox 32"/>
+          <p:cNvSpPr txBox="1"/>
+          <p:nvPr/>
+        </p:nvSpPr>
+        <p:spPr>
+          <a:xfrm>
+            <a:off x="411479" y="5029200"/>
+            <a:ext cx="11365992" cy="201168"/>
           </a:xfrm>
           <a:prstGeom prst="rect">
             <a:avLst/>
@@ -7819,7 +7776,7 @@
                   <a:srgbClr val="FFFFFF"/>
                 </a:solidFill>
               </a:rPr>
-              <a:t>Votre livret reste strictement personnel — il ne sera pas noté. C'est votre outil de progression, pas une évaluation.</a:t>
+              <a:t>Votre livret reste strictement personnel — il ne sera pas noté. C'est votre outil de progression.</a:t>
             </a:r>
           </a:p>
         </p:txBody>

</xml_diff>

<commit_message>
Add 10 FIM modules FINALPLUS: logo header, 40Q quiz, Merci slides, J6+J7 ateliers
- 7 original modules (Book0, Book1, J1-J5) with logo on every slide and Merci à tous final slide
- BookQUIZ: 40 questions in 6 parts (A-F) covering UNICEF, secteur associatif, script, KPI, objections, éthique
- BookJ6: Atelier Pratique 1 — simulations d'appels en direct, grilles d'observation
- BookJ7: Atelier Pratique 2 — certification finale, analyse écarts vs UNICEF Paris, plan prise de poste
- SHY-Performance logo on every slide header, charte teal sans rouge
- Version V6-01062026SHY-TE — Fundraisers UNICEF / FIDELIS

https://claude.ai/code/session_01KeQ88BfXySEzARHjHzWvmX
</commit_message>
<xml_diff>
--- a/FIM_Book0_FilConducteur_V6-01062026SHY-TE.pptx
+++ b/FIM_Book0_FilConducteur_V6-01062026SHY-TE.pptx
@@ -3149,7 +3149,7 @@
             <a:avLst/>
           </a:prstGeom>
           <a:solidFill>
-            <a:srgbClr val="005555"/>
+            <a:srgbClr val="005050"/>
           </a:solidFill>
           <a:ln>
             <a:noFill/>
@@ -3229,7 +3229,7 @@
         <p:spPr>
           <a:xfrm>
             <a:off x="347472" y="91440"/>
-            <a:ext cx="3200400" cy="438912"/>
+            <a:ext cx="4572000" cy="402336"/>
           </a:xfrm>
           <a:prstGeom prst="rect">
             <a:avLst/>
@@ -3262,8 +3262,8 @@
         </p:nvSpPr>
         <p:spPr>
           <a:xfrm>
-            <a:off x="347472" y="530352"/>
-            <a:ext cx="7772400" cy="347472"/>
+            <a:off x="347472" y="493776"/>
+            <a:ext cx="8229600" cy="329184"/>
           </a:xfrm>
           <a:prstGeom prst="rect">
             <a:avLst/>
@@ -3296,8 +3296,8 @@
         </p:nvSpPr>
         <p:spPr>
           <a:xfrm>
-            <a:off x="347472" y="932688"/>
-            <a:ext cx="7772400" cy="292608"/>
+            <a:off x="347472" y="877824"/>
+            <a:ext cx="8229600" cy="274320"/>
           </a:xfrm>
           <a:prstGeom prst="rect">
             <a:avLst/>
@@ -3330,8 +3330,8 @@
         </p:nvSpPr>
         <p:spPr>
           <a:xfrm>
-            <a:off x="347472" y="1207008"/>
-            <a:ext cx="10515600" cy="914400"/>
+            <a:off x="347472" y="1188720"/>
+            <a:ext cx="10515600" cy="960120"/>
           </a:xfrm>
           <a:prstGeom prst="rect">
             <a:avLst/>
@@ -3346,7 +3346,7 @@
           <a:p>
             <a:pPr algn="l"/>
             <a:r>
-              <a:rPr sz="3000" b="1" i="0">
+              <a:rPr sz="2900" b="1" i="0">
                 <a:solidFill>
                   <a:srgbClr val="FFFFFF"/>
                 </a:solidFill>
@@ -3364,8 +3364,8 @@
         </p:nvSpPr>
         <p:spPr>
           <a:xfrm>
-            <a:off x="347472" y="1901952"/>
-            <a:ext cx="10515600" cy="402336"/>
+            <a:off x="347472" y="1920240"/>
+            <a:ext cx="10515600" cy="384048"/>
           </a:xfrm>
           <a:prstGeom prst="rect">
             <a:avLst/>
@@ -3406,8 +3406,8 @@
         </p:blipFill>
         <p:spPr>
           <a:xfrm>
-            <a:off x="11247120" y="45720"/>
-            <a:ext cx="822960" cy="804672"/>
+            <a:off x="11228832" y="0"/>
+            <a:ext cx="841248" cy="676656"/>
           </a:xfrm>
           <a:prstGeom prst="rect">
             <a:avLst/>
@@ -3429,7 +3429,7 @@
             <a:avLst/>
           </a:prstGeom>
           <a:solidFill>
-            <a:srgbClr val="005555"/>
+            <a:srgbClr val="005050"/>
           </a:solidFill>
           <a:ln>
             <a:noFill/>
@@ -3552,7 +3552,7 @@
             <a:r>
               <a:rPr sz="1300" b="1" i="0">
                 <a:solidFill>
-                  <a:srgbClr val="005555"/>
+                  <a:srgbClr val="005050"/>
                 </a:solidFill>
               </a:rPr>
               <a:t>Vous allez maîtriser le script officiel UNICEF en 7 étapes, qualifier vos appels
@@ -3637,7 +3637,7 @@
             <a:avLst/>
           </a:prstGeom>
           <a:solidFill>
-            <a:srgbClr val="005555"/>
+            <a:srgbClr val="005050"/>
           </a:solidFill>
           <a:ln>
             <a:noFill/>
@@ -3716,8 +3716,8 @@
         </p:nvSpPr>
         <p:spPr>
           <a:xfrm>
-            <a:off x="164592" y="73152"/>
-            <a:ext cx="2011680" cy="347472"/>
+            <a:off x="164592" y="91440"/>
+            <a:ext cx="1920240" cy="329184"/>
           </a:xfrm>
           <a:prstGeom prst="rect">
             <a:avLst/>
@@ -3750,8 +3750,8 @@
         </p:nvSpPr>
         <p:spPr>
           <a:xfrm>
-            <a:off x="2286000" y="91440"/>
-            <a:ext cx="36576" cy="502920"/>
+            <a:off x="2212848" y="109728"/>
+            <a:ext cx="36576" cy="475488"/>
           </a:xfrm>
           <a:prstGeom prst="rect">
             <a:avLst/>
@@ -3793,8 +3793,8 @@
         </p:nvSpPr>
         <p:spPr>
           <a:xfrm>
-            <a:off x="2423160" y="91440"/>
-            <a:ext cx="9235440" cy="502920"/>
+            <a:off x="2350008" y="91440"/>
+            <a:ext cx="8823960" cy="502920"/>
           </a:xfrm>
           <a:prstGeom prst="rect">
             <a:avLst/>
@@ -3814,7 +3814,7 @@
                   <a:srgbClr val="FFFFFF"/>
                 </a:solidFill>
               </a:rPr>
-              <a:t>Vos 5 Journées — Ce qui vous attend</a:t>
+              <a:t>Vos 5 Journées + 2 Ateliers — Ce qui vous attend</a:t>
             </a:r>
           </a:p>
         </p:txBody>
@@ -3835,8 +3835,8 @@
         </p:blipFill>
         <p:spPr>
           <a:xfrm>
-            <a:off x="11247120" y="0"/>
-            <a:ext cx="822960" cy="676656"/>
+            <a:off x="11228832" y="0"/>
+            <a:ext cx="841248" cy="676656"/>
           </a:xfrm>
           <a:prstGeom prst="rect">
             <a:avLst/>
@@ -3858,7 +3858,7 @@
             <a:avLst/>
           </a:prstGeom>
           <a:solidFill>
-            <a:srgbClr val="005555"/>
+            <a:srgbClr val="005050"/>
           </a:solidFill>
           <a:ln>
             <a:noFill/>
@@ -3929,13 +3929,13 @@
         <p:spPr>
           <a:xfrm>
             <a:off x="274320" y="804672"/>
-            <a:ext cx="2286000" cy="329184"/>
+            <a:ext cx="1664208" cy="310896"/>
           </a:xfrm>
           <a:prstGeom prst="rect">
             <a:avLst/>
           </a:prstGeom>
           <a:solidFill>
-            <a:srgbClr val="005555"/>
+            <a:srgbClr val="005050"/>
           </a:solidFill>
           <a:ln>
             <a:noFill/>
@@ -3971,8 +3971,8 @@
         </p:nvSpPr>
         <p:spPr>
           <a:xfrm>
-            <a:off x="347472" y="832104"/>
-            <a:ext cx="2139696" cy="256032"/>
+            <a:off x="329184" y="832104"/>
+            <a:ext cx="1554480" cy="237744"/>
           </a:xfrm>
           <a:prstGeom prst="rect">
             <a:avLst/>
@@ -3987,12 +3987,12 @@
           <a:p>
             <a:pPr algn="l"/>
             <a:r>
-              <a:rPr sz="1000" b="1" i="0">
+              <a:rPr sz="900" b="1" i="0">
                 <a:solidFill>
                   <a:srgbClr val="FFFFFF"/>
                 </a:solidFill>
               </a:rPr>
-              <a:t>JOUR 1</a:t>
+              <a:t>J1</a:t>
             </a:r>
           </a:p>
         </p:txBody>
@@ -4005,8 +4005,8 @@
         </p:nvSpPr>
         <p:spPr>
           <a:xfrm>
-            <a:off x="274320" y="1133856"/>
-            <a:ext cx="2286000" cy="960120"/>
+            <a:off x="274320" y="1115568"/>
+            <a:ext cx="1664208" cy="822960"/>
           </a:xfrm>
           <a:prstGeom prst="rect">
             <a:avLst/>
@@ -4048,8 +4048,8 @@
         </p:nvSpPr>
         <p:spPr>
           <a:xfrm>
-            <a:off x="384048" y="1161288"/>
-            <a:ext cx="2066543" cy="896112"/>
+            <a:off x="347472" y="1143000"/>
+            <a:ext cx="1517904" cy="768096"/>
           </a:xfrm>
           <a:prstGeom prst="rect">
             <a:avLst/>
@@ -4064,7 +4064,7 @@
           <a:p>
             <a:pPr algn="ctr"/>
             <a:r>
-              <a:rPr sz="1300" b="1" i="0">
+              <a:rPr sz="1000" b="1" i="0">
                 <a:solidFill>
                   <a:srgbClr val="FFFFFF"/>
                 </a:solidFill>
@@ -4083,8 +4083,8 @@
         </p:nvSpPr>
         <p:spPr>
           <a:xfrm>
-            <a:off x="274320" y="2093976"/>
-            <a:ext cx="2286000" cy="3291840"/>
+            <a:off x="274320" y="1938528"/>
+            <a:ext cx="1664208" cy="3429000"/>
           </a:xfrm>
           <a:prstGeom prst="rect">
             <a:avLst/>
@@ -4092,7 +4092,7 @@
           <a:solidFill>
             <a:srgbClr val="FFFFFF"/>
           </a:solidFill>
-          <a:ln w="19050">
+          <a:ln w="12700">
             <a:solidFill>
               <a:srgbClr val="008080"/>
             </a:solidFill>
@@ -4128,8 +4128,8 @@
         </p:nvSpPr>
         <p:spPr>
           <a:xfrm>
-            <a:off x="402336" y="2167128"/>
-            <a:ext cx="2029968" cy="3127248"/>
+            <a:off x="365760" y="1993392"/>
+            <a:ext cx="1481328" cy="3200400"/>
           </a:xfrm>
           <a:prstGeom prst="rect">
             <a:avLst/>
@@ -4144,12 +4144,12 @@
           <a:p>
             <a:pPr algn="l"/>
             <a:r>
-              <a:rPr sz="1000" b="0" i="0">
+              <a:rPr sz="800" b="0" i="0">
                 <a:solidFill>
                   <a:srgbClr val="1A1A1A"/>
                 </a:solidFill>
               </a:rPr>
-              <a:t>Mission UNICEF · KPI (CU/H, TX Transfo, PDC) · Nomenclature FIDELIS · Organisation de la production</a:t>
+              <a:t>Mission UNICEF · KPI FIDELIS · Nomenclature DON/INDÉCIS/REFUS · Organisation production</a:t>
             </a:r>
           </a:p>
         </p:txBody>
@@ -4162,14 +4162,14 @@
         </p:nvSpPr>
         <p:spPr>
           <a:xfrm>
-            <a:off x="2633472" y="804672"/>
-            <a:ext cx="2286000" cy="329184"/>
+            <a:off x="1975104" y="804672"/>
+            <a:ext cx="1664208" cy="310896"/>
           </a:xfrm>
           <a:prstGeom prst="rect">
             <a:avLst/>
           </a:prstGeom>
           <a:solidFill>
-            <a:srgbClr val="005555"/>
+            <a:srgbClr val="005050"/>
           </a:solidFill>
           <a:ln>
             <a:noFill/>
@@ -4205,8 +4205,8 @@
         </p:nvSpPr>
         <p:spPr>
           <a:xfrm>
-            <a:off x="2706624" y="832104"/>
-            <a:ext cx="2139696" cy="256032"/>
+            <a:off x="2029968" y="832104"/>
+            <a:ext cx="1554480" cy="237744"/>
           </a:xfrm>
           <a:prstGeom prst="rect">
             <a:avLst/>
@@ -4221,12 +4221,12 @@
           <a:p>
             <a:pPr algn="l"/>
             <a:r>
-              <a:rPr sz="1000" b="1" i="0">
+              <a:rPr sz="900" b="1" i="0">
                 <a:solidFill>
                   <a:srgbClr val="FFFFFF"/>
                 </a:solidFill>
               </a:rPr>
-              <a:t>JOUR 2</a:t>
+              <a:t>J2</a:t>
             </a:r>
           </a:p>
         </p:txBody>
@@ -4239,8 +4239,8 @@
         </p:nvSpPr>
         <p:spPr>
           <a:xfrm>
-            <a:off x="2633472" y="1133856"/>
-            <a:ext cx="2286000" cy="960120"/>
+            <a:off x="1975104" y="1115568"/>
+            <a:ext cx="1664208" cy="822960"/>
           </a:xfrm>
           <a:prstGeom prst="rect">
             <a:avLst/>
@@ -4282,8 +4282,8 @@
         </p:nvSpPr>
         <p:spPr>
           <a:xfrm>
-            <a:off x="2743200" y="1161288"/>
-            <a:ext cx="2066543" cy="896112"/>
+            <a:off x="2048256" y="1143000"/>
+            <a:ext cx="1517904" cy="768096"/>
           </a:xfrm>
           <a:prstGeom prst="rect">
             <a:avLst/>
@@ -4298,12 +4298,12 @@
           <a:p>
             <a:pPr algn="ctr"/>
             <a:r>
-              <a:rPr sz="1300" b="1" i="0">
+              <a:rPr sz="1000" b="1" i="0">
                 <a:solidFill>
                   <a:srgbClr val="FFFFFF"/>
                 </a:solidFill>
               </a:rPr>
-              <a:t>Le Monde
+              <a:t>Monde
 Associatif</a:t>
             </a:r>
           </a:p>
@@ -4317,8 +4317,8 @@
         </p:nvSpPr>
         <p:spPr>
           <a:xfrm>
-            <a:off x="2633472" y="2093976"/>
-            <a:ext cx="2286000" cy="3291840"/>
+            <a:off x="1975104" y="1938528"/>
+            <a:ext cx="1664208" cy="3429000"/>
           </a:xfrm>
           <a:prstGeom prst="rect">
             <a:avLst/>
@@ -4326,7 +4326,7 @@
           <a:solidFill>
             <a:srgbClr val="FFFFFF"/>
           </a:solidFill>
-          <a:ln w="19050">
+          <a:ln w="12700">
             <a:solidFill>
               <a:srgbClr val="008080"/>
             </a:solidFill>
@@ -4362,8 +4362,8 @@
         </p:nvSpPr>
         <p:spPr>
           <a:xfrm>
-            <a:off x="2761488" y="2167128"/>
-            <a:ext cx="2029968" cy="3127248"/>
+            <a:off x="2066544" y="1993392"/>
+            <a:ext cx="1481328" cy="3200400"/>
           </a:xfrm>
           <a:prstGeom prst="rect">
             <a:avLst/>
@@ -4378,12 +4378,12 @@
           <a:p>
             <a:pPr algn="l"/>
             <a:r>
-              <a:rPr sz="1000" b="0" i="0">
+              <a:rPr sz="800" b="0" i="0">
                 <a:solidFill>
                   <a:srgbClr val="1A1A1A"/>
                 </a:solidFill>
               </a:rPr>
-              <a:t>Loi 1901 · Histoire humanitaire · Principes humanitaires · Don régulier · Label Don en Confiance</a:t>
+              <a:t>Loi 1901 · Histoire humanitaire · 3 principes · Don régulier · Label Don en Confiance</a:t>
             </a:r>
           </a:p>
         </p:txBody>
@@ -4396,14 +4396,14 @@
         </p:nvSpPr>
         <p:spPr>
           <a:xfrm>
-            <a:off x="4992624" y="804672"/>
-            <a:ext cx="2286000" cy="329184"/>
+            <a:off x="3675888" y="804672"/>
+            <a:ext cx="1664208" cy="310896"/>
           </a:xfrm>
           <a:prstGeom prst="rect">
             <a:avLst/>
           </a:prstGeom>
           <a:solidFill>
-            <a:srgbClr val="005555"/>
+            <a:srgbClr val="005050"/>
           </a:solidFill>
           <a:ln>
             <a:noFill/>
@@ -4439,8 +4439,8 @@
         </p:nvSpPr>
         <p:spPr>
           <a:xfrm>
-            <a:off x="5065776" y="832104"/>
-            <a:ext cx="2139696" cy="256032"/>
+            <a:off x="3730752" y="832104"/>
+            <a:ext cx="1554480" cy="237744"/>
           </a:xfrm>
           <a:prstGeom prst="rect">
             <a:avLst/>
@@ -4455,12 +4455,12 @@
           <a:p>
             <a:pPr algn="l"/>
             <a:r>
-              <a:rPr sz="1000" b="1" i="0">
+              <a:rPr sz="900" b="1" i="0">
                 <a:solidFill>
                   <a:srgbClr val="FFFFFF"/>
                 </a:solidFill>
               </a:rPr>
-              <a:t>JOUR 3</a:t>
+              <a:t>J3</a:t>
             </a:r>
           </a:p>
         </p:txBody>
@@ -4473,8 +4473,8 @@
         </p:nvSpPr>
         <p:spPr>
           <a:xfrm>
-            <a:off x="4992624" y="1133856"/>
-            <a:ext cx="2286000" cy="960120"/>
+            <a:off x="3675888" y="1115568"/>
+            <a:ext cx="1664208" cy="822960"/>
           </a:xfrm>
           <a:prstGeom prst="rect">
             <a:avLst/>
@@ -4516,8 +4516,8 @@
         </p:nvSpPr>
         <p:spPr>
           <a:xfrm>
-            <a:off x="5102352" y="1161288"/>
-            <a:ext cx="2066543" cy="896112"/>
+            <a:off x="3749040" y="1143000"/>
+            <a:ext cx="1517904" cy="768096"/>
           </a:xfrm>
           <a:prstGeom prst="rect">
             <a:avLst/>
@@ -4532,7 +4532,7 @@
           <a:p>
             <a:pPr algn="ctr"/>
             <a:r>
-              <a:rPr sz="1300" b="1" i="0">
+              <a:rPr sz="1000" b="1" i="0">
                 <a:solidFill>
                   <a:srgbClr val="FFFFFF"/>
                 </a:solidFill>
@@ -4551,8 +4551,8 @@
         </p:nvSpPr>
         <p:spPr>
           <a:xfrm>
-            <a:off x="4992624" y="2093976"/>
-            <a:ext cx="2286000" cy="3291840"/>
+            <a:off x="3675888" y="1938528"/>
+            <a:ext cx="1664208" cy="3429000"/>
           </a:xfrm>
           <a:prstGeom prst="rect">
             <a:avLst/>
@@ -4560,7 +4560,7 @@
           <a:solidFill>
             <a:srgbClr val="FFFFFF"/>
           </a:solidFill>
-          <a:ln w="19050">
+          <a:ln w="12700">
             <a:solidFill>
               <a:srgbClr val="008080"/>
             </a:solidFill>
@@ -4596,8 +4596,8 @@
         </p:nvSpPr>
         <p:spPr>
           <a:xfrm>
-            <a:off x="5120640" y="2167128"/>
-            <a:ext cx="2029968" cy="3127248"/>
+            <a:off x="3767328" y="1993392"/>
+            <a:ext cx="1481328" cy="3200400"/>
           </a:xfrm>
           <a:prstGeom prst="rect">
             <a:avLst/>
@@ -4612,12 +4612,12 @@
           <a:p>
             <a:pPr algn="l"/>
             <a:r>
-              <a:rPr sz="1000" b="0" i="0">
+              <a:rPr sz="800" b="0" i="0">
                 <a:solidFill>
                   <a:srgbClr val="1A1A1A"/>
                 </a:solidFill>
               </a:rPr>
-              <a:t>Script officiel UNICEF 7 étapes · 5 règles d'accroche · 4 modes de validation du don · Lecture à voix haute</a:t>
+              <a:t>Script 7 étapes · 5 règles accroche · 4 modes validation · Lecture à voix haute</a:t>
             </a:r>
           </a:p>
         </p:txBody>
@@ -4630,14 +4630,14 @@
         </p:nvSpPr>
         <p:spPr>
           <a:xfrm>
-            <a:off x="7351775" y="804672"/>
-            <a:ext cx="2286000" cy="329184"/>
+            <a:off x="5376672" y="804672"/>
+            <a:ext cx="1664208" cy="310896"/>
           </a:xfrm>
           <a:prstGeom prst="rect">
             <a:avLst/>
           </a:prstGeom>
           <a:solidFill>
-            <a:srgbClr val="005555"/>
+            <a:srgbClr val="005050"/>
           </a:solidFill>
           <a:ln>
             <a:noFill/>
@@ -4673,8 +4673,8 @@
         </p:nvSpPr>
         <p:spPr>
           <a:xfrm>
-            <a:off x="7424927" y="832104"/>
-            <a:ext cx="2139696" cy="256032"/>
+            <a:off x="5431536" y="832104"/>
+            <a:ext cx="1554480" cy="237744"/>
           </a:xfrm>
           <a:prstGeom prst="rect">
             <a:avLst/>
@@ -4689,12 +4689,12 @@
           <a:p>
             <a:pPr algn="l"/>
             <a:r>
-              <a:rPr sz="1000" b="1" i="0">
+              <a:rPr sz="900" b="1" i="0">
                 <a:solidFill>
                   <a:srgbClr val="FFFFFF"/>
                 </a:solidFill>
               </a:rPr>
-              <a:t>JOUR 4</a:t>
+              <a:t>J4</a:t>
             </a:r>
           </a:p>
         </p:txBody>
@@ -4707,8 +4707,8 @@
         </p:nvSpPr>
         <p:spPr>
           <a:xfrm>
-            <a:off x="7351775" y="1133856"/>
-            <a:ext cx="2286000" cy="960120"/>
+            <a:off x="5376672" y="1115568"/>
+            <a:ext cx="1664208" cy="822960"/>
           </a:xfrm>
           <a:prstGeom prst="rect">
             <a:avLst/>
@@ -4750,8 +4750,8 @@
         </p:nvSpPr>
         <p:spPr>
           <a:xfrm>
-            <a:off x="7461503" y="1161288"/>
-            <a:ext cx="2066543" cy="896112"/>
+            <a:off x="5449824" y="1143000"/>
+            <a:ext cx="1517904" cy="768096"/>
           </a:xfrm>
           <a:prstGeom prst="rect">
             <a:avLst/>
@@ -4766,13 +4766,13 @@
           <a:p>
             <a:pPr algn="ctr"/>
             <a:r>
-              <a:rPr sz="1300" b="1" i="0">
+              <a:rPr sz="1000" b="1" i="0">
                 <a:solidFill>
                   <a:srgbClr val="FFFFFF"/>
                 </a:solidFill>
               </a:rPr>
               <a:t>Traitement
-des Objections</a:t>
+Objections</a:t>
             </a:r>
           </a:p>
         </p:txBody>
@@ -4785,8 +4785,8 @@
         </p:nvSpPr>
         <p:spPr>
           <a:xfrm>
-            <a:off x="7351775" y="2093976"/>
-            <a:ext cx="2286000" cy="3291840"/>
+            <a:off x="5376672" y="1938528"/>
+            <a:ext cx="1664208" cy="3429000"/>
           </a:xfrm>
           <a:prstGeom prst="rect">
             <a:avLst/>
@@ -4794,7 +4794,7 @@
           <a:solidFill>
             <a:srgbClr val="FFFFFF"/>
           </a:solidFill>
-          <a:ln w="19050">
+          <a:ln w="12700">
             <a:solidFill>
               <a:srgbClr val="008080"/>
             </a:solidFill>
@@ -4830,8 +4830,8 @@
         </p:nvSpPr>
         <p:spPr>
           <a:xfrm>
-            <a:off x="7479792" y="2167128"/>
-            <a:ext cx="2029968" cy="3127248"/>
+            <a:off x="5468112" y="1993392"/>
+            <a:ext cx="1481328" cy="3200400"/>
           </a:xfrm>
           <a:prstGeom prst="rect">
             <a:avLst/>
@@ -4846,7 +4846,7 @@
           <a:p>
             <a:pPr algn="l"/>
             <a:r>
-              <a:rPr sz="1000" b="0" i="0">
+              <a:rPr sz="800" b="0" i="0">
                 <a:solidFill>
                   <a:srgbClr val="1A1A1A"/>
                 </a:solidFill>
@@ -4864,14 +4864,14 @@
         </p:nvSpPr>
         <p:spPr>
           <a:xfrm>
-            <a:off x="9710928" y="804672"/>
-            <a:ext cx="2286000" cy="329184"/>
+            <a:off x="7077456" y="804672"/>
+            <a:ext cx="1664208" cy="310896"/>
           </a:xfrm>
           <a:prstGeom prst="rect">
             <a:avLst/>
           </a:prstGeom>
           <a:solidFill>
-            <a:srgbClr val="005555"/>
+            <a:srgbClr val="005050"/>
           </a:solidFill>
           <a:ln>
             <a:noFill/>
@@ -4907,8 +4907,8 @@
         </p:nvSpPr>
         <p:spPr>
           <a:xfrm>
-            <a:off x="9784080" y="832104"/>
-            <a:ext cx="2139696" cy="256032"/>
+            <a:off x="7132320" y="832104"/>
+            <a:ext cx="1554480" cy="237744"/>
           </a:xfrm>
           <a:prstGeom prst="rect">
             <a:avLst/>
@@ -4923,12 +4923,12 @@
           <a:p>
             <a:pPr algn="l"/>
             <a:r>
-              <a:rPr sz="1000" b="1" i="0">
+              <a:rPr sz="900" b="1" i="0">
                 <a:solidFill>
                   <a:srgbClr val="FFFFFF"/>
                 </a:solidFill>
               </a:rPr>
-              <a:t>JOUR 5</a:t>
+              <a:t>J5</a:t>
             </a:r>
           </a:p>
         </p:txBody>
@@ -4941,8 +4941,8 @@
         </p:nvSpPr>
         <p:spPr>
           <a:xfrm>
-            <a:off x="9710928" y="1133856"/>
-            <a:ext cx="2286000" cy="960120"/>
+            <a:off x="7077456" y="1115568"/>
+            <a:ext cx="1664208" cy="822960"/>
           </a:xfrm>
           <a:prstGeom prst="rect">
             <a:avLst/>
@@ -4984,8 +4984,8 @@
         </p:nvSpPr>
         <p:spPr>
           <a:xfrm>
-            <a:off x="9820655" y="1161288"/>
-            <a:ext cx="2066543" cy="896112"/>
+            <a:off x="7150608" y="1143000"/>
+            <a:ext cx="1517904" cy="768096"/>
           </a:xfrm>
           <a:prstGeom prst="rect">
             <a:avLst/>
@@ -5000,13 +5000,13 @@
           <a:p>
             <a:pPr algn="ctr"/>
             <a:r>
-              <a:rPr sz="1300" b="1" i="0">
+              <a:rPr sz="1000" b="1" i="0">
                 <a:solidFill>
                   <a:srgbClr val="FFFFFF"/>
                 </a:solidFill>
               </a:rPr>
               <a:t>Synthèse &amp;
-Certification</a:t>
+Certif.</a:t>
             </a:r>
           </a:p>
         </p:txBody>
@@ -5019,8 +5019,8 @@
         </p:nvSpPr>
         <p:spPr>
           <a:xfrm>
-            <a:off x="9710928" y="2093976"/>
-            <a:ext cx="2286000" cy="3291840"/>
+            <a:off x="7077456" y="1938528"/>
+            <a:ext cx="1664208" cy="3429000"/>
           </a:xfrm>
           <a:prstGeom prst="rect">
             <a:avLst/>
@@ -5028,7 +5028,7 @@
           <a:solidFill>
             <a:srgbClr val="FFFFFF"/>
           </a:solidFill>
-          <a:ln w="19050">
+          <a:ln w="12700">
             <a:solidFill>
               <a:srgbClr val="008080"/>
             </a:solidFill>
@@ -5064,8 +5064,8 @@
         </p:nvSpPr>
         <p:spPr>
           <a:xfrm>
-            <a:off x="9838944" y="2167128"/>
-            <a:ext cx="2029968" cy="3127248"/>
+            <a:off x="7168896" y="1993392"/>
+            <a:ext cx="1481328" cy="3200400"/>
           </a:xfrm>
           <a:prstGeom prst="rect">
             <a:avLst/>
@@ -5080,12 +5080,12 @@
           <a:p>
             <a:pPr algn="l"/>
             <a:r>
-              <a:rPr sz="1000" b="0" i="0">
+              <a:rPr sz="800" b="0" i="0">
                 <a:solidFill>
                   <a:srgbClr val="1A1A1A"/>
                 </a:solidFill>
               </a:rPr>
-              <a:t>Simulations d'appels complets · Grille 24 critères · Quiz 40 questions · Remise des certifications</a:t>
+              <a:t>Simulations · Grille 24 critères · Quiz 40 questions · Remise certifications</a:t>
             </a:r>
           </a:p>
         </p:txBody>
@@ -5098,8 +5098,85 @@
         </p:nvSpPr>
         <p:spPr>
           <a:xfrm>
-            <a:off x="274320" y="5532120"/>
-            <a:ext cx="11640312" cy="347472"/>
+            <a:off x="8778240" y="804672"/>
+            <a:ext cx="1664208" cy="310896"/>
+          </a:xfrm>
+          <a:prstGeom prst="rect">
+            <a:avLst/>
+          </a:prstGeom>
+          <a:solidFill>
+            <a:srgbClr val="005050"/>
+          </a:solidFill>
+          <a:ln>
+            <a:noFill/>
+          </a:ln>
+        </p:spPr>
+        <p:style>
+          <a:lnRef idx="1">
+            <a:schemeClr val="accent1"/>
+          </a:lnRef>
+          <a:fillRef idx="3">
+            <a:schemeClr val="accent1"/>
+          </a:fillRef>
+          <a:effectRef idx="2">
+            <a:schemeClr val="accent1"/>
+          </a:effectRef>
+          <a:fontRef idx="minor">
+            <a:schemeClr val="lt1"/>
+          </a:fontRef>
+        </p:style>
+        <p:txBody>
+          <a:bodyPr rtlCol="0" anchor="ctr"/>
+          <a:lstStyle/>
+          <a:p>
+            <a:pPr algn="ctr"/>
+          </a:p>
+        </p:txBody>
+      </p:sp>
+      <p:sp>
+        <p:nvSpPr>
+          <p:cNvPr id="42" name="TextBox 41"/>
+          <p:cNvSpPr txBox="1"/>
+          <p:nvPr/>
+        </p:nvSpPr>
+        <p:spPr>
+          <a:xfrm>
+            <a:off x="8833104" y="832104"/>
+            <a:ext cx="1554480" cy="237744"/>
+          </a:xfrm>
+          <a:prstGeom prst="rect">
+            <a:avLst/>
+          </a:prstGeom>
+          <a:noFill/>
+        </p:spPr>
+        <p:txBody>
+          <a:bodyPr wrap="square">
+            <a:spAutoFit/>
+          </a:bodyPr>
+          <a:lstStyle/>
+          <a:p>
+            <a:pPr algn="l"/>
+            <a:r>
+              <a:rPr sz="900" b="1" i="0">
+                <a:solidFill>
+                  <a:srgbClr val="FFFFFF"/>
+                </a:solidFill>
+              </a:rPr>
+              <a:t>J6</a:t>
+            </a:r>
+          </a:p>
+        </p:txBody>
+      </p:sp>
+      <p:sp>
+        <p:nvSpPr>
+          <p:cNvPr id="43" name="Rectangle 42"/>
+          <p:cNvSpPr/>
+          <p:nvPr/>
+        </p:nvSpPr>
+        <p:spPr>
+          <a:xfrm>
+            <a:off x="8778240" y="1115568"/>
+            <a:ext cx="1664208" cy="822960"/>
           </a:xfrm>
           <a:prstGeom prst="rect">
             <a:avLst/>
@@ -5135,7 +5212,398 @@
       </p:sp>
       <p:sp>
         <p:nvSpPr>
-          <p:cNvPr id="42" name="TextBox 41"/>
+          <p:cNvPr id="44" name="TextBox 43"/>
+          <p:cNvSpPr txBox="1"/>
+          <p:nvPr/>
+        </p:nvSpPr>
+        <p:spPr>
+          <a:xfrm>
+            <a:off x="8851392" y="1143000"/>
+            <a:ext cx="1517904" cy="768096"/>
+          </a:xfrm>
+          <a:prstGeom prst="rect">
+            <a:avLst/>
+          </a:prstGeom>
+          <a:noFill/>
+        </p:spPr>
+        <p:txBody>
+          <a:bodyPr wrap="square">
+            <a:spAutoFit/>
+          </a:bodyPr>
+          <a:lstStyle/>
+          <a:p>
+            <a:pPr algn="ctr"/>
+            <a:r>
+              <a:rPr sz="1000" b="1" i="0">
+                <a:solidFill>
+                  <a:srgbClr val="FFFFFF"/>
+                </a:solidFill>
+              </a:rPr>
+              <a:t>Atelier
+Pratique 1</a:t>
+            </a:r>
+          </a:p>
+        </p:txBody>
+      </p:sp>
+      <p:sp>
+        <p:nvSpPr>
+          <p:cNvPr id="45" name="Rectangle 44"/>
+          <p:cNvSpPr/>
+          <p:nvPr/>
+        </p:nvSpPr>
+        <p:spPr>
+          <a:xfrm>
+            <a:off x="8778240" y="1938528"/>
+            <a:ext cx="1664208" cy="3429000"/>
+          </a:xfrm>
+          <a:prstGeom prst="rect">
+            <a:avLst/>
+          </a:prstGeom>
+          <a:solidFill>
+            <a:srgbClr val="FFFFFF"/>
+          </a:solidFill>
+          <a:ln w="12700">
+            <a:solidFill>
+              <a:srgbClr val="008080"/>
+            </a:solidFill>
+          </a:ln>
+        </p:spPr>
+        <p:style>
+          <a:lnRef idx="1">
+            <a:schemeClr val="accent1"/>
+          </a:lnRef>
+          <a:fillRef idx="3">
+            <a:schemeClr val="accent1"/>
+          </a:fillRef>
+          <a:effectRef idx="2">
+            <a:schemeClr val="accent1"/>
+          </a:effectRef>
+          <a:fontRef idx="minor">
+            <a:schemeClr val="lt1"/>
+          </a:fontRef>
+        </p:style>
+        <p:txBody>
+          <a:bodyPr rtlCol="0" anchor="ctr"/>
+          <a:lstStyle/>
+          <a:p>
+            <a:pPr algn="ctr"/>
+          </a:p>
+        </p:txBody>
+      </p:sp>
+      <p:sp>
+        <p:nvSpPr>
+          <p:cNvPr id="46" name="TextBox 45"/>
+          <p:cNvSpPr txBox="1"/>
+          <p:nvPr/>
+        </p:nvSpPr>
+        <p:spPr>
+          <a:xfrm>
+            <a:off x="8869680" y="1993392"/>
+            <a:ext cx="1481328" cy="3200400"/>
+          </a:xfrm>
+          <a:prstGeom prst="rect">
+            <a:avLst/>
+          </a:prstGeom>
+          <a:noFill/>
+        </p:spPr>
+        <p:txBody>
+          <a:bodyPr wrap="square">
+            <a:spAutoFit/>
+          </a:bodyPr>
+          <a:lstStyle/>
+          <a:p>
+            <a:pPr algn="l"/>
+            <a:r>
+              <a:rPr sz="800" b="0" i="0">
+                <a:solidFill>
+                  <a:srgbClr val="1A1A1A"/>
+                </a:solidFill>
+              </a:rPr>
+              <a:t>Appels simulés live · Grille formateur · Feedback immédiat · Cas complexes</a:t>
+            </a:r>
+          </a:p>
+        </p:txBody>
+      </p:sp>
+      <p:sp>
+        <p:nvSpPr>
+          <p:cNvPr id="47" name="Rectangle 46"/>
+          <p:cNvSpPr/>
+          <p:nvPr/>
+        </p:nvSpPr>
+        <p:spPr>
+          <a:xfrm>
+            <a:off x="10479024" y="804672"/>
+            <a:ext cx="1664208" cy="310896"/>
+          </a:xfrm>
+          <a:prstGeom prst="rect">
+            <a:avLst/>
+          </a:prstGeom>
+          <a:solidFill>
+            <a:srgbClr val="005050"/>
+          </a:solidFill>
+          <a:ln>
+            <a:noFill/>
+          </a:ln>
+        </p:spPr>
+        <p:style>
+          <a:lnRef idx="1">
+            <a:schemeClr val="accent1"/>
+          </a:lnRef>
+          <a:fillRef idx="3">
+            <a:schemeClr val="accent1"/>
+          </a:fillRef>
+          <a:effectRef idx="2">
+            <a:schemeClr val="accent1"/>
+          </a:effectRef>
+          <a:fontRef idx="minor">
+            <a:schemeClr val="lt1"/>
+          </a:fontRef>
+        </p:style>
+        <p:txBody>
+          <a:bodyPr rtlCol="0" anchor="ctr"/>
+          <a:lstStyle/>
+          <a:p>
+            <a:pPr algn="ctr"/>
+          </a:p>
+        </p:txBody>
+      </p:sp>
+      <p:sp>
+        <p:nvSpPr>
+          <p:cNvPr id="48" name="TextBox 47"/>
+          <p:cNvSpPr txBox="1"/>
+          <p:nvPr/>
+        </p:nvSpPr>
+        <p:spPr>
+          <a:xfrm>
+            <a:off x="10533888" y="832104"/>
+            <a:ext cx="1554480" cy="237744"/>
+          </a:xfrm>
+          <a:prstGeom prst="rect">
+            <a:avLst/>
+          </a:prstGeom>
+          <a:noFill/>
+        </p:spPr>
+        <p:txBody>
+          <a:bodyPr wrap="square">
+            <a:spAutoFit/>
+          </a:bodyPr>
+          <a:lstStyle/>
+          <a:p>
+            <a:pPr algn="l"/>
+            <a:r>
+              <a:rPr sz="900" b="1" i="0">
+                <a:solidFill>
+                  <a:srgbClr val="FFFFFF"/>
+                </a:solidFill>
+              </a:rPr>
+              <a:t>J7</a:t>
+            </a:r>
+          </a:p>
+        </p:txBody>
+      </p:sp>
+      <p:sp>
+        <p:nvSpPr>
+          <p:cNvPr id="49" name="Rectangle 48"/>
+          <p:cNvSpPr/>
+          <p:nvPr/>
+        </p:nvSpPr>
+        <p:spPr>
+          <a:xfrm>
+            <a:off x="10479024" y="1115568"/>
+            <a:ext cx="1664208" cy="822960"/>
+          </a:xfrm>
+          <a:prstGeom prst="rect">
+            <a:avLst/>
+          </a:prstGeom>
+          <a:solidFill>
+            <a:srgbClr val="008080"/>
+          </a:solidFill>
+          <a:ln>
+            <a:noFill/>
+          </a:ln>
+        </p:spPr>
+        <p:style>
+          <a:lnRef idx="1">
+            <a:schemeClr val="accent1"/>
+          </a:lnRef>
+          <a:fillRef idx="3">
+            <a:schemeClr val="accent1"/>
+          </a:fillRef>
+          <a:effectRef idx="2">
+            <a:schemeClr val="accent1"/>
+          </a:effectRef>
+          <a:fontRef idx="minor">
+            <a:schemeClr val="lt1"/>
+          </a:fontRef>
+        </p:style>
+        <p:txBody>
+          <a:bodyPr rtlCol="0" anchor="ctr"/>
+          <a:lstStyle/>
+          <a:p>
+            <a:pPr algn="ctr"/>
+          </a:p>
+        </p:txBody>
+      </p:sp>
+      <p:sp>
+        <p:nvSpPr>
+          <p:cNvPr id="50" name="TextBox 49"/>
+          <p:cNvSpPr txBox="1"/>
+          <p:nvPr/>
+        </p:nvSpPr>
+        <p:spPr>
+          <a:xfrm>
+            <a:off x="10552176" y="1143000"/>
+            <a:ext cx="1517904" cy="768096"/>
+          </a:xfrm>
+          <a:prstGeom prst="rect">
+            <a:avLst/>
+          </a:prstGeom>
+          <a:noFill/>
+        </p:spPr>
+        <p:txBody>
+          <a:bodyPr wrap="square">
+            <a:spAutoFit/>
+          </a:bodyPr>
+          <a:lstStyle/>
+          <a:p>
+            <a:pPr algn="ctr"/>
+            <a:r>
+              <a:rPr sz="1000" b="1" i="0">
+                <a:solidFill>
+                  <a:srgbClr val="FFFFFF"/>
+                </a:solidFill>
+              </a:rPr>
+              <a:t>Atelier
+Pratique 2</a:t>
+            </a:r>
+          </a:p>
+        </p:txBody>
+      </p:sp>
+      <p:sp>
+        <p:nvSpPr>
+          <p:cNvPr id="51" name="Rectangle 50"/>
+          <p:cNvSpPr/>
+          <p:nvPr/>
+        </p:nvSpPr>
+        <p:spPr>
+          <a:xfrm>
+            <a:off x="10479024" y="1938528"/>
+            <a:ext cx="1664208" cy="3429000"/>
+          </a:xfrm>
+          <a:prstGeom prst="rect">
+            <a:avLst/>
+          </a:prstGeom>
+          <a:solidFill>
+            <a:srgbClr val="FFFFFF"/>
+          </a:solidFill>
+          <a:ln w="12700">
+            <a:solidFill>
+              <a:srgbClr val="008080"/>
+            </a:solidFill>
+          </a:ln>
+        </p:spPr>
+        <p:style>
+          <a:lnRef idx="1">
+            <a:schemeClr val="accent1"/>
+          </a:lnRef>
+          <a:fillRef idx="3">
+            <a:schemeClr val="accent1"/>
+          </a:fillRef>
+          <a:effectRef idx="2">
+            <a:schemeClr val="accent1"/>
+          </a:effectRef>
+          <a:fontRef idx="minor">
+            <a:schemeClr val="lt1"/>
+          </a:fontRef>
+        </p:style>
+        <p:txBody>
+          <a:bodyPr rtlCol="0" anchor="ctr"/>
+          <a:lstStyle/>
+          <a:p>
+            <a:pPr algn="ctr"/>
+          </a:p>
+        </p:txBody>
+      </p:sp>
+      <p:sp>
+        <p:nvSpPr>
+          <p:cNvPr id="52" name="TextBox 51"/>
+          <p:cNvSpPr txBox="1"/>
+          <p:nvPr/>
+        </p:nvSpPr>
+        <p:spPr>
+          <a:xfrm>
+            <a:off x="10570464" y="1993392"/>
+            <a:ext cx="1481328" cy="3200400"/>
+          </a:xfrm>
+          <a:prstGeom prst="rect">
+            <a:avLst/>
+          </a:prstGeom>
+          <a:noFill/>
+        </p:spPr>
+        <p:txBody>
+          <a:bodyPr wrap="square">
+            <a:spAutoFit/>
+          </a:bodyPr>
+          <a:lstStyle/>
+          <a:p>
+            <a:pPr algn="l"/>
+            <a:r>
+              <a:rPr sz="800" b="0" i="0">
+                <a:solidFill>
+                  <a:srgbClr val="1A1A1A"/>
+                </a:solidFill>
+              </a:rPr>
+              <a:t>Perfectionnement · Certification finale · Plan prise de poste J+0→J+30</a:t>
+            </a:r>
+          </a:p>
+        </p:txBody>
+      </p:sp>
+      <p:sp>
+        <p:nvSpPr>
+          <p:cNvPr id="53" name="Rectangle 52"/>
+          <p:cNvSpPr/>
+          <p:nvPr/>
+        </p:nvSpPr>
+        <p:spPr>
+          <a:xfrm>
+            <a:off x="274320" y="5532120"/>
+            <a:ext cx="11640312" cy="347472"/>
+          </a:xfrm>
+          <a:prstGeom prst="rect">
+            <a:avLst/>
+          </a:prstGeom>
+          <a:solidFill>
+            <a:srgbClr val="008080"/>
+          </a:solidFill>
+          <a:ln>
+            <a:noFill/>
+          </a:ln>
+        </p:spPr>
+        <p:style>
+          <a:lnRef idx="1">
+            <a:schemeClr val="accent1"/>
+          </a:lnRef>
+          <a:fillRef idx="3">
+            <a:schemeClr val="accent1"/>
+          </a:fillRef>
+          <a:effectRef idx="2">
+            <a:schemeClr val="accent1"/>
+          </a:effectRef>
+          <a:fontRef idx="minor">
+            <a:schemeClr val="lt1"/>
+          </a:fontRef>
+        </p:style>
+        <p:txBody>
+          <a:bodyPr rtlCol="0" anchor="ctr"/>
+          <a:lstStyle/>
+          <a:p>
+            <a:pPr algn="ctr"/>
+          </a:p>
+        </p:txBody>
+      </p:sp>
+      <p:sp>
+        <p:nvSpPr>
+          <p:cNvPr id="54" name="TextBox 53"/>
           <p:cNvSpPr txBox="1"/>
           <p:nvPr/>
         </p:nvSpPr>
@@ -5162,7 +5630,7 @@
                   <a:srgbClr val="FFFFFF"/>
                 </a:solidFill>
               </a:rPr>
-              <a:t>35 heures de formation intensive · Organisation journée production : 9h30–17h30 · 6h40 de production effective</a:t>
+              <a:t>35h formation + 2 ateliers pratiques · 9h30–17h30 · 6h40 production effective · Certification FIDELIS × UNICEF France</a:t>
             </a:r>
           </a:p>
         </p:txBody>
@@ -5243,7 +5711,7 @@
             <a:avLst/>
           </a:prstGeom>
           <a:solidFill>
-            <a:srgbClr val="005555"/>
+            <a:srgbClr val="005050"/>
           </a:solidFill>
           <a:ln>
             <a:noFill/>
@@ -5322,8 +5790,8 @@
         </p:nvSpPr>
         <p:spPr>
           <a:xfrm>
-            <a:off x="164592" y="73152"/>
-            <a:ext cx="2011680" cy="347472"/>
+            <a:off x="164592" y="91440"/>
+            <a:ext cx="1920240" cy="329184"/>
           </a:xfrm>
           <a:prstGeom prst="rect">
             <a:avLst/>
@@ -5356,8 +5824,8 @@
         </p:nvSpPr>
         <p:spPr>
           <a:xfrm>
-            <a:off x="2286000" y="91440"/>
-            <a:ext cx="36576" cy="502920"/>
+            <a:off x="2212848" y="109728"/>
+            <a:ext cx="36576" cy="475488"/>
           </a:xfrm>
           <a:prstGeom prst="rect">
             <a:avLst/>
@@ -5399,8 +5867,8 @@
         </p:nvSpPr>
         <p:spPr>
           <a:xfrm>
-            <a:off x="2423160" y="91440"/>
-            <a:ext cx="9235440" cy="502920"/>
+            <a:off x="2350008" y="91440"/>
+            <a:ext cx="8823960" cy="502920"/>
           </a:xfrm>
           <a:prstGeom prst="rect">
             <a:avLst/>
@@ -5441,8 +5909,8 @@
         </p:blipFill>
         <p:spPr>
           <a:xfrm>
-            <a:off x="11247120" y="0"/>
-            <a:ext cx="822960" cy="676656"/>
+            <a:off x="11228832" y="0"/>
+            <a:ext cx="841248" cy="676656"/>
           </a:xfrm>
           <a:prstGeom prst="rect">
             <a:avLst/>
@@ -5464,7 +5932,7 @@
             <a:avLst/>
           </a:prstGeom>
           <a:solidFill>
-            <a:srgbClr val="005555"/>
+            <a:srgbClr val="005050"/>
           </a:solidFill>
           <a:ln>
             <a:noFill/>
@@ -5598,7 +6066,7 @@
                   <a:srgbClr val="FFFFFF"/>
                 </a:solidFill>
               </a:rPr>
-              <a:t>Vos engagements en tant qu'apprenant</a:t>
+              <a:t>Vos engagements</a:t>
             </a:r>
           </a:p>
         </p:txBody>
@@ -6386,7 +6854,7 @@
                   <a:srgbClr val="1A1A1A"/>
                 </a:solidFill>
               </a:rPr>
-              <a:t>• Un suivi après la formation à J+15 et J+30</a:t>
+              <a:t>• Un suivi à J+15 et J+30 après la formation</a:t>
             </a:r>
           </a:p>
         </p:txBody>
@@ -6542,7 +7010,7 @@
                   <a:srgbClr val="FFFFFF"/>
                 </a:solidFill>
               </a:rPr>
-              <a:t>Droit à l'erreur garanti — Chaque simulation ratée est un pas vers la maîtrise. Mantra de la formation : « Le refus d'aujourd'hui peut être le don de demain »</a:t>
+              <a:t>Mantra de la formation : « Le refus d'aujourd'hui peut être le don de demain »</a:t>
             </a:r>
           </a:p>
         </p:txBody>
@@ -6580,7 +7048,7 @@
             <a:avLst/>
           </a:prstGeom>
           <a:solidFill>
-            <a:srgbClr val="F0F7F7"/>
+            <a:srgbClr val="005050"/>
           </a:solidFill>
           <a:ln>
             <a:noFill/>
@@ -6617,50 +7085,7 @@
         <p:spPr>
           <a:xfrm>
             <a:off x="0" y="0"/>
-            <a:ext cx="12188952" cy="685800"/>
-          </a:xfrm>
-          <a:prstGeom prst="rect">
-            <a:avLst/>
-          </a:prstGeom>
-          <a:solidFill>
-            <a:srgbClr val="005555"/>
-          </a:solidFill>
-          <a:ln>
-            <a:noFill/>
-          </a:ln>
-        </p:spPr>
-        <p:style>
-          <a:lnRef idx="1">
-            <a:schemeClr val="accent1"/>
-          </a:lnRef>
-          <a:fillRef idx="3">
-            <a:schemeClr val="accent1"/>
-          </a:fillRef>
-          <a:effectRef idx="2">
-            <a:schemeClr val="accent1"/>
-          </a:effectRef>
-          <a:fontRef idx="minor">
-            <a:schemeClr val="lt1"/>
-          </a:fontRef>
-        </p:style>
-        <p:txBody>
-          <a:bodyPr rtlCol="0" anchor="ctr"/>
-          <a:lstStyle/>
-          <a:p>
-            <a:pPr algn="ctr"/>
-          </a:p>
-        </p:txBody>
-      </p:sp>
-      <p:sp>
-        <p:nvSpPr>
-          <p:cNvPr id="4" name="Rectangle 3"/>
-          <p:cNvSpPr/>
-          <p:nvPr/>
-        </p:nvSpPr>
-        <p:spPr>
-          <a:xfrm>
-            <a:off x="0" y="667512"/>
-            <a:ext cx="12188952" cy="45720"/>
+            <a:ext cx="12188952" cy="73152"/>
           </a:xfrm>
           <a:prstGeom prst="rect">
             <a:avLst/>
@@ -6696,48 +7121,14 @@
       </p:sp>
       <p:sp>
         <p:nvSpPr>
-          <p:cNvPr id="5" name="TextBox 4"/>
-          <p:cNvSpPr txBox="1"/>
-          <p:nvPr/>
-        </p:nvSpPr>
-        <p:spPr>
-          <a:xfrm>
-            <a:off x="164592" y="73152"/>
-            <a:ext cx="2011680" cy="347472"/>
-          </a:xfrm>
-          <a:prstGeom prst="rect">
-            <a:avLst/>
-          </a:prstGeom>
-          <a:noFill/>
-        </p:spPr>
-        <p:txBody>
-          <a:bodyPr wrap="square">
-            <a:spAutoFit/>
-          </a:bodyPr>
-          <a:lstStyle/>
-          <a:p>
-            <a:pPr algn="l"/>
-            <a:r>
-              <a:rPr sz="1400" b="1" i="0">
-                <a:solidFill>
-                  <a:srgbClr val="FFFFFF"/>
-                </a:solidFill>
-              </a:rPr>
-              <a:t>SHY-Performance</a:t>
-            </a:r>
-          </a:p>
-        </p:txBody>
-      </p:sp>
-      <p:sp>
-        <p:nvSpPr>
-          <p:cNvPr id="6" name="Rectangle 5"/>
+          <p:cNvPr id="4" name="Rectangle 3"/>
           <p:cNvSpPr/>
           <p:nvPr/>
         </p:nvSpPr>
         <p:spPr>
           <a:xfrm>
-            <a:off x="2286000" y="91440"/>
-            <a:ext cx="36576" cy="502920"/>
+            <a:off x="0" y="6784848"/>
+            <a:ext cx="12188952" cy="73152"/>
           </a:xfrm>
           <a:prstGeom prst="rect">
             <a:avLst/>
@@ -6773,14 +7164,57 @@
       </p:sp>
       <p:sp>
         <p:nvSpPr>
-          <p:cNvPr id="7" name="TextBox 6"/>
+          <p:cNvPr id="5" name="Oval 4"/>
+          <p:cNvSpPr/>
+          <p:nvPr/>
+        </p:nvSpPr>
+        <p:spPr>
+          <a:xfrm>
+            <a:off x="4114800" y="1097280"/>
+            <a:ext cx="3931920" cy="3931920"/>
+          </a:xfrm>
+          <a:prstGeom prst="ellipse">
+            <a:avLst/>
+          </a:prstGeom>
+          <a:solidFill>
+            <a:srgbClr val="006A6A"/>
+          </a:solidFill>
+          <a:ln>
+            <a:noFill/>
+          </a:ln>
+        </p:spPr>
+        <p:style>
+          <a:lnRef idx="1">
+            <a:schemeClr val="accent1"/>
+          </a:lnRef>
+          <a:fillRef idx="3">
+            <a:schemeClr val="accent1"/>
+          </a:fillRef>
+          <a:effectRef idx="2">
+            <a:schemeClr val="accent1"/>
+          </a:effectRef>
+          <a:fontRef idx="minor">
+            <a:schemeClr val="lt1"/>
+          </a:fontRef>
+        </p:style>
+        <p:txBody>
+          <a:bodyPr rtlCol="0" anchor="ctr"/>
+          <a:lstStyle/>
+          <a:p>
+            <a:pPr algn="ctr"/>
+          </a:p>
+        </p:txBody>
+      </p:sp>
+      <p:sp>
+        <p:nvSpPr>
+          <p:cNvPr id="6" name="TextBox 5"/>
           <p:cNvSpPr txBox="1"/>
           <p:nvPr/>
         </p:nvSpPr>
         <p:spPr>
           <a:xfrm>
-            <a:off x="2423160" y="91440"/>
-            <a:ext cx="9235440" cy="502920"/>
+            <a:off x="5029200" y="2011680"/>
+            <a:ext cx="2103120" cy="1371600"/>
           </a:xfrm>
           <a:prstGeom prst="rect">
             <a:avLst/>
@@ -6793,21 +7227,191 @@
           </a:bodyPr>
           <a:lstStyle/>
           <a:p>
-            <a:pPr algn="l"/>
-            <a:r>
-              <a:rPr sz="1600" b="1" i="0">
+            <a:pPr algn="ctr"/>
+            <a:r>
+              <a:rPr sz="4800" b="0" i="0">
                 <a:solidFill>
                   <a:srgbClr val="FFFFFF"/>
                 </a:solidFill>
               </a:rPr>
-              <a:t>Votre Livret Personnel — Journal de Bord Quotidien</a:t>
+              <a:t>🙏</a:t>
+            </a:r>
+          </a:p>
+        </p:txBody>
+      </p:sp>
+      <p:sp>
+        <p:nvSpPr>
+          <p:cNvPr id="7" name="TextBox 6"/>
+          <p:cNvSpPr txBox="1"/>
+          <p:nvPr/>
+        </p:nvSpPr>
+        <p:spPr>
+          <a:xfrm>
+            <a:off x="1371600" y="1280160"/>
+            <a:ext cx="9418320" cy="1097280"/>
+          </a:xfrm>
+          <a:prstGeom prst="rect">
+            <a:avLst/>
+          </a:prstGeom>
+          <a:noFill/>
+        </p:spPr>
+        <p:txBody>
+          <a:bodyPr wrap="square">
+            <a:spAutoFit/>
+          </a:bodyPr>
+          <a:lstStyle/>
+          <a:p>
+            <a:pPr algn="ctr"/>
+            <a:r>
+              <a:rPr sz="4600" b="1" i="0">
+                <a:solidFill>
+                  <a:srgbClr val="FFFFFF"/>
+                </a:solidFill>
+              </a:rPr>
+              <a:t>Merci à Tous !</a:t>
+            </a:r>
+          </a:p>
+        </p:txBody>
+      </p:sp>
+      <p:sp>
+        <p:nvSpPr>
+          <p:cNvPr id="8" name="TextBox 7"/>
+          <p:cNvSpPr txBox="1"/>
+          <p:nvPr/>
+        </p:nvSpPr>
+        <p:spPr>
+          <a:xfrm>
+            <a:off x="1371600" y="2606040"/>
+            <a:ext cx="9418320" cy="548640"/>
+          </a:xfrm>
+          <a:prstGeom prst="rect">
+            <a:avLst/>
+          </a:prstGeom>
+          <a:noFill/>
+        </p:spPr>
+        <p:txBody>
+          <a:bodyPr wrap="square">
+            <a:spAutoFit/>
+          </a:bodyPr>
+          <a:lstStyle/>
+          <a:p>
+            <a:pPr algn="ctr"/>
+            <a:r>
+              <a:rPr sz="1800" b="0" i="1">
+                <a:solidFill>
+                  <a:srgbClr val="CCEEEE"/>
+                </a:solidFill>
+              </a:rPr>
+              <a:t>Votre engagement fait la différence pour les enfants du monde entier.</a:t>
+            </a:r>
+          </a:p>
+        </p:txBody>
+      </p:sp>
+      <p:sp>
+        <p:nvSpPr>
+          <p:cNvPr id="9" name="TextBox 8"/>
+          <p:cNvSpPr txBox="1"/>
+          <p:nvPr/>
+        </p:nvSpPr>
+        <p:spPr>
+          <a:xfrm>
+            <a:off x="1371600" y="3246120"/>
+            <a:ext cx="9418320" cy="347472"/>
+          </a:xfrm>
+          <a:prstGeom prst="rect">
+            <a:avLst/>
+          </a:prstGeom>
+          <a:noFill/>
+        </p:spPr>
+        <p:txBody>
+          <a:bodyPr wrap="square">
+            <a:spAutoFit/>
+          </a:bodyPr>
+          <a:lstStyle/>
+          <a:p>
+            <a:pPr algn="ctr"/>
+            <a:r>
+              <a:rPr sz="1200" b="0" i="0">
+                <a:solidFill>
+                  <a:srgbClr val="88DDDD"/>
+                </a:solidFill>
+              </a:rPr>
+              <a:t>Book 0 — Fil Conducteur · Formation FIM</a:t>
+            </a:r>
+          </a:p>
+        </p:txBody>
+      </p:sp>
+      <p:sp>
+        <p:nvSpPr>
+          <p:cNvPr id="10" name="TextBox 9"/>
+          <p:cNvSpPr txBox="1"/>
+          <p:nvPr/>
+        </p:nvSpPr>
+        <p:spPr>
+          <a:xfrm>
+            <a:off x="1828800" y="3749039"/>
+            <a:ext cx="8531352" cy="457200"/>
+          </a:xfrm>
+          <a:prstGeom prst="rect">
+            <a:avLst/>
+          </a:prstGeom>
+          <a:noFill/>
+        </p:spPr>
+        <p:txBody>
+          <a:bodyPr wrap="square">
+            <a:spAutoFit/>
+          </a:bodyPr>
+          <a:lstStyle/>
+          <a:p>
+            <a:pPr algn="ctr"/>
+            <a:r>
+              <a:rPr sz="1400" b="0" i="1">
+                <a:solidFill>
+                  <a:srgbClr val="AADDDD"/>
+                </a:solidFill>
+              </a:rPr>
+              <a:t>« Le refus d'aujourd'hui peut être le don de demain »</a:t>
+            </a:r>
+          </a:p>
+        </p:txBody>
+      </p:sp>
+      <p:sp>
+        <p:nvSpPr>
+          <p:cNvPr id="11" name="TextBox 10"/>
+          <p:cNvSpPr txBox="1"/>
+          <p:nvPr/>
+        </p:nvSpPr>
+        <p:spPr>
+          <a:xfrm>
+            <a:off x="0" y="4572000"/>
+            <a:ext cx="12188952" cy="329184"/>
+          </a:xfrm>
+          <a:prstGeom prst="rect">
+            <a:avLst/>
+          </a:prstGeom>
+          <a:noFill/>
+        </p:spPr>
+        <p:txBody>
+          <a:bodyPr wrap="square">
+            <a:spAutoFit/>
+          </a:bodyPr>
+          <a:lstStyle/>
+          <a:p>
+            <a:pPr algn="ctr"/>
+            <a:r>
+              <a:rPr sz="1000" b="0" i="0">
+                <a:solidFill>
+                  <a:srgbClr val="88DDDD"/>
+                </a:solidFill>
+              </a:rPr>
+              <a:t>SHY-Performance  ·  Formation FIM  ·  UNICEF France  ·  V6-01062026SHY-TE</a:t>
             </a:r>
           </a:p>
         </p:txBody>
       </p:sp>
       <p:pic>
         <p:nvPicPr>
-          <p:cNvPr id="8" name="Picture 7" descr="shy_logo_v2.png"/>
+          <p:cNvPr id="12" name="Picture 11" descr="shy_logo_v2.png"/>
           <p:cNvPicPr>
             <a:picLocks noChangeAspect="1"/>
           </p:cNvPicPr>
@@ -6821,8 +7425,8 @@
         </p:blipFill>
         <p:spPr>
           <a:xfrm>
-            <a:off x="11247120" y="0"/>
-            <a:ext cx="822960" cy="676656"/>
+            <a:off x="5669280" y="5120640"/>
+            <a:ext cx="914400" cy="896112"/>
           </a:xfrm>
           <a:prstGeom prst="rect">
             <a:avLst/>
@@ -6831,57 +7435,14 @@
       </p:pic>
       <p:sp>
         <p:nvSpPr>
-          <p:cNvPr id="9" name="Rectangle 8"/>
-          <p:cNvSpPr/>
-          <p:nvPr/>
-        </p:nvSpPr>
-        <p:spPr>
-          <a:xfrm>
-            <a:off x="0" y="6492240"/>
-            <a:ext cx="12188952" cy="365760"/>
-          </a:xfrm>
-          <a:prstGeom prst="rect">
-            <a:avLst/>
-          </a:prstGeom>
-          <a:solidFill>
-            <a:srgbClr val="005555"/>
-          </a:solidFill>
-          <a:ln>
-            <a:noFill/>
-          </a:ln>
-        </p:spPr>
-        <p:style>
-          <a:lnRef idx="1">
-            <a:schemeClr val="accent1"/>
-          </a:lnRef>
-          <a:fillRef idx="3">
-            <a:schemeClr val="accent1"/>
-          </a:fillRef>
-          <a:effectRef idx="2">
-            <a:schemeClr val="accent1"/>
-          </a:effectRef>
-          <a:fontRef idx="minor">
-            <a:schemeClr val="lt1"/>
-          </a:fontRef>
-        </p:style>
-        <p:txBody>
-          <a:bodyPr rtlCol="0" anchor="ctr"/>
-          <a:lstStyle/>
-          <a:p>
-            <a:pPr algn="ctr"/>
-          </a:p>
-        </p:txBody>
-      </p:sp>
-      <p:sp>
-        <p:nvSpPr>
-          <p:cNvPr id="10" name="TextBox 9"/>
+          <p:cNvPr id="13" name="TextBox 12"/>
           <p:cNvSpPr txBox="1"/>
           <p:nvPr/>
         </p:nvSpPr>
         <p:spPr>
           <a:xfrm>
-            <a:off x="0" y="6519672"/>
-            <a:ext cx="12188952" cy="274320"/>
+            <a:off x="0" y="6035040"/>
+            <a:ext cx="12188952" cy="329184"/>
           </a:xfrm>
           <a:prstGeom prst="rect">
             <a:avLst/>
@@ -6896,887 +7457,12 @@
           <a:p>
             <a:pPr algn="ctr"/>
             <a:r>
-              <a:rPr sz="800" b="0" i="0">
+              <a:rPr sz="1000" b="1" i="0">
                 <a:solidFill>
                   <a:srgbClr val="FFFFFF"/>
                 </a:solidFill>
               </a:rPr>
-              <a:t>SHY-Performance  ·  Formation FIM  ·  UNICEF France  ·  V6-01062026SHY-TE</a:t>
-            </a:r>
-          </a:p>
-        </p:txBody>
-      </p:sp>
-      <p:sp>
-        <p:nvSpPr>
-          <p:cNvPr id="11" name="TextBox 10"/>
-          <p:cNvSpPr txBox="1"/>
-          <p:nvPr/>
-        </p:nvSpPr>
-        <p:spPr>
-          <a:xfrm>
-            <a:off x="320040" y="804672"/>
-            <a:ext cx="11430000" cy="320040"/>
-          </a:xfrm>
-          <a:prstGeom prst="rect">
-            <a:avLst/>
-          </a:prstGeom>
-          <a:noFill/>
-        </p:spPr>
-        <p:txBody>
-          <a:bodyPr wrap="square">
-            <a:spAutoFit/>
-          </a:bodyPr>
-          <a:lstStyle/>
-          <a:p>
-            <a:pPr algn="l"/>
-            <a:r>
-              <a:rPr sz="1200" b="1" i="0">
-                <a:solidFill>
-                  <a:srgbClr val="005555"/>
-                </a:solidFill>
-              </a:rPr>
-              <a:t>Chaque soir, 5 minutes pour compléter ces 4 points :</a:t>
-            </a:r>
-          </a:p>
-        </p:txBody>
-      </p:sp>
-      <p:sp>
-        <p:nvSpPr>
-          <p:cNvPr id="12" name="Rectangle 11"/>
-          <p:cNvSpPr/>
-          <p:nvPr/>
-        </p:nvSpPr>
-        <p:spPr>
-          <a:xfrm>
-            <a:off x="274320" y="1207008"/>
-            <a:ext cx="530352" cy="896112"/>
-          </a:xfrm>
-          <a:prstGeom prst="rect">
-            <a:avLst/>
-          </a:prstGeom>
-          <a:solidFill>
-            <a:srgbClr val="008080"/>
-          </a:solidFill>
-          <a:ln>
-            <a:noFill/>
-          </a:ln>
-        </p:spPr>
-        <p:style>
-          <a:lnRef idx="1">
-            <a:schemeClr val="accent1"/>
-          </a:lnRef>
-          <a:fillRef idx="3">
-            <a:schemeClr val="accent1"/>
-          </a:fillRef>
-          <a:effectRef idx="2">
-            <a:schemeClr val="accent1"/>
-          </a:effectRef>
-          <a:fontRef idx="minor">
-            <a:schemeClr val="lt1"/>
-          </a:fontRef>
-        </p:style>
-        <p:txBody>
-          <a:bodyPr rtlCol="0" anchor="ctr"/>
-          <a:lstStyle/>
-          <a:p>
-            <a:pPr algn="ctr"/>
-          </a:p>
-        </p:txBody>
-      </p:sp>
-      <p:sp>
-        <p:nvSpPr>
-          <p:cNvPr id="13" name="TextBox 12"/>
-          <p:cNvSpPr txBox="1"/>
-          <p:nvPr/>
-        </p:nvSpPr>
-        <p:spPr>
-          <a:xfrm>
-            <a:off x="292608" y="1389888"/>
-            <a:ext cx="493776" cy="530352"/>
-          </a:xfrm>
-          <a:prstGeom prst="rect">
-            <a:avLst/>
-          </a:prstGeom>
-          <a:noFill/>
-        </p:spPr>
-        <p:txBody>
-          <a:bodyPr wrap="square">
-            <a:spAutoFit/>
-          </a:bodyPr>
-          <a:lstStyle/>
-          <a:p>
-            <a:pPr algn="ctr"/>
-            <a:r>
-              <a:rPr sz="2000" b="1" i="0">
-                <a:solidFill>
-                  <a:srgbClr val="FFFFFF"/>
-                </a:solidFill>
-              </a:rPr>
-              <a:t>①</a:t>
-            </a:r>
-          </a:p>
-        </p:txBody>
-      </p:sp>
-      <p:sp>
-        <p:nvSpPr>
-          <p:cNvPr id="14" name="Rectangle 13"/>
-          <p:cNvSpPr/>
-          <p:nvPr/>
-        </p:nvSpPr>
-        <p:spPr>
-          <a:xfrm>
-            <a:off x="822960" y="1207008"/>
-            <a:ext cx="11064240" cy="896112"/>
-          </a:xfrm>
-          <a:prstGeom prst="rect">
-            <a:avLst/>
-          </a:prstGeom>
-          <a:solidFill>
-            <a:srgbClr val="FFFFFF"/>
-          </a:solidFill>
-          <a:ln w="6350">
-            <a:solidFill>
-              <a:srgbClr val="008080"/>
-            </a:solidFill>
-          </a:ln>
-        </p:spPr>
-        <p:style>
-          <a:lnRef idx="1">
-            <a:schemeClr val="accent1"/>
-          </a:lnRef>
-          <a:fillRef idx="3">
-            <a:schemeClr val="accent1"/>
-          </a:fillRef>
-          <a:effectRef idx="2">
-            <a:schemeClr val="accent1"/>
-          </a:effectRef>
-          <a:fontRef idx="minor">
-            <a:schemeClr val="lt1"/>
-          </a:fontRef>
-        </p:style>
-        <p:txBody>
-          <a:bodyPr rtlCol="0" anchor="ctr"/>
-          <a:lstStyle/>
-          <a:p>
-            <a:pPr algn="ctr"/>
-          </a:p>
-        </p:txBody>
-      </p:sp>
-      <p:sp>
-        <p:nvSpPr>
-          <p:cNvPr id="15" name="TextBox 14"/>
-          <p:cNvSpPr txBox="1"/>
-          <p:nvPr/>
-        </p:nvSpPr>
-        <p:spPr>
-          <a:xfrm>
-            <a:off x="932688" y="1261872"/>
-            <a:ext cx="10881360" cy="274320"/>
-          </a:xfrm>
-          <a:prstGeom prst="rect">
-            <a:avLst/>
-          </a:prstGeom>
-          <a:noFill/>
-        </p:spPr>
-        <p:txBody>
-          <a:bodyPr wrap="square">
-            <a:spAutoFit/>
-          </a:bodyPr>
-          <a:lstStyle/>
-          <a:p>
-            <a:pPr algn="l"/>
-            <a:r>
-              <a:rPr sz="1100" b="1" i="0">
-                <a:solidFill>
-                  <a:srgbClr val="005555"/>
-                </a:solidFill>
-              </a:rPr>
-              <a:t>Ce que j'ai réussi aujourd'hui</a:t>
-            </a:r>
-          </a:p>
-        </p:txBody>
-      </p:sp>
-      <p:sp>
-        <p:nvSpPr>
-          <p:cNvPr id="16" name="TextBox 15"/>
-          <p:cNvSpPr txBox="1"/>
-          <p:nvPr/>
-        </p:nvSpPr>
-        <p:spPr>
-          <a:xfrm>
-            <a:off x="932688" y="1545336"/>
-            <a:ext cx="10881360" cy="493776"/>
-          </a:xfrm>
-          <a:prstGeom prst="rect">
-            <a:avLst/>
-          </a:prstGeom>
-          <a:noFill/>
-        </p:spPr>
-        <p:txBody>
-          <a:bodyPr wrap="square">
-            <a:spAutoFit/>
-          </a:bodyPr>
-          <a:lstStyle/>
-          <a:p>
-            <a:pPr algn="l"/>
-            <a:r>
-              <a:rPr sz="1000" b="0" i="1">
-                <a:solidFill>
-                  <a:srgbClr val="1A1A1A"/>
-                </a:solidFill>
-              </a:rPr>
-              <a:t>Notez 1 ou 2 moments où vous avez senti la progression.
-Ex : 'J'ai appliqué les 5 règles d'accroche sans hésitation.'</a:t>
-            </a:r>
-          </a:p>
-        </p:txBody>
-      </p:sp>
-      <p:sp>
-        <p:nvSpPr>
-          <p:cNvPr id="17" name="Rectangle 16"/>
-          <p:cNvSpPr/>
-          <p:nvPr/>
-        </p:nvSpPr>
-        <p:spPr>
-          <a:xfrm>
-            <a:off x="274320" y="2139696"/>
-            <a:ext cx="530352" cy="896112"/>
-          </a:xfrm>
-          <a:prstGeom prst="rect">
-            <a:avLst/>
-          </a:prstGeom>
-          <a:solidFill>
-            <a:srgbClr val="008080"/>
-          </a:solidFill>
-          <a:ln>
-            <a:noFill/>
-          </a:ln>
-        </p:spPr>
-        <p:style>
-          <a:lnRef idx="1">
-            <a:schemeClr val="accent1"/>
-          </a:lnRef>
-          <a:fillRef idx="3">
-            <a:schemeClr val="accent1"/>
-          </a:fillRef>
-          <a:effectRef idx="2">
-            <a:schemeClr val="accent1"/>
-          </a:effectRef>
-          <a:fontRef idx="minor">
-            <a:schemeClr val="lt1"/>
-          </a:fontRef>
-        </p:style>
-        <p:txBody>
-          <a:bodyPr rtlCol="0" anchor="ctr"/>
-          <a:lstStyle/>
-          <a:p>
-            <a:pPr algn="ctr"/>
-          </a:p>
-        </p:txBody>
-      </p:sp>
-      <p:sp>
-        <p:nvSpPr>
-          <p:cNvPr id="18" name="TextBox 17"/>
-          <p:cNvSpPr txBox="1"/>
-          <p:nvPr/>
-        </p:nvSpPr>
-        <p:spPr>
-          <a:xfrm>
-            <a:off x="292608" y="2322576"/>
-            <a:ext cx="493776" cy="530352"/>
-          </a:xfrm>
-          <a:prstGeom prst="rect">
-            <a:avLst/>
-          </a:prstGeom>
-          <a:noFill/>
-        </p:spPr>
-        <p:txBody>
-          <a:bodyPr wrap="square">
-            <a:spAutoFit/>
-          </a:bodyPr>
-          <a:lstStyle/>
-          <a:p>
-            <a:pPr algn="ctr"/>
-            <a:r>
-              <a:rPr sz="2000" b="1" i="0">
-                <a:solidFill>
-                  <a:srgbClr val="FFFFFF"/>
-                </a:solidFill>
-              </a:rPr>
-              <a:t>②</a:t>
-            </a:r>
-          </a:p>
-        </p:txBody>
-      </p:sp>
-      <p:sp>
-        <p:nvSpPr>
-          <p:cNvPr id="19" name="Rectangle 18"/>
-          <p:cNvSpPr/>
-          <p:nvPr/>
-        </p:nvSpPr>
-        <p:spPr>
-          <a:xfrm>
-            <a:off x="822960" y="2139696"/>
-            <a:ext cx="11064240" cy="896112"/>
-          </a:xfrm>
-          <a:prstGeom prst="rect">
-            <a:avLst/>
-          </a:prstGeom>
-          <a:solidFill>
-            <a:srgbClr val="FFFFFF"/>
-          </a:solidFill>
-          <a:ln w="6350">
-            <a:solidFill>
-              <a:srgbClr val="008080"/>
-            </a:solidFill>
-          </a:ln>
-        </p:spPr>
-        <p:style>
-          <a:lnRef idx="1">
-            <a:schemeClr val="accent1"/>
-          </a:lnRef>
-          <a:fillRef idx="3">
-            <a:schemeClr val="accent1"/>
-          </a:fillRef>
-          <a:effectRef idx="2">
-            <a:schemeClr val="accent1"/>
-          </a:effectRef>
-          <a:fontRef idx="minor">
-            <a:schemeClr val="lt1"/>
-          </a:fontRef>
-        </p:style>
-        <p:txBody>
-          <a:bodyPr rtlCol="0" anchor="ctr"/>
-          <a:lstStyle/>
-          <a:p>
-            <a:pPr algn="ctr"/>
-          </a:p>
-        </p:txBody>
-      </p:sp>
-      <p:sp>
-        <p:nvSpPr>
-          <p:cNvPr id="20" name="TextBox 19"/>
-          <p:cNvSpPr txBox="1"/>
-          <p:nvPr/>
-        </p:nvSpPr>
-        <p:spPr>
-          <a:xfrm>
-            <a:off x="932688" y="2194560"/>
-            <a:ext cx="10881360" cy="274320"/>
-          </a:xfrm>
-          <a:prstGeom prst="rect">
-            <a:avLst/>
-          </a:prstGeom>
-          <a:noFill/>
-        </p:spPr>
-        <p:txBody>
-          <a:bodyPr wrap="square">
-            <a:spAutoFit/>
-          </a:bodyPr>
-          <a:lstStyle/>
-          <a:p>
-            <a:pPr algn="l"/>
-            <a:r>
-              <a:rPr sz="1100" b="1" i="0">
-                <a:solidFill>
-                  <a:srgbClr val="005555"/>
-                </a:solidFill>
-              </a:rPr>
-              <a:t>Ce qui m'a challengé</a:t>
-            </a:r>
-          </a:p>
-        </p:txBody>
-      </p:sp>
-      <p:sp>
-        <p:nvSpPr>
-          <p:cNvPr id="21" name="TextBox 20"/>
-          <p:cNvSpPr txBox="1"/>
-          <p:nvPr/>
-        </p:nvSpPr>
-        <p:spPr>
-          <a:xfrm>
-            <a:off x="932688" y="2478024"/>
-            <a:ext cx="10881360" cy="493776"/>
-          </a:xfrm>
-          <a:prstGeom prst="rect">
-            <a:avLst/>
-          </a:prstGeom>
-          <a:noFill/>
-        </p:spPr>
-        <p:txBody>
-          <a:bodyPr wrap="square">
-            <a:spAutoFit/>
-          </a:bodyPr>
-          <a:lstStyle/>
-          <a:p>
-            <a:pPr algn="l"/>
-            <a:r>
-              <a:rPr sz="1000" b="0" i="1">
-                <a:solidFill>
-                  <a:srgbClr val="1A1A1A"/>
-                </a:solidFill>
-              </a:rPr>
-              <a:t>Une situation difficile et pourquoi elle vous a bloqué.
-Ex : 'Quand le prospect a dit "arnaque", j'ai manqué la reformulation.'</a:t>
-            </a:r>
-          </a:p>
-        </p:txBody>
-      </p:sp>
-      <p:sp>
-        <p:nvSpPr>
-          <p:cNvPr id="22" name="Rectangle 21"/>
-          <p:cNvSpPr/>
-          <p:nvPr/>
-        </p:nvSpPr>
-        <p:spPr>
-          <a:xfrm>
-            <a:off x="274320" y="3072384"/>
-            <a:ext cx="530352" cy="896112"/>
-          </a:xfrm>
-          <a:prstGeom prst="rect">
-            <a:avLst/>
-          </a:prstGeom>
-          <a:solidFill>
-            <a:srgbClr val="008080"/>
-          </a:solidFill>
-          <a:ln>
-            <a:noFill/>
-          </a:ln>
-        </p:spPr>
-        <p:style>
-          <a:lnRef idx="1">
-            <a:schemeClr val="accent1"/>
-          </a:lnRef>
-          <a:fillRef idx="3">
-            <a:schemeClr val="accent1"/>
-          </a:fillRef>
-          <a:effectRef idx="2">
-            <a:schemeClr val="accent1"/>
-          </a:effectRef>
-          <a:fontRef idx="minor">
-            <a:schemeClr val="lt1"/>
-          </a:fontRef>
-        </p:style>
-        <p:txBody>
-          <a:bodyPr rtlCol="0" anchor="ctr"/>
-          <a:lstStyle/>
-          <a:p>
-            <a:pPr algn="ctr"/>
-          </a:p>
-        </p:txBody>
-      </p:sp>
-      <p:sp>
-        <p:nvSpPr>
-          <p:cNvPr id="23" name="TextBox 22"/>
-          <p:cNvSpPr txBox="1"/>
-          <p:nvPr/>
-        </p:nvSpPr>
-        <p:spPr>
-          <a:xfrm>
-            <a:off x="292608" y="3255264"/>
-            <a:ext cx="493776" cy="530352"/>
-          </a:xfrm>
-          <a:prstGeom prst="rect">
-            <a:avLst/>
-          </a:prstGeom>
-          <a:noFill/>
-        </p:spPr>
-        <p:txBody>
-          <a:bodyPr wrap="square">
-            <a:spAutoFit/>
-          </a:bodyPr>
-          <a:lstStyle/>
-          <a:p>
-            <a:pPr algn="ctr"/>
-            <a:r>
-              <a:rPr sz="2000" b="1" i="0">
-                <a:solidFill>
-                  <a:srgbClr val="FFFFFF"/>
-                </a:solidFill>
-              </a:rPr>
-              <a:t>③</a:t>
-            </a:r>
-          </a:p>
-        </p:txBody>
-      </p:sp>
-      <p:sp>
-        <p:nvSpPr>
-          <p:cNvPr id="24" name="Rectangle 23"/>
-          <p:cNvSpPr/>
-          <p:nvPr/>
-        </p:nvSpPr>
-        <p:spPr>
-          <a:xfrm>
-            <a:off x="822960" y="3072384"/>
-            <a:ext cx="11064240" cy="896112"/>
-          </a:xfrm>
-          <a:prstGeom prst="rect">
-            <a:avLst/>
-          </a:prstGeom>
-          <a:solidFill>
-            <a:srgbClr val="FFFFFF"/>
-          </a:solidFill>
-          <a:ln w="6350">
-            <a:solidFill>
-              <a:srgbClr val="008080"/>
-            </a:solidFill>
-          </a:ln>
-        </p:spPr>
-        <p:style>
-          <a:lnRef idx="1">
-            <a:schemeClr val="accent1"/>
-          </a:lnRef>
-          <a:fillRef idx="3">
-            <a:schemeClr val="accent1"/>
-          </a:fillRef>
-          <a:effectRef idx="2">
-            <a:schemeClr val="accent1"/>
-          </a:effectRef>
-          <a:fontRef idx="minor">
-            <a:schemeClr val="lt1"/>
-          </a:fontRef>
-        </p:style>
-        <p:txBody>
-          <a:bodyPr rtlCol="0" anchor="ctr"/>
-          <a:lstStyle/>
-          <a:p>
-            <a:pPr algn="ctr"/>
-          </a:p>
-        </p:txBody>
-      </p:sp>
-      <p:sp>
-        <p:nvSpPr>
-          <p:cNvPr id="25" name="TextBox 24"/>
-          <p:cNvSpPr txBox="1"/>
-          <p:nvPr/>
-        </p:nvSpPr>
-        <p:spPr>
-          <a:xfrm>
-            <a:off x="932688" y="3127248"/>
-            <a:ext cx="10881360" cy="274320"/>
-          </a:xfrm>
-          <a:prstGeom prst="rect">
-            <a:avLst/>
-          </a:prstGeom>
-          <a:noFill/>
-        </p:spPr>
-        <p:txBody>
-          <a:bodyPr wrap="square">
-            <a:spAutoFit/>
-          </a:bodyPr>
-          <a:lstStyle/>
-          <a:p>
-            <a:pPr algn="l"/>
-            <a:r>
-              <a:rPr sz="1100" b="1" i="0">
-                <a:solidFill>
-                  <a:srgbClr val="005555"/>
-                </a:solidFill>
-              </a:rPr>
-              <a:t>Mon insight du jour</a:t>
-            </a:r>
-          </a:p>
-        </p:txBody>
-      </p:sp>
-      <p:sp>
-        <p:nvSpPr>
-          <p:cNvPr id="26" name="TextBox 25"/>
-          <p:cNvSpPr txBox="1"/>
-          <p:nvPr/>
-        </p:nvSpPr>
-        <p:spPr>
-          <a:xfrm>
-            <a:off x="932688" y="3410712"/>
-            <a:ext cx="10881360" cy="493776"/>
-          </a:xfrm>
-          <a:prstGeom prst="rect">
-            <a:avLst/>
-          </a:prstGeom>
-          <a:noFill/>
-        </p:spPr>
-        <p:txBody>
-          <a:bodyPr wrap="square">
-            <a:spAutoFit/>
-          </a:bodyPr>
-          <a:lstStyle/>
-          <a:p>
-            <a:pPr algn="l"/>
-            <a:r>
-              <a:rPr sz="1000" b="0" i="1">
-                <a:solidFill>
-                  <a:srgbClr val="1A1A1A"/>
-                </a:solidFill>
-              </a:rPr>
-              <a:t>L'apprentissage que vous n'auriez pas pu anticiper ce matin.
-Ex : 'La pause après la proposition vaut mieux qu'une relance immédiate.'</a:t>
-            </a:r>
-          </a:p>
-        </p:txBody>
-      </p:sp>
-      <p:sp>
-        <p:nvSpPr>
-          <p:cNvPr id="27" name="Rectangle 26"/>
-          <p:cNvSpPr/>
-          <p:nvPr/>
-        </p:nvSpPr>
-        <p:spPr>
-          <a:xfrm>
-            <a:off x="274320" y="4005072"/>
-            <a:ext cx="530352" cy="896112"/>
-          </a:xfrm>
-          <a:prstGeom prst="rect">
-            <a:avLst/>
-          </a:prstGeom>
-          <a:solidFill>
-            <a:srgbClr val="008080"/>
-          </a:solidFill>
-          <a:ln>
-            <a:noFill/>
-          </a:ln>
-        </p:spPr>
-        <p:style>
-          <a:lnRef idx="1">
-            <a:schemeClr val="accent1"/>
-          </a:lnRef>
-          <a:fillRef idx="3">
-            <a:schemeClr val="accent1"/>
-          </a:fillRef>
-          <a:effectRef idx="2">
-            <a:schemeClr val="accent1"/>
-          </a:effectRef>
-          <a:fontRef idx="minor">
-            <a:schemeClr val="lt1"/>
-          </a:fontRef>
-        </p:style>
-        <p:txBody>
-          <a:bodyPr rtlCol="0" anchor="ctr"/>
-          <a:lstStyle/>
-          <a:p>
-            <a:pPr algn="ctr"/>
-          </a:p>
-        </p:txBody>
-      </p:sp>
-      <p:sp>
-        <p:nvSpPr>
-          <p:cNvPr id="28" name="TextBox 27"/>
-          <p:cNvSpPr txBox="1"/>
-          <p:nvPr/>
-        </p:nvSpPr>
-        <p:spPr>
-          <a:xfrm>
-            <a:off x="292608" y="4187952"/>
-            <a:ext cx="493776" cy="530352"/>
-          </a:xfrm>
-          <a:prstGeom prst="rect">
-            <a:avLst/>
-          </a:prstGeom>
-          <a:noFill/>
-        </p:spPr>
-        <p:txBody>
-          <a:bodyPr wrap="square">
-            <a:spAutoFit/>
-          </a:bodyPr>
-          <a:lstStyle/>
-          <a:p>
-            <a:pPr algn="ctr"/>
-            <a:r>
-              <a:rPr sz="2000" b="1" i="0">
-                <a:solidFill>
-                  <a:srgbClr val="FFFFFF"/>
-                </a:solidFill>
-              </a:rPr>
-              <a:t>④</a:t>
-            </a:r>
-          </a:p>
-        </p:txBody>
-      </p:sp>
-      <p:sp>
-        <p:nvSpPr>
-          <p:cNvPr id="29" name="Rectangle 28"/>
-          <p:cNvSpPr/>
-          <p:nvPr/>
-        </p:nvSpPr>
-        <p:spPr>
-          <a:xfrm>
-            <a:off x="822960" y="4005072"/>
-            <a:ext cx="11064240" cy="896112"/>
-          </a:xfrm>
-          <a:prstGeom prst="rect">
-            <a:avLst/>
-          </a:prstGeom>
-          <a:solidFill>
-            <a:srgbClr val="FFFFFF"/>
-          </a:solidFill>
-          <a:ln w="6350">
-            <a:solidFill>
-              <a:srgbClr val="008080"/>
-            </a:solidFill>
-          </a:ln>
-        </p:spPr>
-        <p:style>
-          <a:lnRef idx="1">
-            <a:schemeClr val="accent1"/>
-          </a:lnRef>
-          <a:fillRef idx="3">
-            <a:schemeClr val="accent1"/>
-          </a:fillRef>
-          <a:effectRef idx="2">
-            <a:schemeClr val="accent1"/>
-          </a:effectRef>
-          <a:fontRef idx="minor">
-            <a:schemeClr val="lt1"/>
-          </a:fontRef>
-        </p:style>
-        <p:txBody>
-          <a:bodyPr rtlCol="0" anchor="ctr"/>
-          <a:lstStyle/>
-          <a:p>
-            <a:pPr algn="ctr"/>
-          </a:p>
-        </p:txBody>
-      </p:sp>
-      <p:sp>
-        <p:nvSpPr>
-          <p:cNvPr id="30" name="TextBox 29"/>
-          <p:cNvSpPr txBox="1"/>
-          <p:nvPr/>
-        </p:nvSpPr>
-        <p:spPr>
-          <a:xfrm>
-            <a:off x="932688" y="4059935"/>
-            <a:ext cx="10881360" cy="274320"/>
-          </a:xfrm>
-          <a:prstGeom prst="rect">
-            <a:avLst/>
-          </a:prstGeom>
-          <a:noFill/>
-        </p:spPr>
-        <p:txBody>
-          <a:bodyPr wrap="square">
-            <a:spAutoFit/>
-          </a:bodyPr>
-          <a:lstStyle/>
-          <a:p>
-            <a:pPr algn="l"/>
-            <a:r>
-              <a:rPr sz="1100" b="1" i="0">
-                <a:solidFill>
-                  <a:srgbClr val="005555"/>
-                </a:solidFill>
-              </a:rPr>
-              <a:t>Mon engagement pour demain</a:t>
-            </a:r>
-          </a:p>
-        </p:txBody>
-      </p:sp>
-      <p:sp>
-        <p:nvSpPr>
-          <p:cNvPr id="31" name="TextBox 30"/>
-          <p:cNvSpPr txBox="1"/>
-          <p:nvPr/>
-        </p:nvSpPr>
-        <p:spPr>
-          <a:xfrm>
-            <a:off x="932688" y="4343400"/>
-            <a:ext cx="10881360" cy="493776"/>
-          </a:xfrm>
-          <a:prstGeom prst="rect">
-            <a:avLst/>
-          </a:prstGeom>
-          <a:noFill/>
-        </p:spPr>
-        <p:txBody>
-          <a:bodyPr wrap="square">
-            <a:spAutoFit/>
-          </a:bodyPr>
-          <a:lstStyle/>
-          <a:p>
-            <a:pPr algn="l"/>
-            <a:r>
-              <a:rPr sz="1000" b="0" i="1">
-                <a:solidFill>
-                  <a:srgbClr val="1A1A1A"/>
-                </a:solidFill>
-              </a:rPr>
-              <a:t>1 comportement précis à changer ou renforcer dès demain.
-Ex : 'Je vais sourire à voix haute dès le mot "Bonjour".'</a:t>
-            </a:r>
-          </a:p>
-        </p:txBody>
-      </p:sp>
-      <p:sp>
-        <p:nvSpPr>
-          <p:cNvPr id="32" name="Rectangle 31"/>
-          <p:cNvSpPr/>
-          <p:nvPr/>
-        </p:nvSpPr>
-        <p:spPr>
-          <a:xfrm>
-            <a:off x="274320" y="4956048"/>
-            <a:ext cx="11640312" cy="347472"/>
-          </a:xfrm>
-          <a:prstGeom prst="rect">
-            <a:avLst/>
-          </a:prstGeom>
-          <a:solidFill>
-            <a:srgbClr val="008080"/>
-          </a:solidFill>
-          <a:ln>
-            <a:noFill/>
-          </a:ln>
-        </p:spPr>
-        <p:style>
-          <a:lnRef idx="1">
-            <a:schemeClr val="accent1"/>
-          </a:lnRef>
-          <a:fillRef idx="3">
-            <a:schemeClr val="accent1"/>
-          </a:fillRef>
-          <a:effectRef idx="2">
-            <a:schemeClr val="accent1"/>
-          </a:effectRef>
-          <a:fontRef idx="minor">
-            <a:schemeClr val="lt1"/>
-          </a:fontRef>
-        </p:style>
-        <p:txBody>
-          <a:bodyPr rtlCol="0" anchor="ctr"/>
-          <a:lstStyle/>
-          <a:p>
-            <a:pPr algn="ctr"/>
-          </a:p>
-        </p:txBody>
-      </p:sp>
-      <p:sp>
-        <p:nvSpPr>
-          <p:cNvPr id="33" name="TextBox 32"/>
-          <p:cNvSpPr txBox="1"/>
-          <p:nvPr/>
-        </p:nvSpPr>
-        <p:spPr>
-          <a:xfrm>
-            <a:off x="411479" y="5029200"/>
-            <a:ext cx="11365992" cy="201168"/>
-          </a:xfrm>
-          <a:prstGeom prst="rect">
-            <a:avLst/>
-          </a:prstGeom>
-          <a:noFill/>
-        </p:spPr>
-        <p:txBody>
-          <a:bodyPr wrap="square">
-            <a:spAutoFit/>
-          </a:bodyPr>
-          <a:lstStyle/>
-          <a:p>
-            <a:pPr algn="l"/>
-            <a:r>
-              <a:rPr sz="1000" b="0" i="0">
-                <a:solidFill>
-                  <a:srgbClr val="FFFFFF"/>
-                </a:solidFill>
-              </a:rPr>
-              <a:t>Votre livret reste strictement personnel — il ne sera pas noté. C'est votre outil de progression.</a:t>
+              <a:t>SHY-Performance  ×  FIDELIS  ×  UNICEF France</a:t>
             </a:r>
           </a:p>
         </p:txBody>

</xml_diff>